<commit_message>
Add Binder xeus-octave environment
</commit_message>
<xml_diff>
--- a/lectures_strang_en/LEC06/slides/Lecture_06_Strang_EN.pptx
+++ b/lectures_strang_en/LEC06/slides/Lecture_06_Strang_EN.pptx
@@ -5,21 +5,22 @@
     <p:sldMasterId id="2147483660" r:id="rId1"/>
   </p:sldMasterIdLst>
   <p:notesMasterIdLst>
-    <p:notesMasterId r:id="rId9"/>
+    <p:notesMasterId r:id="rId10"/>
   </p:notesMasterIdLst>
   <p:handoutMasterIdLst>
-    <p:handoutMasterId r:id="rId10"/>
+    <p:handoutMasterId r:id="rId11"/>
   </p:handoutMasterIdLst>
   <p:sldIdLst>
     <p:sldId id="314" r:id="rId2"/>
-    <p:sldId id="305" r:id="rId3"/>
-    <p:sldId id="310" r:id="rId4"/>
-    <p:sldId id="311" r:id="rId5"/>
-    <p:sldId id="312" r:id="rId6"/>
-    <p:sldId id="313" r:id="rId7"/>
-    <p:sldId id="315" r:id="rId8"/>
+    <p:sldId id="316" r:id="rId3"/>
+    <p:sldId id="305" r:id="rId4"/>
+    <p:sldId id="310" r:id="rId5"/>
+    <p:sldId id="311" r:id="rId6"/>
+    <p:sldId id="312" r:id="rId7"/>
+    <p:sldId id="313" r:id="rId8"/>
+    <p:sldId id="315" r:id="rId9"/>
   </p:sldIdLst>
-  <p:sldSz cx="9144000" cy="6858000" type="screen4x3"/>
+  <p:sldSz cx="12192000" cy="6858000"/>
   <p:notesSz cx="6858000" cy="9144000"/>
   <p:defaultTextStyle>
     <a:defPPr>
@@ -119,12 +120,12 @@
   <p:extLst>
     <p:ext uri="{EFAFB233-063F-42B5-8137-9DF3F51BA10A}">
       <p15:sldGuideLst xmlns:p15="http://schemas.microsoft.com/office/powerpoint/2012/main">
-        <p15:guide id="1" orient="horz" pos="2160">
+        <p15:guide id="1" orient="horz" pos="2160" userDrawn="1">
           <p15:clr>
             <a:srgbClr val="A4A3A4"/>
           </p15:clr>
         </p15:guide>
-        <p15:guide id="2" pos="2880">
+        <p15:guide id="2" pos="3840" userDrawn="1">
           <p15:clr>
             <a:srgbClr val="A4A3A4"/>
           </p15:clr>
@@ -235,7 +236,7 @@
           <a:p>
             <a:fld id="{C7B76BB3-96B4-D949-BA97-2F034CC20E35}" type="datetimeFigureOut">
               <a:rPr lang="es-ES_tradnl" smtClean="0"/>
-              <a:t>26/4/20</a:t>
+              <a:t>20/3/26</a:t>
             </a:fld>
             <a:endParaRPr lang="es-ES_tradnl"/>
           </a:p>
@@ -408,7 +409,7 @@
           <a:p>
             <a:fld id="{BC3897DA-3038-2943-8BC6-34E6C6DE6379}" type="datetimeFigureOut">
               <a:rPr lang="es-ES_tradnl" smtClean="0"/>
-              <a:t>26/4/20</a:t>
+              <a:t>20/3/26</a:t>
             </a:fld>
             <a:endParaRPr lang="es-ES_tradnl"/>
           </a:p>
@@ -426,8 +427,8 @@
         </p:nvSpPr>
         <p:spPr>
           <a:xfrm>
-            <a:off x="1371600" y="1143000"/>
-            <a:ext cx="4114800" cy="3086100"/>
+            <a:off x="685800" y="1143000"/>
+            <a:ext cx="5486400" cy="3086100"/>
           </a:xfrm>
           <a:prstGeom prst="rect">
             <a:avLst/>
@@ -706,7 +707,7 @@
         <p:spPr>
           <a:xfrm>
             <a:off x="0" y="0"/>
-            <a:ext cx="9144000" cy="6858000"/>
+            <a:ext cx="12192000" cy="6858000"/>
           </a:xfrm>
           <a:prstGeom prst="rect">
             <a:avLst/>
@@ -738,7 +739,7 @@
           <a:lstStyle/>
           <a:p>
             <a:pPr algn="ctr" eaLnBrk="1" latinLnBrk="0" hangingPunct="1"/>
-            <a:endParaRPr kumimoji="0" lang="en-US"/>
+            <a:endParaRPr kumimoji="0" lang="en-US" sz="1800"/>
           </a:p>
         </p:txBody>
       </p:sp>
@@ -750,8 +751,8 @@
         </p:nvSpPr>
         <p:spPr>
           <a:xfrm>
-            <a:off x="65313" y="69755"/>
-            <a:ext cx="9013372" cy="6692201"/>
+            <a:off x="87084" y="69755"/>
+            <a:ext cx="12017829" cy="6692201"/>
           </a:xfrm>
           <a:prstGeom prst="roundRect">
             <a:avLst>
@@ -787,7 +788,7 @@
           <a:lstStyle/>
           <a:p>
             <a:pPr algn="ctr" eaLnBrk="1" latinLnBrk="0" hangingPunct="1"/>
-            <a:endParaRPr kumimoji="0" lang="en-US"/>
+            <a:endParaRPr kumimoji="0" lang="en-US" sz="1800"/>
           </a:p>
         </p:txBody>
       </p:sp>
@@ -803,8 +804,8 @@
         </p:nvSpPr>
         <p:spPr>
           <a:xfrm>
-            <a:off x="1295400" y="3200400"/>
-            <a:ext cx="6400800" cy="1600200"/>
+            <a:off x="1727200" y="3200400"/>
+            <a:ext cx="8534400" cy="1600200"/>
           </a:xfrm>
         </p:spPr>
         <p:txBody>
@@ -870,7 +871,7 @@
             <a:fld id="{75EEBB46-7A81-4557-A313-00D814F92FCC}" type="datetimeFigureOut">
               <a:rPr lang="es-ES" smtClean="0"/>
               <a:pPr/>
-              <a:t>26/4/20</a:t>
+              <a:t>20/3/26</a:t>
             </a:fld>
             <a:endParaRPr lang="es-ES"/>
           </a:p>
@@ -945,8 +946,8 @@
         </p:nvSpPr>
         <p:spPr>
           <a:xfrm>
-            <a:off x="62931" y="1449303"/>
-            <a:ext cx="9021537" cy="1527349"/>
+            <a:off x="83909" y="1449304"/>
+            <a:ext cx="12028716" cy="1527349"/>
           </a:xfrm>
           <a:prstGeom prst="rect">
             <a:avLst/>
@@ -981,7 +982,7 @@
           <a:lstStyle/>
           <a:p>
             <a:pPr algn="ctr" eaLnBrk="1" latinLnBrk="0" hangingPunct="1"/>
-            <a:endParaRPr kumimoji="0" lang="en-US"/>
+            <a:endParaRPr kumimoji="0" lang="en-US" sz="1800"/>
           </a:p>
         </p:txBody>
       </p:sp>
@@ -993,8 +994,8 @@
         </p:nvSpPr>
         <p:spPr>
           <a:xfrm>
-            <a:off x="62931" y="1396720"/>
-            <a:ext cx="9021537" cy="120580"/>
+            <a:off x="83909" y="1396720"/>
+            <a:ext cx="12028716" cy="120580"/>
           </a:xfrm>
           <a:prstGeom prst="rect">
             <a:avLst/>
@@ -1029,7 +1030,7 @@
           <a:lstStyle/>
           <a:p>
             <a:pPr algn="ctr" eaLnBrk="1" latinLnBrk="0" hangingPunct="1"/>
-            <a:endParaRPr kumimoji="0" lang="en-US"/>
+            <a:endParaRPr kumimoji="0" lang="en-US" sz="1800"/>
           </a:p>
         </p:txBody>
       </p:sp>
@@ -1041,8 +1042,8 @@
         </p:nvSpPr>
         <p:spPr>
           <a:xfrm>
-            <a:off x="62931" y="2976649"/>
-            <a:ext cx="9021537" cy="110532"/>
+            <a:off x="83909" y="2976649"/>
+            <a:ext cx="12028716" cy="110532"/>
           </a:xfrm>
           <a:prstGeom prst="rect">
             <a:avLst/>
@@ -1075,7 +1076,7 @@
           <a:lstStyle/>
           <a:p>
             <a:pPr algn="ctr" eaLnBrk="1" latinLnBrk="0" hangingPunct="1"/>
-            <a:endParaRPr kumimoji="0" lang="en-US"/>
+            <a:endParaRPr kumimoji="0" lang="en-US" sz="1800"/>
           </a:p>
         </p:txBody>
       </p:sp>
@@ -1091,8 +1092,8 @@
         </p:nvSpPr>
         <p:spPr>
           <a:xfrm>
-            <a:off x="457200" y="1505930"/>
-            <a:ext cx="8229600" cy="1470025"/>
+            <a:off x="609600" y="1505931"/>
+            <a:ext cx="10972800" cy="1470025"/>
           </a:xfrm>
         </p:spPr>
         <p:txBody>
@@ -1233,7 +1234,7 @@
             <a:fld id="{75EEBB46-7A81-4557-A313-00D814F92FCC}" type="datetimeFigureOut">
               <a:rPr lang="es-ES" smtClean="0"/>
               <a:pPr/>
-              <a:t>26/4/20</a:t>
+              <a:t>20/3/26</a:t>
             </a:fld>
             <a:endParaRPr lang="es-ES"/>
           </a:p>
@@ -1327,8 +1328,8 @@
         </p:nvSpPr>
         <p:spPr>
           <a:xfrm>
-            <a:off x="6629400" y="274641"/>
-            <a:ext cx="2011680" cy="5851525"/>
+            <a:off x="8839200" y="274642"/>
+            <a:ext cx="2682240" cy="5851525"/>
           </a:xfrm>
         </p:spPr>
         <p:txBody>
@@ -1355,8 +1356,8 @@
         </p:nvSpPr>
         <p:spPr>
           <a:xfrm>
-            <a:off x="914400" y="274640"/>
-            <a:ext cx="5562600" cy="5851525"/>
+            <a:off x="1219200" y="274640"/>
+            <a:ext cx="7416800" cy="5851525"/>
           </a:xfrm>
         </p:spPr>
         <p:txBody>
@@ -1418,7 +1419,7 @@
             <a:fld id="{75EEBB46-7A81-4557-A313-00D814F92FCC}" type="datetimeFigureOut">
               <a:rPr lang="es-ES" smtClean="0"/>
               <a:pPr/>
-              <a:t>26/4/20</a:t>
+              <a:t>20/3/26</a:t>
             </a:fld>
             <a:endParaRPr lang="es-ES"/>
           </a:p>
@@ -1541,7 +1542,7 @@
             <a:fld id="{75EEBB46-7A81-4557-A313-00D814F92FCC}" type="datetimeFigureOut">
               <a:rPr lang="es-ES" smtClean="0"/>
               <a:pPr/>
-              <a:t>26/4/20</a:t>
+              <a:t>20/3/26</a:t>
             </a:fld>
             <a:endParaRPr lang="es-ES"/>
           </a:p>
@@ -1610,8 +1611,8 @@
         </p:nvSpPr>
         <p:spPr>
           <a:xfrm>
-            <a:off x="914400" y="1447800"/>
-            <a:ext cx="7772400" cy="4572000"/>
+            <a:off x="1219200" y="1447800"/>
+            <a:ext cx="10363200" cy="4572000"/>
           </a:xfrm>
         </p:spPr>
         <p:txBody>
@@ -1694,7 +1695,7 @@
         <p:spPr>
           <a:xfrm>
             <a:off x="0" y="0"/>
-            <a:ext cx="9144000" cy="6858000"/>
+            <a:ext cx="12192000" cy="6858000"/>
           </a:xfrm>
           <a:prstGeom prst="rect">
             <a:avLst/>
@@ -1726,7 +1727,7 @@
           <a:lstStyle/>
           <a:p>
             <a:pPr algn="ctr" eaLnBrk="1" latinLnBrk="0" hangingPunct="1"/>
-            <a:endParaRPr kumimoji="0" lang="en-US"/>
+            <a:endParaRPr kumimoji="0" lang="en-US" sz="1800"/>
           </a:p>
         </p:txBody>
       </p:sp>
@@ -1738,8 +1739,8 @@
         </p:nvSpPr>
         <p:spPr>
           <a:xfrm>
-            <a:off x="65313" y="69755"/>
-            <a:ext cx="9013372" cy="6692201"/>
+            <a:off x="87084" y="69755"/>
+            <a:ext cx="12017829" cy="6692201"/>
           </a:xfrm>
           <a:prstGeom prst="roundRect">
             <a:avLst>
@@ -1775,7 +1776,7 @@
           <a:lstStyle/>
           <a:p>
             <a:pPr algn="ctr" eaLnBrk="1" latinLnBrk="0" hangingPunct="1"/>
-            <a:endParaRPr kumimoji="0" lang="en-US"/>
+            <a:endParaRPr kumimoji="0" lang="en-US" sz="1800"/>
           </a:p>
         </p:txBody>
       </p:sp>
@@ -1791,8 +1792,8 @@
         </p:nvSpPr>
         <p:spPr>
           <a:xfrm>
-            <a:off x="722313" y="952500"/>
-            <a:ext cx="7772400" cy="1362075"/>
+            <a:off x="963084" y="952501"/>
+            <a:ext cx="10363200" cy="1362075"/>
           </a:xfrm>
         </p:spPr>
         <p:txBody>
@@ -1824,8 +1825,8 @@
         </p:nvSpPr>
         <p:spPr>
           <a:xfrm>
-            <a:off x="722313" y="2547938"/>
-            <a:ext cx="7772400" cy="1338262"/>
+            <a:off x="963084" y="2547938"/>
+            <a:ext cx="10363200" cy="1338262"/>
           </a:xfrm>
         </p:spPr>
         <p:txBody>
@@ -1909,7 +1910,7 @@
             <a:fld id="{75EEBB46-7A81-4557-A313-00D814F92FCC}" type="datetimeFigureOut">
               <a:rPr lang="es-ES" smtClean="0"/>
               <a:pPr/>
-              <a:t>26/4/20</a:t>
+              <a:t>20/3/26</a:t>
             </a:fld>
             <a:endParaRPr lang="es-ES"/>
           </a:p>
@@ -1927,8 +1928,8 @@
         </p:nvSpPr>
         <p:spPr>
           <a:xfrm>
-            <a:off x="800100" y="6172200"/>
-            <a:ext cx="4000500" cy="457200"/>
+            <a:off x="1066800" y="6172200"/>
+            <a:ext cx="5334000" cy="457200"/>
           </a:xfrm>
         </p:spPr>
         <p:txBody>
@@ -1955,8 +1956,8 @@
         </p:nvSpPr>
         <p:spPr>
           <a:xfrm flipV="1">
-            <a:off x="69412" y="2376830"/>
-            <a:ext cx="9013515" cy="91440"/>
+            <a:off x="92550" y="2376830"/>
+            <a:ext cx="12018020" cy="91440"/>
           </a:xfrm>
           <a:prstGeom prst="rect">
             <a:avLst/>
@@ -1991,7 +1992,7 @@
           <a:lstStyle/>
           <a:p>
             <a:pPr algn="ctr" eaLnBrk="1" latinLnBrk="0" hangingPunct="1"/>
-            <a:endParaRPr kumimoji="0" lang="en-US"/>
+            <a:endParaRPr kumimoji="0" lang="en-US" sz="1800"/>
           </a:p>
         </p:txBody>
       </p:sp>
@@ -2003,8 +2004,8 @@
         </p:nvSpPr>
         <p:spPr>
           <a:xfrm>
-            <a:off x="69146" y="2341475"/>
-            <a:ext cx="9013781" cy="45719"/>
+            <a:off x="92195" y="2341476"/>
+            <a:ext cx="12018375" cy="45719"/>
           </a:xfrm>
           <a:prstGeom prst="rect">
             <a:avLst/>
@@ -2039,7 +2040,7 @@
           <a:lstStyle/>
           <a:p>
             <a:pPr algn="ctr" eaLnBrk="1" latinLnBrk="0" hangingPunct="1"/>
-            <a:endParaRPr kumimoji="0" lang="en-US"/>
+            <a:endParaRPr kumimoji="0" lang="en-US" sz="1800"/>
           </a:p>
         </p:txBody>
       </p:sp>
@@ -2051,8 +2052,8 @@
         </p:nvSpPr>
         <p:spPr>
           <a:xfrm>
-            <a:off x="68306" y="2468880"/>
-            <a:ext cx="9014621" cy="45720"/>
+            <a:off x="91075" y="2468880"/>
+            <a:ext cx="12019495" cy="45720"/>
           </a:xfrm>
           <a:prstGeom prst="rect">
             <a:avLst/>
@@ -2085,7 +2086,7 @@
           <a:lstStyle/>
           <a:p>
             <a:pPr algn="ctr" eaLnBrk="1" latinLnBrk="0" hangingPunct="1"/>
-            <a:endParaRPr kumimoji="0" lang="en-US"/>
+            <a:endParaRPr kumimoji="0" lang="en-US" sz="1800"/>
           </a:p>
         </p:txBody>
       </p:sp>
@@ -2101,8 +2102,8 @@
         </p:nvSpPr>
         <p:spPr>
           <a:xfrm>
-            <a:off x="146304" y="6208776"/>
-            <a:ext cx="457200" cy="457200"/>
+            <a:off x="195072" y="6208776"/>
+            <a:ext cx="609600" cy="457200"/>
           </a:xfrm>
         </p:spPr>
         <p:txBody>
@@ -2184,7 +2185,7 @@
             <a:fld id="{75EEBB46-7A81-4557-A313-00D814F92FCC}" type="datetimeFigureOut">
               <a:rPr lang="es-ES" smtClean="0"/>
               <a:pPr/>
-              <a:t>26/4/20</a:t>
+              <a:t>20/3/26</a:t>
             </a:fld>
             <a:endParaRPr lang="es-ES"/>
           </a:p>
@@ -2253,8 +2254,8 @@
         </p:nvSpPr>
         <p:spPr>
           <a:xfrm>
-            <a:off x="914400" y="1447800"/>
-            <a:ext cx="3749040" cy="4572000"/>
+            <a:off x="1219200" y="1447800"/>
+            <a:ext cx="4998720" cy="4572000"/>
           </a:xfrm>
         </p:spPr>
         <p:txBody>
@@ -2310,8 +2311,8 @@
         </p:nvSpPr>
         <p:spPr>
           <a:xfrm>
-            <a:off x="4933950" y="1447800"/>
-            <a:ext cx="3749040" cy="4572000"/>
+            <a:off x="6578600" y="1447800"/>
+            <a:ext cx="4998720" cy="4572000"/>
           </a:xfrm>
         </p:spPr>
         <p:txBody>
@@ -2392,8 +2393,8 @@
         </p:nvSpPr>
         <p:spPr>
           <a:xfrm>
-            <a:off x="914400" y="273050"/>
-            <a:ext cx="7772400" cy="1143000"/>
+            <a:off x="1219200" y="273050"/>
+            <a:ext cx="10363200" cy="1143000"/>
           </a:xfrm>
         </p:spPr>
         <p:txBody>
@@ -2424,8 +2425,8 @@
         </p:nvSpPr>
         <p:spPr>
           <a:xfrm>
-            <a:off x="914400" y="1447800"/>
-            <a:ext cx="3733800" cy="762000"/>
+            <a:off x="1219200" y="1447800"/>
+            <a:ext cx="4978400" cy="762000"/>
           </a:xfrm>
           <a:noFill/>
           <a:ln w="12700" cap="sq" cmpd="sng" algn="ctr">
@@ -2487,8 +2488,8 @@
         </p:nvSpPr>
         <p:spPr>
           <a:xfrm>
-            <a:off x="4953000" y="1447800"/>
-            <a:ext cx="3733800" cy="762000"/>
+            <a:off x="6604000" y="1447800"/>
+            <a:ext cx="4978400" cy="762000"/>
           </a:xfrm>
           <a:noFill/>
           <a:ln w="12700" cap="sq" cmpd="sng" algn="ctr">
@@ -2556,7 +2557,7 @@
             <a:fld id="{75EEBB46-7A81-4557-A313-00D814F92FCC}" type="datetimeFigureOut">
               <a:rPr lang="es-ES" smtClean="0"/>
               <a:pPr/>
-              <a:t>26/4/20</a:t>
+              <a:t>20/3/26</a:t>
             </a:fld>
             <a:endParaRPr lang="es-ES"/>
           </a:p>
@@ -2625,8 +2626,8 @@
         </p:nvSpPr>
         <p:spPr>
           <a:xfrm>
-            <a:off x="914400" y="2247900"/>
-            <a:ext cx="3733800" cy="3886200"/>
+            <a:off x="1219200" y="2247900"/>
+            <a:ext cx="4978400" cy="3886200"/>
           </a:xfrm>
         </p:spPr>
         <p:txBody>
@@ -2682,8 +2683,8 @@
         </p:nvSpPr>
         <p:spPr>
           <a:xfrm>
-            <a:off x="4953000" y="2247900"/>
-            <a:ext cx="3733800" cy="3886200"/>
+            <a:off x="6604000" y="2247900"/>
+            <a:ext cx="4978400" cy="3886200"/>
           </a:xfrm>
         </p:spPr>
         <p:txBody>
@@ -2793,7 +2794,7 @@
             <a:fld id="{75EEBB46-7A81-4557-A313-00D814F92FCC}" type="datetimeFigureOut">
               <a:rPr lang="es-ES" smtClean="0"/>
               <a:pPr/>
-              <a:t>26/4/20</a:t>
+              <a:t>20/3/26</a:t>
             </a:fld>
             <a:endParaRPr lang="es-ES"/>
           </a:p>
@@ -2893,7 +2894,7 @@
             <a:fld id="{75EEBB46-7A81-4557-A313-00D814F92FCC}" type="datetimeFigureOut">
               <a:rPr lang="es-ES" smtClean="0"/>
               <a:pPr/>
-              <a:t>26/4/20</a:t>
+              <a:t>20/3/26</a:t>
             </a:fld>
             <a:endParaRPr lang="es-ES"/>
           </a:p>
@@ -2984,7 +2985,7 @@
         <p:spPr>
           <a:xfrm>
             <a:off x="0" y="0"/>
-            <a:ext cx="9144000" cy="6858000"/>
+            <a:ext cx="12192000" cy="6858000"/>
           </a:xfrm>
           <a:prstGeom prst="rect">
             <a:avLst/>
@@ -3017,7 +3018,7 @@
           <a:lstStyle/>
           <a:p>
             <a:pPr algn="ctr" eaLnBrk="1" latinLnBrk="0" hangingPunct="1"/>
-            <a:endParaRPr kumimoji="0" lang="en-US"/>
+            <a:endParaRPr kumimoji="0" lang="en-US" sz="1800"/>
           </a:p>
         </p:txBody>
       </p:sp>
@@ -3029,8 +3030,8 @@
         </p:nvSpPr>
         <p:spPr>
           <a:xfrm>
-            <a:off x="64008" y="69755"/>
-            <a:ext cx="9013372" cy="6693408"/>
+            <a:off x="85344" y="69755"/>
+            <a:ext cx="12017829" cy="6693408"/>
           </a:xfrm>
           <a:prstGeom prst="roundRect">
             <a:avLst>
@@ -3066,7 +3067,7 @@
           <a:lstStyle/>
           <a:p>
             <a:pPr algn="ctr" eaLnBrk="1" latinLnBrk="0" hangingPunct="1"/>
-            <a:endParaRPr kumimoji="0" lang="en-US"/>
+            <a:endParaRPr kumimoji="0" lang="en-US" sz="1800"/>
           </a:p>
         </p:txBody>
       </p:sp>
@@ -3082,8 +3083,8 @@
         </p:nvSpPr>
         <p:spPr>
           <a:xfrm>
-            <a:off x="914400" y="273050"/>
-            <a:ext cx="7772400" cy="1143000"/>
+            <a:off x="1219200" y="273050"/>
+            <a:ext cx="10363200" cy="1143000"/>
           </a:xfrm>
         </p:spPr>
         <p:txBody>
@@ -3115,8 +3116,8 @@
         </p:nvSpPr>
         <p:spPr>
           <a:xfrm>
-            <a:off x="914400" y="1600200"/>
-            <a:ext cx="1905000" cy="4495800"/>
+            <a:off x="1219200" y="1600200"/>
+            <a:ext cx="2540000" cy="4495800"/>
           </a:xfrm>
         </p:spPr>
         <p:txBody>
@@ -3170,7 +3171,7 @@
             <a:fld id="{75EEBB46-7A81-4557-A313-00D814F92FCC}" type="datetimeFigureOut">
               <a:rPr lang="es-ES" smtClean="0"/>
               <a:pPr/>
-              <a:t>26/4/20</a:t>
+              <a:t>20/3/26</a:t>
             </a:fld>
             <a:endParaRPr lang="es-ES"/>
           </a:p>
@@ -3239,8 +3240,8 @@
         </p:nvSpPr>
         <p:spPr>
           <a:xfrm>
-            <a:off x="2971800" y="1600200"/>
-            <a:ext cx="5715000" cy="4495800"/>
+            <a:off x="3962400" y="1600200"/>
+            <a:ext cx="7620000" cy="4495800"/>
           </a:xfrm>
         </p:spPr>
         <p:txBody>
@@ -3321,8 +3322,8 @@
         </p:nvSpPr>
         <p:spPr>
           <a:xfrm>
-            <a:off x="914400" y="4900550"/>
-            <a:ext cx="7315200" cy="522288"/>
+            <a:off x="1219200" y="4900550"/>
+            <a:ext cx="9753600" cy="522288"/>
           </a:xfrm>
         </p:spPr>
         <p:txBody>
@@ -3356,8 +3357,8 @@
         </p:nvSpPr>
         <p:spPr>
           <a:xfrm>
-            <a:off x="914400" y="5445825"/>
-            <a:ext cx="7315200" cy="685800"/>
+            <a:off x="1219200" y="5445825"/>
+            <a:ext cx="9753600" cy="685800"/>
           </a:xfrm>
         </p:spPr>
         <p:txBody>
@@ -3408,7 +3409,7 @@
             <a:fld id="{75EEBB46-7A81-4557-A313-00D814F92FCC}" type="datetimeFigureOut">
               <a:rPr lang="es-ES" smtClean="0"/>
               <a:pPr/>
-              <a:t>26/4/20</a:t>
+              <a:t>20/3/26</a:t>
             </a:fld>
             <a:endParaRPr lang="es-ES"/>
           </a:p>
@@ -3426,8 +3427,8 @@
         </p:nvSpPr>
         <p:spPr>
           <a:xfrm>
-            <a:off x="914400" y="6172200"/>
-            <a:ext cx="3886200" cy="457200"/>
+            <a:off x="1219200" y="6172200"/>
+            <a:ext cx="5181600" cy="457200"/>
           </a:xfrm>
         </p:spPr>
         <p:txBody>
@@ -3450,8 +3451,8 @@
         </p:nvSpPr>
         <p:spPr>
           <a:xfrm>
-            <a:off x="146304" y="6208776"/>
-            <a:ext cx="457200" cy="457200"/>
+            <a:off x="195072" y="6208776"/>
+            <a:ext cx="609600" cy="457200"/>
           </a:xfrm>
         </p:spPr>
         <p:txBody>
@@ -3475,8 +3476,8 @@
         </p:nvSpPr>
         <p:spPr>
           <a:xfrm flipV="1">
-            <a:off x="68307" y="4683555"/>
-            <a:ext cx="9006840" cy="91440"/>
+            <a:off x="91076" y="4683555"/>
+            <a:ext cx="12009120" cy="91440"/>
           </a:xfrm>
           <a:prstGeom prst="rect">
             <a:avLst/>
@@ -3511,7 +3512,7 @@
           <a:lstStyle/>
           <a:p>
             <a:pPr algn="ctr" eaLnBrk="1" latinLnBrk="0" hangingPunct="1"/>
-            <a:endParaRPr kumimoji="0" lang="en-US"/>
+            <a:endParaRPr kumimoji="0" lang="en-US" sz="1800"/>
           </a:p>
         </p:txBody>
       </p:sp>
@@ -3523,8 +3524,8 @@
         </p:nvSpPr>
         <p:spPr>
           <a:xfrm>
-            <a:off x="68508" y="4650474"/>
-            <a:ext cx="9006639" cy="45719"/>
+            <a:off x="91345" y="4650475"/>
+            <a:ext cx="12008852" cy="45719"/>
           </a:xfrm>
           <a:prstGeom prst="rect">
             <a:avLst/>
@@ -3559,7 +3560,7 @@
           <a:lstStyle/>
           <a:p>
             <a:pPr algn="ctr" eaLnBrk="1" latinLnBrk="0" hangingPunct="1"/>
-            <a:endParaRPr kumimoji="0" lang="en-US"/>
+            <a:endParaRPr kumimoji="0" lang="en-US" sz="1800"/>
           </a:p>
         </p:txBody>
       </p:sp>
@@ -3571,8 +3572,8 @@
         </p:nvSpPr>
         <p:spPr>
           <a:xfrm>
-            <a:off x="68510" y="4773224"/>
-            <a:ext cx="9006637" cy="48807"/>
+            <a:off x="91348" y="4773225"/>
+            <a:ext cx="12008849" cy="48807"/>
           </a:xfrm>
           <a:prstGeom prst="rect">
             <a:avLst/>
@@ -3605,7 +3606,7 @@
           <a:lstStyle/>
           <a:p>
             <a:pPr algn="ctr" eaLnBrk="1" latinLnBrk="0" hangingPunct="1"/>
-            <a:endParaRPr kumimoji="0" lang="en-US"/>
+            <a:endParaRPr kumimoji="0" lang="en-US" sz="1800"/>
           </a:p>
         </p:txBody>
       </p:sp>
@@ -3621,8 +3622,8 @@
         </p:nvSpPr>
         <p:spPr>
           <a:xfrm>
-            <a:off x="68308" y="66675"/>
-            <a:ext cx="9001873" cy="4581525"/>
+            <a:off x="91078" y="66675"/>
+            <a:ext cx="12002497" cy="4581525"/>
           </a:xfrm>
           <a:prstGeom prst="round2SameRect">
             <a:avLst>
@@ -3695,7 +3696,7 @@
         <p:spPr>
           <a:xfrm>
             <a:off x="0" y="0"/>
-            <a:ext cx="9144000" cy="6858000"/>
+            <a:ext cx="12192000" cy="6858000"/>
           </a:xfrm>
           <a:prstGeom prst="rect">
             <a:avLst/>
@@ -3727,7 +3728,7 @@
           <a:lstStyle/>
           <a:p>
             <a:pPr algn="ctr" eaLnBrk="1" latinLnBrk="0" hangingPunct="1"/>
-            <a:endParaRPr kumimoji="0" lang="en-US"/>
+            <a:endParaRPr kumimoji="0" lang="en-US" sz="1800"/>
           </a:p>
         </p:txBody>
       </p:sp>
@@ -3739,8 +3740,8 @@
         </p:nvSpPr>
         <p:spPr>
           <a:xfrm>
-            <a:off x="64008" y="69755"/>
-            <a:ext cx="9013372" cy="6693408"/>
+            <a:off x="85344" y="69755"/>
+            <a:ext cx="12017829" cy="6693408"/>
           </a:xfrm>
           <a:prstGeom prst="roundRect">
             <a:avLst>
@@ -3776,7 +3777,7 @@
           <a:lstStyle/>
           <a:p>
             <a:pPr algn="ctr" eaLnBrk="1" latinLnBrk="0" hangingPunct="1"/>
-            <a:endParaRPr kumimoji="0" lang="en-US"/>
+            <a:endParaRPr kumimoji="0" lang="en-US" sz="1800"/>
           </a:p>
         </p:txBody>
       </p:sp>
@@ -3792,8 +3793,8 @@
         </p:nvSpPr>
         <p:spPr>
           <a:xfrm>
-            <a:off x="914400" y="274638"/>
-            <a:ext cx="7772400" cy="1143000"/>
+            <a:off x="1219200" y="274638"/>
+            <a:ext cx="10363200" cy="1143000"/>
           </a:xfrm>
           <a:prstGeom prst="rect">
             <a:avLst/>
@@ -3825,8 +3826,8 @@
         </p:nvSpPr>
         <p:spPr>
           <a:xfrm>
-            <a:off x="914400" y="1447800"/>
-            <a:ext cx="7772400" cy="4572000"/>
+            <a:off x="1219200" y="1447800"/>
+            <a:ext cx="10363200" cy="4572000"/>
           </a:xfrm>
           <a:prstGeom prst="rect">
             <a:avLst/>
@@ -3887,8 +3888,8 @@
         </p:nvSpPr>
         <p:spPr>
           <a:xfrm>
-            <a:off x="6172200" y="6191250"/>
-            <a:ext cx="2476500" cy="476250"/>
+            <a:off x="8229600" y="6191250"/>
+            <a:ext cx="3302000" cy="476250"/>
           </a:xfrm>
           <a:prstGeom prst="rect">
             <a:avLst/>
@@ -3909,7 +3910,7 @@
             <a:fld id="{75EEBB46-7A81-4557-A313-00D814F92FCC}" type="datetimeFigureOut">
               <a:rPr lang="es-ES" smtClean="0"/>
               <a:pPr/>
-              <a:t>26/4/20</a:t>
+              <a:t>20/3/26</a:t>
             </a:fld>
             <a:endParaRPr lang="es-ES"/>
           </a:p>
@@ -3927,8 +3928,8 @@
         </p:nvSpPr>
         <p:spPr>
           <a:xfrm>
-            <a:off x="914400" y="6172200"/>
-            <a:ext cx="3962400" cy="457200"/>
+            <a:off x="1219200" y="6172200"/>
+            <a:ext cx="5283200" cy="457200"/>
           </a:xfrm>
           <a:prstGeom prst="rect">
             <a:avLst/>
@@ -3978,8 +3979,8 @@
         </p:nvSpPr>
         <p:spPr>
           <a:xfrm>
-            <a:off x="146304" y="6210300"/>
-            <a:ext cx="457200" cy="457200"/>
+            <a:off x="195072" y="6210300"/>
+            <a:ext cx="609600" cy="457200"/>
           </a:xfrm>
           <a:prstGeom prst="ellipse">
             <a:avLst/>
@@ -4342,7 +4343,7 @@
         </p:nvSpPr>
         <p:spPr>
           <a:xfrm>
-            <a:off x="539552" y="1472559"/>
+            <a:off x="2063552" y="1472560"/>
             <a:ext cx="8229600" cy="1470025"/>
           </a:xfrm>
         </p:spPr>
@@ -4404,7 +4405,7 @@
         </p:blipFill>
         <p:spPr bwMode="auto">
           <a:xfrm>
-            <a:off x="3929058" y="285728"/>
+            <a:off x="5453058" y="285728"/>
             <a:ext cx="3600450" cy="1152526"/>
           </a:xfrm>
           <a:prstGeom prst="rect">
@@ -4431,7 +4432,7 @@
             </p:nvSpPr>
             <p:spPr>
               <a:xfrm>
-                <a:off x="539552" y="3429000"/>
+                <a:off x="2063552" y="3429000"/>
                 <a:ext cx="7762056" cy="2413248"/>
               </a:xfrm>
               <a:prstGeom prst="rect">
@@ -4637,7 +4638,7 @@
                   <a:rPr lang="es-ES" sz="3400" dirty="0" err="1"/>
                   <a:t>requirements</a:t>
                 </a:r>
-                <a:endParaRPr lang="es-ES" sz="3400" b="0" dirty="0">
+                <a:endParaRPr lang="es-ES" sz="3400" dirty="0">
                   <a:latin typeface="Cambria Math" panose="02040503050406030204" pitchFamily="18" charset="0"/>
                 </a:endParaRPr>
               </a:p>
@@ -4649,7 +4650,7 @@
                 <a14:m>
                   <m:oMath xmlns:m="http://schemas.openxmlformats.org/officeDocument/2006/math">
                     <m:r>
-                      <a:rPr lang="es-ES" sz="3400" b="0" i="1" smtClean="0">
+                      <a:rPr lang="es-ES" sz="3400" i="1">
                         <a:latin typeface="Cambria Math" panose="02040503050406030204" pitchFamily="18" charset="0"/>
                       </a:rPr>
                       <m:t>𝐶</m:t>
@@ -4657,14 +4658,14 @@
                     <m:d>
                       <m:dPr>
                         <m:ctrlPr>
-                          <a:rPr lang="es-ES" sz="3400" b="0" i="1" smtClean="0">
+                          <a:rPr lang="es-ES" sz="3400" i="1">
                             <a:latin typeface="Cambria Math" panose="02040503050406030204" pitchFamily="18" charset="0"/>
                           </a:rPr>
                         </m:ctrlPr>
                       </m:dPr>
                       <m:e>
                         <m:r>
-                          <a:rPr lang="es-ES" sz="3400" b="0" i="1" smtClean="0">
+                          <a:rPr lang="es-ES" sz="3400" i="1">
                             <a:latin typeface="Cambria Math" panose="02040503050406030204" pitchFamily="18" charset="0"/>
                           </a:rPr>
                           <m:t>𝐴</m:t>
@@ -4711,19 +4712,19 @@
                 <a14:m>
                   <m:oMath xmlns:m="http://schemas.openxmlformats.org/officeDocument/2006/math">
                     <m:r>
-                      <a:rPr lang="es-ES" sz="3600" b="0" i="1" smtClean="0">
+                      <a:rPr lang="es-ES" sz="3600" i="1">
                         <a:latin typeface="Cambria Math" panose="02040503050406030204" pitchFamily="18" charset="0"/>
                       </a:rPr>
                       <m:t>𝐴𝑥</m:t>
                     </m:r>
                     <m:r>
-                      <a:rPr lang="es-ES" sz="3600" b="0" i="1" smtClean="0">
+                      <a:rPr lang="es-ES" sz="3600" i="1">
                         <a:latin typeface="Cambria Math" panose="02040503050406030204" pitchFamily="18" charset="0"/>
                       </a:rPr>
                       <m:t>=</m:t>
                     </m:r>
                     <m:r>
-                      <a:rPr lang="es-ES" sz="3600" b="0" i="1" smtClean="0">
+                      <a:rPr lang="es-ES" sz="3600" i="1">
                         <a:latin typeface="Cambria Math" panose="02040503050406030204" pitchFamily="18" charset="0"/>
                       </a:rPr>
                       <m:t>𝑏</m:t>
@@ -4740,7 +4741,7 @@
                 <a14:m>
                   <m:oMath xmlns:m="http://schemas.openxmlformats.org/officeDocument/2006/math">
                     <m:r>
-                      <a:rPr lang="es-ES" sz="3600" b="0" i="1" smtClean="0">
+                      <a:rPr lang="es-ES" sz="3600" i="1">
                         <a:latin typeface="Cambria Math" panose="02040503050406030204" pitchFamily="18" charset="0"/>
                       </a:rPr>
                       <m:t>𝑁</m:t>
@@ -4770,7 +4771,7 @@
                       <m:t>→</m:t>
                     </m:r>
                     <m:r>
-                      <a:rPr lang="es-ES" sz="3600" b="0" i="1" smtClean="0">
+                      <a:rPr lang="es-ES" sz="3600" i="1">
                         <a:latin typeface="Cambria Math" panose="02040503050406030204" pitchFamily="18" charset="0"/>
                         <a:ea typeface="Cambria Math" panose="02040503050406030204" pitchFamily="18" charset="0"/>
                       </a:rPr>
@@ -4808,7 +4809,7 @@
             </p:nvSpPr>
             <p:spPr>
               <a:xfrm>
-                <a:off x="539552" y="3429000"/>
+                <a:off x="2063552" y="3429000"/>
                 <a:ext cx="7762056" cy="2413248"/>
               </a:xfrm>
               <a:prstGeom prst="rect">
@@ -4817,7 +4818,7 @@
               <a:blipFill>
                 <a:blip r:embed="rId3"/>
                 <a:stretch>
-                  <a:fillRect t="-2618" b="-8377"/>
+                  <a:fillRect t="-3158" b="-8947"/>
                 </a:stretch>
               </a:blipFill>
             </p:spPr>
@@ -4826,7 +4827,7 @@
               <a:lstStyle/>
               <a:p>
                 <a:r>
-                  <a:rPr lang="es-PY">
+                  <a:rPr lang="es-ES_tradnl">
                     <a:noFill/>
                   </a:rPr>
                   <a:t> </a:t>
@@ -4859,8 +4860,8 @@
         </p:blipFill>
         <p:spPr>
           <a:xfrm>
-            <a:off x="442342" y="5809903"/>
-            <a:ext cx="800100" cy="279400"/>
+            <a:off x="407368" y="6261804"/>
+            <a:ext cx="1325480" cy="462866"/>
           </a:xfrm>
           <a:prstGeom prst="rect">
             <a:avLst/>
@@ -4881,7 +4882,7 @@
         </p:nvSpPr>
         <p:spPr>
           <a:xfrm>
-            <a:off x="320097" y="6139488"/>
+            <a:off x="7824192" y="6089303"/>
             <a:ext cx="4572000" cy="646331"/>
           </a:xfrm>
           <a:prstGeom prst="rect">
@@ -4919,7 +4920,13 @@
   <p:cSld>
     <p:spTree>
       <p:nvGrpSpPr>
-        <p:cNvPr id="1" name=""/>
+        <p:cNvPr id="1" name="">
+          <a:extLst>
+            <a:ext uri="{FF2B5EF4-FFF2-40B4-BE49-F238E27FC236}">
+              <a16:creationId xmlns:a16="http://schemas.microsoft.com/office/drawing/2014/main" id="{CC87843B-9E1C-E3A2-E63D-D723452811DF}"/>
+            </a:ext>
+          </a:extLst>
+        </p:cNvPr>
         <p:cNvGrpSpPr/>
         <p:nvPr/>
       </p:nvGrpSpPr>
@@ -4936,7 +4943,7 @@
           <p:cNvPr id="11" name="1 Título">
             <a:extLst>
               <a:ext uri="{FF2B5EF4-FFF2-40B4-BE49-F238E27FC236}">
-                <a16:creationId xmlns:a16="http://schemas.microsoft.com/office/drawing/2014/main" id="{78093345-92CF-5F44-AAF2-10D38BEB5F91}"/>
+                <a16:creationId xmlns:a16="http://schemas.microsoft.com/office/drawing/2014/main" id="{826D7F17-8254-C93F-9AAE-E2AEE3FFFC8E}"/>
               </a:ext>
             </a:extLst>
           </p:cNvPr>
@@ -4947,8 +4954,8 @@
         </p:nvSpPr>
         <p:spPr>
           <a:xfrm>
-            <a:off x="142655" y="255786"/>
-            <a:ext cx="5365449" cy="1084982"/>
+            <a:off x="345876" y="20954"/>
+            <a:ext cx="6758236" cy="1084982"/>
           </a:xfrm>
           <a:prstGeom prst="rect">
             <a:avLst/>
@@ -4956,7 +4963,7 @@
         </p:spPr>
         <p:txBody>
           <a:bodyPr>
-            <a:normAutofit fontScale="97500"/>
+            <a:noAutofit/>
           </a:bodyPr>
           <a:lstStyle>
             <a:lvl1pPr algn="l" rtl="0" eaLnBrk="1" latinLnBrk="0" hangingPunct="1">
@@ -4976,195 +4983,222 @@
           </a:lstStyle>
           <a:p>
             <a:r>
-              <a:rPr lang="es-PY" sz="3600" dirty="0"/>
+              <a:rPr lang="es-PY" dirty="0">
+                <a:latin typeface="Calibri" panose="020F0502020204030204" pitchFamily="34" charset="0"/>
+                <a:cs typeface="Calibri" panose="020F0502020204030204" pitchFamily="34" charset="0"/>
+              </a:rPr>
               <a:t>Vector Space requirements.</a:t>
             </a:r>
-            <a:endParaRPr lang="es-ES" sz="3600" dirty="0"/>
+            <a:endParaRPr lang="es-ES" dirty="0">
+              <a:latin typeface="Calibri" panose="020F0502020204030204" pitchFamily="34" charset="0"/>
+              <a:cs typeface="Calibri" panose="020F0502020204030204" pitchFamily="34" charset="0"/>
+            </a:endParaRPr>
           </a:p>
         </p:txBody>
       </p:sp>
-      <mc:AlternateContent xmlns:mc="http://schemas.openxmlformats.org/markup-compatibility/2006" xmlns:a14="http://schemas.microsoft.com/office/drawing/2010/main">
-        <mc:Choice Requires="a14">
+      <p:sp>
+        <p:nvSpPr>
+          <p:cNvPr id="57" name="Rectángulo 56">
+            <a:extLst>
+              <a:ext uri="{FF2B5EF4-FFF2-40B4-BE49-F238E27FC236}">
+                <a16:creationId xmlns:a16="http://schemas.microsoft.com/office/drawing/2014/main" id="{EE91AD85-4067-73A2-68B5-CB6CD98BFE2E}"/>
+              </a:ext>
+            </a:extLst>
+          </p:cNvPr>
+          <p:cNvSpPr/>
+          <p:nvPr/>
+        </p:nvSpPr>
+        <p:spPr>
+          <a:xfrm>
+            <a:off x="2063552" y="4897580"/>
+            <a:ext cx="8064896" cy="584775"/>
+          </a:xfrm>
+          <a:prstGeom prst="rect">
+            <a:avLst/>
+          </a:prstGeom>
+        </p:spPr>
+        <p:txBody>
+          <a:bodyPr wrap="square">
+            <a:spAutoFit/>
+          </a:bodyPr>
+          <a:lstStyle/>
+          <a:p>
+            <a:r>
+              <a:rPr lang="es-PY" sz="3200" b="1" dirty="0">
+                <a:solidFill>
+                  <a:srgbClr val="0070C0"/>
+                </a:solidFill>
+                <a:latin typeface="Calibri" panose="020F0502020204030204" pitchFamily="34" charset="0"/>
+                <a:cs typeface="Calibri" panose="020F0502020204030204" pitchFamily="34" charset="0"/>
+              </a:rPr>
+              <a:t>Subspace = closed under linear combinations</a:t>
+            </a:r>
+          </a:p>
+        </p:txBody>
+      </p:sp>
+      <mc:AlternateContent xmlns:mc="http://schemas.openxmlformats.org/markup-compatibility/2006">
+        <mc:Choice xmlns:a14="http://schemas.microsoft.com/office/drawing/2010/main" Requires="a14">
           <p:sp>
             <p:nvSpPr>
-              <p:cNvPr id="57" name="Rectángulo 56">
+              <p:cNvPr id="3" name="CuadroTexto 2">
                 <a:extLst>
                   <a:ext uri="{FF2B5EF4-FFF2-40B4-BE49-F238E27FC236}">
-                    <a16:creationId xmlns:a16="http://schemas.microsoft.com/office/drawing/2014/main" id="{FF769936-45DB-3043-8E11-78E1F8784A69}"/>
+                    <a16:creationId xmlns:a16="http://schemas.microsoft.com/office/drawing/2014/main" id="{D19BE13C-B0FB-B96E-8DCB-D445FEBFE2CB}"/>
                   </a:ext>
                 </a:extLst>
               </p:cNvPr>
-              <p:cNvSpPr/>
+              <p:cNvSpPr txBox="1"/>
               <p:nvPr/>
             </p:nvSpPr>
             <p:spPr>
               <a:xfrm>
-                <a:off x="539552" y="1059994"/>
-                <a:ext cx="6768752" cy="1569660"/>
+                <a:off x="4136716" y="1668032"/>
+                <a:ext cx="3639330" cy="430887"/>
               </a:xfrm>
               <a:prstGeom prst="rect">
                 <a:avLst/>
               </a:prstGeom>
+              <a:noFill/>
             </p:spPr>
             <p:txBody>
-              <a:bodyPr wrap="square">
+              <a:bodyPr wrap="none" lIns="0" tIns="0" rIns="0" bIns="0" rtlCol="0">
                 <a:spAutoFit/>
               </a:bodyPr>
               <a:lstStyle/>
               <a:p>
-                <a:pPr algn="just"/>
                 <a14:m>
-                  <m:oMath xmlns:m="http://schemas.openxmlformats.org/officeDocument/2006/math">
-                    <m:r>
-                      <a:rPr lang="es-ES" sz="3200" b="1" i="1" dirty="0" smtClean="0">
-                        <a:latin typeface="Cambria Math" panose="02040503050406030204" pitchFamily="18" charset="0"/>
-                      </a:rPr>
-                      <m:t>𝒗</m:t>
-                    </m:r>
-                    <m:r>
-                      <a:rPr lang="es-ES" sz="3200" b="0" i="1" dirty="0" smtClean="0">
-                        <a:latin typeface="Cambria Math" panose="02040503050406030204" pitchFamily="18" charset="0"/>
-                      </a:rPr>
-                      <m:t>+</m:t>
-                    </m:r>
-                    <m:r>
-                      <a:rPr lang="es-ES" sz="3200" b="1" i="1" dirty="0" smtClean="0">
-                        <a:latin typeface="Cambria Math" panose="02040503050406030204" pitchFamily="18" charset="0"/>
-                      </a:rPr>
-                      <m:t>𝒘</m:t>
-                    </m:r>
-                    <m:r>
-                      <a:rPr lang="es-ES" sz="3200" b="0" i="1" dirty="0" smtClean="0">
-                        <a:latin typeface="Cambria Math" panose="02040503050406030204" pitchFamily="18" charset="0"/>
-                      </a:rPr>
-                      <m:t> </m:t>
-                    </m:r>
-                  </m:oMath>
+                  <m:oMathPara xmlns:m="http://schemas.openxmlformats.org/officeDocument/2006/math">
+                    <m:oMathParaPr>
+                      <m:jc m:val="centerGroup"/>
+                    </m:oMathParaPr>
+                    <m:oMath xmlns:m="http://schemas.openxmlformats.org/officeDocument/2006/math">
+                      <m:r>
+                        <m:rPr>
+                          <m:nor/>
+                        </m:rPr>
+                        <a:rPr lang="es-PY" sz="2800" smtClean="0"/>
+                        <m:t>v</m:t>
+                      </m:r>
+                      <m:r>
+                        <m:rPr>
+                          <m:nor/>
+                        </m:rPr>
+                        <a:rPr lang="es-PY" sz="2800" smtClean="0"/>
+                        <m:t> ∈ </m:t>
+                      </m:r>
+                      <m:r>
+                        <m:rPr>
+                          <m:nor/>
+                        </m:rPr>
+                        <a:rPr lang="es-PY" sz="2800" smtClean="0"/>
+                        <m:t>ℝ</m:t>
+                      </m:r>
+                      <m:r>
+                        <m:rPr>
+                          <m:nor/>
+                        </m:rPr>
+                        <a:rPr lang="es-PY" sz="2800" smtClean="0"/>
+                        <m:t>ⁿ, </m:t>
+                      </m:r>
+                      <m:r>
+                        <m:rPr>
+                          <m:nor/>
+                        </m:rPr>
+                        <a:rPr lang="es-PY" sz="2800" smtClean="0"/>
+                        <m:t>w</m:t>
+                      </m:r>
+                      <m:r>
+                        <m:rPr>
+                          <m:nor/>
+                        </m:rPr>
+                        <a:rPr lang="es-PY" sz="2800" smtClean="0"/>
+                        <m:t> ∈ </m:t>
+                      </m:r>
+                      <m:r>
+                        <m:rPr>
+                          <m:nor/>
+                        </m:rPr>
+                        <a:rPr lang="es-PY" sz="2800" smtClean="0"/>
+                        <m:t>ℝ</m:t>
+                      </m:r>
+                      <m:r>
+                        <m:rPr>
+                          <m:nor/>
+                        </m:rPr>
+                        <a:rPr lang="es-PY" sz="2800" smtClean="0"/>
+                        <m:t>ⁿ</m:t>
+                      </m:r>
+                      <m:r>
+                        <a:rPr lang="en-US" sz="2800" b="0" i="1" smtClean="0">
+                          <a:latin typeface="Cambria Math" panose="02040503050406030204" pitchFamily="18" charset="0"/>
+                        </a:rPr>
+                        <m:t>, </m:t>
+                      </m:r>
+                      <m:r>
+                        <a:rPr lang="es-PY" sz="2800" i="1" smtClean="0">
+                          <a:latin typeface="Cambria Math" panose="02040503050406030204" pitchFamily="18" charset="0"/>
+                          <a:ea typeface="Cambria Math" panose="02040503050406030204" pitchFamily="18" charset="0"/>
+                        </a:rPr>
+                        <m:t>𝛼</m:t>
+                      </m:r>
+                      <m:r>
+                        <m:rPr>
+                          <m:nor/>
+                        </m:rPr>
+                        <a:rPr lang="es-PY" sz="2800"/>
+                        <m:t> ,</m:t>
+                      </m:r>
+                      <m:r>
+                        <m:rPr>
+                          <m:sty m:val="p"/>
+                        </m:rPr>
+                        <a:rPr lang="el-GR" sz="2800" i="1" smtClean="0">
+                          <a:latin typeface="Cambria Math" panose="02040503050406030204" pitchFamily="18" charset="0"/>
+                          <a:ea typeface="Cambria Math" panose="02040503050406030204" pitchFamily="18" charset="0"/>
+                        </a:rPr>
+                        <m:t>β</m:t>
+                      </m:r>
+                      <m:r>
+                        <m:rPr>
+                          <m:nor/>
+                        </m:rPr>
+                        <a:rPr lang="es-PY" sz="2800"/>
+                        <m:t> ∈ </m:t>
+                      </m:r>
+                      <m:r>
+                        <m:rPr>
+                          <m:nor/>
+                        </m:rPr>
+                        <a:rPr lang="es-PY" sz="2800"/>
+                        <m:t>ℝ</m:t>
+                      </m:r>
+                    </m:oMath>
+                  </m:oMathPara>
                 </a14:m>
-                <a:r>
-                  <a:rPr lang="es-PY" sz="3200" dirty="0"/>
-                  <a:t>and </a:t>
-                </a:r>
-                <a14:m>
-                  <m:oMath xmlns:m="http://schemas.openxmlformats.org/officeDocument/2006/math">
-                    <m:r>
-                      <m:rPr>
-                        <m:sty m:val="p"/>
-                      </m:rPr>
-                      <a:rPr lang="es-ES" sz="3200" b="0" i="0" dirty="0" smtClean="0">
-                        <a:latin typeface="Cambria Math" panose="02040503050406030204" pitchFamily="18" charset="0"/>
-                      </a:rPr>
-                      <m:t>c</m:t>
-                    </m:r>
-                    <m:r>
-                      <a:rPr lang="es-ES" sz="3200" b="1" i="1" dirty="0">
-                        <a:latin typeface="Cambria Math" panose="02040503050406030204" pitchFamily="18" charset="0"/>
-                      </a:rPr>
-                      <m:t>𝒗</m:t>
-                    </m:r>
-                  </m:oMath>
-                </a14:m>
-                <a:r>
-                  <a:rPr lang="es-PY" sz="3200" dirty="0"/>
-                  <a:t> are </a:t>
-                </a:r>
-                <a:r>
-                  <a:rPr lang="es-PY" sz="3200" u="sng" dirty="0"/>
-                  <a:t>in the space</a:t>
-                </a:r>
-                <a:r>
-                  <a:rPr lang="es-PY" sz="3200" dirty="0"/>
-                  <a:t>.</a:t>
-                </a:r>
-              </a:p>
-              <a:p>
-                <a:pPr algn="just"/>
-                <a:endParaRPr lang="es-PY" sz="3200" dirty="0"/>
-              </a:p>
-              <a:p>
-                <a:pPr algn="just"/>
-                <a:r>
-                  <a:rPr lang="es-PY" sz="3200" dirty="0"/>
-                  <a:t>All combinations </a:t>
-                </a:r>
-                <a14:m>
-                  <m:oMath xmlns:m="http://schemas.openxmlformats.org/officeDocument/2006/math">
-                    <m:r>
-                      <m:rPr>
-                        <m:sty m:val="p"/>
-                      </m:rPr>
-                      <a:rPr lang="es-ES" sz="3200" b="0" i="0" dirty="0" smtClean="0">
-                        <a:latin typeface="Cambria Math" panose="02040503050406030204" pitchFamily="18" charset="0"/>
-                      </a:rPr>
-                      <m:t>c</m:t>
-                    </m:r>
-                    <m:r>
-                      <a:rPr lang="es-ES" sz="3200" b="1" i="1" dirty="0">
-                        <a:latin typeface="Cambria Math" panose="02040503050406030204" pitchFamily="18" charset="0"/>
-                      </a:rPr>
-                      <m:t>𝒗</m:t>
-                    </m:r>
-                    <m:r>
-                      <a:rPr lang="es-ES" sz="3200" i="1" dirty="0">
-                        <a:latin typeface="Cambria Math" panose="02040503050406030204" pitchFamily="18" charset="0"/>
-                      </a:rPr>
-                      <m:t>+</m:t>
-                    </m:r>
-                    <m:r>
-                      <a:rPr lang="es-ES" sz="3200" b="1" i="1" dirty="0" smtClean="0">
-                        <a:latin typeface="Cambria Math" panose="02040503050406030204" pitchFamily="18" charset="0"/>
-                      </a:rPr>
-                      <m:t>𝒅</m:t>
-                    </m:r>
-                    <m:r>
-                      <a:rPr lang="es-ES" sz="3200" b="1" i="1" dirty="0">
-                        <a:latin typeface="Cambria Math" panose="02040503050406030204" pitchFamily="18" charset="0"/>
-                      </a:rPr>
-                      <m:t>𝒘</m:t>
-                    </m:r>
-                    <m:r>
-                      <a:rPr lang="es-ES" sz="3200" i="1" dirty="0">
-                        <a:latin typeface="Cambria Math" panose="02040503050406030204" pitchFamily="18" charset="0"/>
-                      </a:rPr>
-                      <m:t> </m:t>
-                    </m:r>
-                  </m:oMath>
-                </a14:m>
-                <a:r>
-                  <a:rPr lang="es-PY" sz="3200" dirty="0"/>
-                  <a:t>are </a:t>
-                </a:r>
-                <a:r>
-                  <a:rPr lang="es-PY" sz="3200" u="sng" dirty="0"/>
-                  <a:t>in the space</a:t>
-                </a:r>
-                <a:r>
-                  <a:rPr lang="es-PY" sz="3200" dirty="0"/>
-                  <a:t>.</a:t>
-                </a:r>
+                <a:endParaRPr lang="es-PY" sz="2800" dirty="0"/>
               </a:p>
             </p:txBody>
           </p:sp>
         </mc:Choice>
-        <mc:Fallback xmlns="">
+        <mc:Fallback>
           <p:sp>
             <p:nvSpPr>
-              <p:cNvPr id="57" name="Rectángulo 56">
+              <p:cNvPr id="3" name="CuadroTexto 2">
                 <a:extLst>
                   <a:ext uri="{FF2B5EF4-FFF2-40B4-BE49-F238E27FC236}">
-                    <a16:creationId xmlns:a16="http://schemas.microsoft.com/office/drawing/2014/main" id="{FF769936-45DB-3043-8E11-78E1F8784A69}"/>
+                    <a16:creationId xmlns:a16="http://schemas.microsoft.com/office/drawing/2014/main" id="{D19BE13C-B0FB-B96E-8DCB-D445FEBFE2CB}"/>
                   </a:ext>
                 </a:extLst>
               </p:cNvPr>
-              <p:cNvSpPr>
+              <p:cNvSpPr txBox="1">
                 <a:spLocks noRot="1" noChangeAspect="1" noMove="1" noResize="1" noEditPoints="1" noAdjustHandles="1" noChangeArrowheads="1" noChangeShapeType="1" noTextEdit="1"/>
               </p:cNvSpPr>
               <p:nvPr/>
             </p:nvSpPr>
             <p:spPr>
               <a:xfrm>
-                <a:off x="539552" y="1059994"/>
-                <a:ext cx="6768752" cy="1569660"/>
+                <a:off x="4136716" y="1668032"/>
+                <a:ext cx="3639330" cy="430887"/>
               </a:xfrm>
               <a:prstGeom prst="rect">
                 <a:avLst/>
@@ -5172,7 +5206,7 @@
               <a:blipFill>
                 <a:blip r:embed="rId2"/>
                 <a:stretch>
-                  <a:fillRect l="-2060" t="-3200" r="-1311" b="-12000"/>
+                  <a:fillRect l="-347" t="-14286" r="-1736" b="-40000"/>
                 </a:stretch>
               </a:blipFill>
             </p:spPr>
@@ -5181,7 +5215,7 @@
               <a:lstStyle/>
               <a:p>
                 <a:r>
-                  <a:rPr lang="es-PY">
+                  <a:rPr lang="es-ES_tradnl">
                     <a:noFill/>
                   </a:rPr>
                   <a:t> </a:t>
@@ -5191,232 +5225,146 @@
           </p:sp>
         </mc:Fallback>
       </mc:AlternateContent>
-      <mc:AlternateContent xmlns:mc="http://schemas.openxmlformats.org/markup-compatibility/2006" xmlns:a14="http://schemas.microsoft.com/office/drawing/2010/main">
-        <mc:Choice Requires="a14">
+      <mc:AlternateContent xmlns:mc="http://schemas.openxmlformats.org/markup-compatibility/2006">
+        <mc:Choice xmlns:a14="http://schemas.microsoft.com/office/drawing/2010/main" Requires="a14">
           <p:sp>
             <p:nvSpPr>
-              <p:cNvPr id="5" name="Rectángulo 4">
+              <p:cNvPr id="4" name="CuadroTexto 3">
                 <a:extLst>
                   <a:ext uri="{FF2B5EF4-FFF2-40B4-BE49-F238E27FC236}">
-                    <a16:creationId xmlns:a16="http://schemas.microsoft.com/office/drawing/2014/main" id="{A3586177-BBC9-A143-9F1F-4C8C829E42A8}"/>
+                    <a16:creationId xmlns:a16="http://schemas.microsoft.com/office/drawing/2014/main" id="{83A1DDDF-8143-1FE4-9440-BC9076F00C96}"/>
                   </a:ext>
                 </a:extLst>
               </p:cNvPr>
-              <p:cNvSpPr/>
+              <p:cNvSpPr txBox="1"/>
               <p:nvPr/>
             </p:nvSpPr>
             <p:spPr>
               <a:xfrm>
-                <a:off x="6228184" y="263550"/>
-                <a:ext cx="2769989" cy="1077218"/>
+                <a:off x="4681993" y="3073343"/>
+                <a:ext cx="2854948" cy="553998"/>
               </a:xfrm>
               <a:prstGeom prst="rect">
                 <a:avLst/>
               </a:prstGeom>
+              <a:noFill/>
             </p:spPr>
             <p:txBody>
-              <a:bodyPr wrap="none">
+              <a:bodyPr wrap="none" lIns="0" tIns="0" rIns="0" bIns="0" rtlCol="0">
                 <a:spAutoFit/>
               </a:bodyPr>
               <a:lstStyle/>
               <a:p>
                 <a14:m>
-                  <m:oMath xmlns:m="http://schemas.openxmlformats.org/officeDocument/2006/math">
-                    <m:r>
-                      <a:rPr lang="es-ES" sz="3200" b="1" i="1" dirty="0" smtClean="0">
-                        <a:latin typeface="Cambria Math" panose="02040503050406030204" pitchFamily="18" charset="0"/>
-                      </a:rPr>
-                      <m:t>𝒗</m:t>
-                    </m:r>
-                  </m:oMath>
-                </a14:m>
-                <a:r>
-                  <a:rPr lang="es-ES" sz="3200" dirty="0"/>
-                  <a:t> </a:t>
-                </a:r>
-                <a14:m>
-                  <m:oMath xmlns:m="http://schemas.openxmlformats.org/officeDocument/2006/math">
-                    <m:r>
-                      <a:rPr lang="es-ES" sz="3200" b="1" i="1" dirty="0" smtClean="0">
-                        <a:latin typeface="Cambria Math" panose="02040503050406030204" pitchFamily="18" charset="0"/>
-                        <a:ea typeface="Cambria Math" panose="02040503050406030204" pitchFamily="18" charset="0"/>
-                      </a:rPr>
-                      <m:t>∈</m:t>
-                    </m:r>
-                    <m:sSup>
-                      <m:sSupPr>
-                        <m:ctrlPr>
-                          <a:rPr lang="es-ES" sz="3200" b="1" i="1" dirty="0" smtClean="0">
-                            <a:latin typeface="Cambria Math" panose="02040503050406030204" pitchFamily="18" charset="0"/>
-                            <a:ea typeface="Cambria Math" panose="02040503050406030204" pitchFamily="18" charset="0"/>
-                          </a:rPr>
-                        </m:ctrlPr>
-                      </m:sSupPr>
-                      <m:e>
-                        <m:r>
-                          <a:rPr lang="es-ES" sz="3200" b="1" i="1" dirty="0" smtClean="0">
-                            <a:latin typeface="Cambria Math" panose="02040503050406030204" pitchFamily="18" charset="0"/>
-                            <a:ea typeface="Cambria Math" panose="02040503050406030204" pitchFamily="18" charset="0"/>
-                          </a:rPr>
-                          <m:t>ℝ</m:t>
-                        </m:r>
-                      </m:e>
-                      <m:sup>
-                        <m:r>
-                          <a:rPr lang="es-ES" sz="3200" b="1" i="1" dirty="0" smtClean="0">
-                            <a:latin typeface="Cambria Math" panose="02040503050406030204" pitchFamily="18" charset="0"/>
-                            <a:ea typeface="Cambria Math" panose="02040503050406030204" pitchFamily="18" charset="0"/>
-                          </a:rPr>
-                          <m:t>𝒏</m:t>
-                        </m:r>
-                      </m:sup>
-                    </m:sSup>
-                  </m:oMath>
-                </a14:m>
-                <a:r>
-                  <a:rPr lang="es-ES" sz="3200" b="1" i="1" dirty="0">
-                    <a:latin typeface="Cambria Math" panose="02040503050406030204" pitchFamily="18" charset="0"/>
-                    <a:ea typeface="Cambria Math" panose="02040503050406030204" pitchFamily="18" charset="0"/>
-                  </a:rPr>
-                  <a:t>, </a:t>
-                </a:r>
-                <a:r>
-                  <a:rPr lang="es-ES" sz="3200" dirty="0">
-                    <a:latin typeface="Cambria Math" panose="02040503050406030204" pitchFamily="18" charset="0"/>
-                    <a:ea typeface="Cambria Math" panose="02040503050406030204" pitchFamily="18" charset="0"/>
-                  </a:rPr>
-                  <a:t>c </a:t>
-                </a:r>
-                <a14:m>
-                  <m:oMath xmlns:m="http://schemas.openxmlformats.org/officeDocument/2006/math">
-                    <m:r>
-                      <a:rPr lang="es-ES" sz="3200" i="1" smtClean="0">
-                        <a:latin typeface="Cambria Math" panose="02040503050406030204" pitchFamily="18" charset="0"/>
-                        <a:ea typeface="Cambria Math" panose="02040503050406030204" pitchFamily="18" charset="0"/>
-                      </a:rPr>
-                      <m:t>∈</m:t>
-                    </m:r>
-                    <m:r>
-                      <a:rPr lang="es-ES" sz="3200" i="1" smtClean="0">
-                        <a:latin typeface="Cambria Math" panose="02040503050406030204" pitchFamily="18" charset="0"/>
-                        <a:ea typeface="Cambria Math" panose="02040503050406030204" pitchFamily="18" charset="0"/>
-                      </a:rPr>
-                      <m:t>ℝ</m:t>
-                    </m:r>
-                  </m:oMath>
-                </a14:m>
-                <a:endParaRPr lang="es-ES" sz="3200" b="1" i="1" dirty="0">
-                  <a:latin typeface="Cambria Math" panose="02040503050406030204" pitchFamily="18" charset="0"/>
-                  <a:ea typeface="Cambria Math" panose="02040503050406030204" pitchFamily="18" charset="0"/>
-                </a:endParaRPr>
-              </a:p>
-              <a:p>
-                <a:pPr/>
-                <a14:m>
                   <m:oMathPara xmlns:m="http://schemas.openxmlformats.org/officeDocument/2006/math">
                     <m:oMathParaPr>
-                      <m:jc m:val="left"/>
+                      <m:jc m:val="centerGroup"/>
                     </m:oMathParaPr>
                     <m:oMath xmlns:m="http://schemas.openxmlformats.org/officeDocument/2006/math">
                       <m:r>
-                        <a:rPr lang="es-ES" sz="3200" b="1" i="1" dirty="0">
-                          <a:latin typeface="Cambria Math" panose="02040503050406030204" pitchFamily="18" charset="0"/>
-                        </a:rPr>
-                        <m:t>𝒘</m:t>
-                      </m:r>
-                      <m:r>
-                        <a:rPr lang="es-ES" sz="3200" b="1" i="1" dirty="0">
+                        <a:rPr lang="es-PY" sz="3600" b="1" i="1" smtClean="0">
                           <a:latin typeface="Cambria Math" panose="02040503050406030204" pitchFamily="18" charset="0"/>
                           <a:ea typeface="Cambria Math" panose="02040503050406030204" pitchFamily="18" charset="0"/>
                         </a:rPr>
-                        <m:t>∈</m:t>
+                        <m:t>𝛂</m:t>
                       </m:r>
-                      <m:sSup>
-                        <m:sSupPr>
-                          <m:ctrlPr>
-                            <a:rPr lang="es-ES" sz="3200" b="1" i="1" dirty="0">
-                              <a:latin typeface="Cambria Math" panose="02040503050406030204" pitchFamily="18" charset="0"/>
-                              <a:ea typeface="Cambria Math" panose="02040503050406030204" pitchFamily="18" charset="0"/>
-                            </a:rPr>
-                          </m:ctrlPr>
-                        </m:sSupPr>
-                        <m:e>
-                          <m:r>
-                            <a:rPr lang="es-ES" sz="3200" b="1" i="1" dirty="0">
-                              <a:latin typeface="Cambria Math" panose="02040503050406030204" pitchFamily="18" charset="0"/>
-                              <a:ea typeface="Cambria Math" panose="02040503050406030204" pitchFamily="18" charset="0"/>
-                            </a:rPr>
-                            <m:t>ℝ</m:t>
-                          </m:r>
-                        </m:e>
-                        <m:sup>
-                          <m:r>
-                            <a:rPr lang="es-ES" sz="3200" b="1" i="1" dirty="0">
-                              <a:latin typeface="Cambria Math" panose="02040503050406030204" pitchFamily="18" charset="0"/>
-                              <a:ea typeface="Cambria Math" panose="02040503050406030204" pitchFamily="18" charset="0"/>
-                            </a:rPr>
-                            <m:t>𝒏</m:t>
-                          </m:r>
-                        </m:sup>
-                      </m:sSup>
                       <m:r>
-                        <a:rPr lang="es-ES" sz="3200" b="0" i="0" dirty="0" smtClean="0">
+                        <a:rPr lang="en-US" sz="3600" b="1" i="1" smtClean="0">
                           <a:latin typeface="Cambria Math" panose="02040503050406030204" pitchFamily="18" charset="0"/>
                           <a:ea typeface="Cambria Math" panose="02040503050406030204" pitchFamily="18" charset="0"/>
                         </a:rPr>
-                        <m:t>,</m:t>
+                        <m:t> </m:t>
                       </m:r>
                       <m:r>
                         <m:rPr>
                           <m:nor/>
                         </m:rPr>
-                        <a:rPr lang="es-ES" sz="3200" b="0" i="0" dirty="0" smtClean="0">
+                        <a:rPr lang="es-PY" sz="3600" b="1"/>
+                        <m:t>v</m:t>
+                      </m:r>
+                      <m:r>
+                        <m:rPr>
+                          <m:nor/>
+                        </m:rPr>
+                        <a:rPr lang="es-PY" sz="3600"/>
+                        <m:t> </m:t>
+                      </m:r>
+                      <m:r>
+                        <m:rPr>
+                          <m:nor/>
+                        </m:rPr>
+                        <a:rPr lang="en-US" sz="3600" b="0" i="0" smtClean="0"/>
+                        <m:t> </m:t>
+                      </m:r>
+                      <m:r>
+                        <m:rPr>
+                          <m:nor/>
+                        </m:rPr>
+                        <a:rPr lang="es-PY" sz="3600"/>
+                        <m:t>+ </m:t>
+                      </m:r>
+                      <m:r>
+                        <a:rPr lang="es-PY" sz="3600" i="1" smtClean="0">
                           <a:latin typeface="Cambria Math" panose="02040503050406030204" pitchFamily="18" charset="0"/>
                           <a:ea typeface="Cambria Math" panose="02040503050406030204" pitchFamily="18" charset="0"/>
                         </a:rPr>
-                        <m:t>d</m:t>
+                        <m:t>𝛃</m:t>
                       </m:r>
                       <m:r>
-                        <a:rPr lang="es-ES" sz="3200" i="1">
+                        <a:rPr lang="en-US" sz="3600" b="0" i="1" smtClean="0">
                           <a:latin typeface="Cambria Math" panose="02040503050406030204" pitchFamily="18" charset="0"/>
                           <a:ea typeface="Cambria Math" panose="02040503050406030204" pitchFamily="18" charset="0"/>
                         </a:rPr>
-                        <m:t>∈</m:t>
+                        <m:t> </m:t>
                       </m:r>
                       <m:r>
-                        <a:rPr lang="es-ES" sz="3200" i="1">
-                          <a:latin typeface="Cambria Math" panose="02040503050406030204" pitchFamily="18" charset="0"/>
-                          <a:ea typeface="Cambria Math" panose="02040503050406030204" pitchFamily="18" charset="0"/>
-                        </a:rPr>
-                        <m:t>ℝ</m:t>
+                        <m:rPr>
+                          <m:nor/>
+                        </m:rPr>
+                        <a:rPr lang="es-PY" sz="3600" b="1"/>
+                        <m:t>w</m:t>
+                      </m:r>
+                      <m:r>
+                        <m:rPr>
+                          <m:nor/>
+                        </m:rPr>
+                        <a:rPr lang="es-PY" sz="3600"/>
+                        <m:t> ∈ </m:t>
+                      </m:r>
+                      <m:r>
+                        <m:rPr>
+                          <m:nor/>
+                        </m:rPr>
+                        <a:rPr lang="es-PY" sz="3600"/>
+                        <m:t>V</m:t>
                       </m:r>
                     </m:oMath>
                   </m:oMathPara>
                 </a14:m>
-                <a:endParaRPr lang="es-PY" sz="3200" dirty="0"/>
+                <a:endParaRPr lang="es-PY" sz="3600" dirty="0"/>
               </a:p>
             </p:txBody>
           </p:sp>
         </mc:Choice>
-        <mc:Fallback xmlns="">
+        <mc:Fallback>
           <p:sp>
             <p:nvSpPr>
-              <p:cNvPr id="5" name="Rectángulo 4">
+              <p:cNvPr id="4" name="CuadroTexto 3">
                 <a:extLst>
                   <a:ext uri="{FF2B5EF4-FFF2-40B4-BE49-F238E27FC236}">
-                    <a16:creationId xmlns:a16="http://schemas.microsoft.com/office/drawing/2014/main" id="{A3586177-BBC9-A143-9F1F-4C8C829E42A8}"/>
+                    <a16:creationId xmlns:a16="http://schemas.microsoft.com/office/drawing/2014/main" id="{83A1DDDF-8143-1FE4-9440-BC9076F00C96}"/>
                   </a:ext>
                 </a:extLst>
               </p:cNvPr>
-              <p:cNvSpPr>
+              <p:cNvSpPr txBox="1">
                 <a:spLocks noRot="1" noChangeAspect="1" noMove="1" noResize="1" noEditPoints="1" noAdjustHandles="1" noChangeArrowheads="1" noChangeShapeType="1" noTextEdit="1"/>
               </p:cNvSpPr>
               <p:nvPr/>
             </p:nvSpPr>
             <p:spPr>
               <a:xfrm>
-                <a:off x="6228184" y="263550"/>
-                <a:ext cx="2769989" cy="1077218"/>
+                <a:off x="4681993" y="3073343"/>
+                <a:ext cx="2854948" cy="553998"/>
               </a:xfrm>
               <a:prstGeom prst="rect">
                 <a:avLst/>
@@ -5424,7 +5372,7 @@
               <a:blipFill>
                 <a:blip r:embed="rId3"/>
                 <a:stretch>
-                  <a:fillRect t="-9302"/>
+                  <a:fillRect l="-1770" t="-13333" r="-2655" b="-40000"/>
                 </a:stretch>
               </a:blipFill>
             </p:spPr>
@@ -5433,7 +5381,7 @@
               <a:lstStyle/>
               <a:p>
                 <a:r>
-                  <a:rPr lang="es-PY">
+                  <a:rPr lang="es-ES_tradnl">
                     <a:noFill/>
                   </a:rPr>
                   <a:t> </a:t>
@@ -5443,139 +5391,10 @@
           </p:sp>
         </mc:Fallback>
       </mc:AlternateContent>
-      <p:pic>
-        <p:nvPicPr>
-          <p:cNvPr id="8" name="Imagen 7">
-            <a:extLst>
-              <a:ext uri="{FF2B5EF4-FFF2-40B4-BE49-F238E27FC236}">
-                <a16:creationId xmlns:a16="http://schemas.microsoft.com/office/drawing/2014/main" id="{09E2323A-FE06-5D40-A983-19EEAFD28BE8}"/>
-              </a:ext>
-            </a:extLst>
-          </p:cNvPr>
-          <p:cNvPicPr>
-            <a:picLocks noChangeAspect="1"/>
-          </p:cNvPicPr>
-          <p:nvPr/>
-        </p:nvPicPr>
-        <p:blipFill>
-          <a:blip r:embed="rId4">
-            <a:extLst>
-              <a:ext uri="{28A0092B-C50C-407E-A947-70E740481C1C}">
-                <a14:useLocalDpi xmlns:a14="http://schemas.microsoft.com/office/drawing/2010/main" val="0"/>
-              </a:ext>
-            </a:extLst>
-          </a:blip>
-          <a:stretch>
-            <a:fillRect/>
-          </a:stretch>
-        </p:blipFill>
-        <p:spPr>
-          <a:xfrm>
-            <a:off x="543010" y="3426098"/>
-            <a:ext cx="6765294" cy="3109559"/>
-          </a:xfrm>
-          <a:prstGeom prst="rect">
-            <a:avLst/>
-          </a:prstGeom>
-        </p:spPr>
-      </p:pic>
-      <p:sp>
-        <p:nvSpPr>
-          <p:cNvPr id="35" name="1 Título">
-            <a:extLst>
-              <a:ext uri="{FF2B5EF4-FFF2-40B4-BE49-F238E27FC236}">
-                <a16:creationId xmlns:a16="http://schemas.microsoft.com/office/drawing/2014/main" id="{3EE116D9-7994-1641-8740-59620AE765FA}"/>
-              </a:ext>
-            </a:extLst>
-          </p:cNvPr>
-          <p:cNvSpPr txBox="1">
-            <a:spLocks/>
-          </p:cNvSpPr>
-          <p:nvPr/>
-        </p:nvSpPr>
-        <p:spPr>
-          <a:xfrm>
-            <a:off x="323528" y="2629654"/>
-            <a:ext cx="6120680" cy="1084982"/>
-          </a:xfrm>
-          <a:prstGeom prst="rect">
-            <a:avLst/>
-          </a:prstGeom>
-        </p:spPr>
-        <p:txBody>
-          <a:bodyPr>
-            <a:normAutofit fontScale="97500"/>
-          </a:bodyPr>
-          <a:lstStyle>
-            <a:lvl1pPr algn="l" rtl="0" eaLnBrk="1" latinLnBrk="0" hangingPunct="1">
-              <a:spcBef>
-                <a:spcPct val="0"/>
-              </a:spcBef>
-              <a:buNone/>
-              <a:defRPr kumimoji="0" sz="4000" kern="1200">
-                <a:solidFill>
-                  <a:schemeClr val="tx2"/>
-                </a:solidFill>
-                <a:latin typeface="+mj-lt"/>
-                <a:ea typeface="+mj-ea"/>
-                <a:cs typeface="+mj-cs"/>
-              </a:defRPr>
-            </a:lvl1pPr>
-          </a:lstStyle>
-          <a:p>
-            <a:r>
-              <a:rPr lang="es-PY" sz="3600" dirty="0"/>
-              <a:t>Examples</a:t>
-            </a:r>
-            <a:endParaRPr lang="es-ES" sz="3600" dirty="0"/>
-          </a:p>
-        </p:txBody>
-      </p:sp>
-      <p:sp>
-        <p:nvSpPr>
-          <p:cNvPr id="9" name="CuadroTexto 8">
-            <a:extLst>
-              <a:ext uri="{FF2B5EF4-FFF2-40B4-BE49-F238E27FC236}">
-                <a16:creationId xmlns:a16="http://schemas.microsoft.com/office/drawing/2014/main" id="{6608D834-683B-6F40-9FD1-DE7E51207FB9}"/>
-              </a:ext>
-            </a:extLst>
-          </p:cNvPr>
-          <p:cNvSpPr txBox="1"/>
-          <p:nvPr/>
-        </p:nvSpPr>
-        <p:spPr>
-          <a:xfrm>
-            <a:off x="2825379" y="2780928"/>
-            <a:ext cx="2742417" cy="646331"/>
-          </a:xfrm>
-          <a:prstGeom prst="rect">
-            <a:avLst/>
-          </a:prstGeom>
-          <a:noFill/>
-        </p:spPr>
-        <p:txBody>
-          <a:bodyPr wrap="none" rtlCol="0">
-            <a:spAutoFit/>
-          </a:bodyPr>
-          <a:lstStyle/>
-          <a:p>
-            <a:r>
-              <a:rPr lang="es-PY" dirty="0"/>
-              <a:t>P is a plane trough the (0,0,0).</a:t>
-            </a:r>
-          </a:p>
-          <a:p>
-            <a:r>
-              <a:rPr lang="es-PY" dirty="0"/>
-              <a:t>L is a line trough the (0,0,0)</a:t>
-            </a:r>
-          </a:p>
-        </p:txBody>
-      </p:sp>
     </p:spTree>
     <p:extLst>
       <p:ext uri="{BB962C8B-B14F-4D97-AF65-F5344CB8AC3E}">
-        <p14:creationId xmlns:p14="http://schemas.microsoft.com/office/powerpoint/2010/main" val="561215893"/>
+        <p14:creationId xmlns:p14="http://schemas.microsoft.com/office/powerpoint/2010/main" val="2062708160"/>
       </p:ext>
     </p:extLst>
   </p:cSld>
@@ -5618,7 +5437,284 @@
         </p:nvSpPr>
         <p:spPr>
           <a:xfrm>
-            <a:off x="142655" y="255786"/>
+            <a:off x="345876" y="20954"/>
+            <a:ext cx="8846468" cy="1084982"/>
+          </a:xfrm>
+          <a:prstGeom prst="rect">
+            <a:avLst/>
+          </a:prstGeom>
+        </p:spPr>
+        <p:txBody>
+          <a:bodyPr>
+            <a:noAutofit/>
+          </a:bodyPr>
+          <a:lstStyle>
+            <a:lvl1pPr algn="l" rtl="0" eaLnBrk="1" latinLnBrk="0" hangingPunct="1">
+              <a:spcBef>
+                <a:spcPct val="0"/>
+              </a:spcBef>
+              <a:buNone/>
+              <a:defRPr kumimoji="0" sz="4000" kern="1200">
+                <a:solidFill>
+                  <a:schemeClr val="tx2"/>
+                </a:solidFill>
+                <a:latin typeface="+mj-lt"/>
+                <a:ea typeface="+mj-ea"/>
+                <a:cs typeface="+mj-cs"/>
+              </a:defRPr>
+            </a:lvl1pPr>
+          </a:lstStyle>
+          <a:p>
+            <a:r>
+              <a:rPr lang="es-PY" dirty="0"/>
+              <a:t>Subspaces in </a:t>
+            </a:r>
+            <a:r>
+              <a:rPr lang="es-PY" dirty="0">
+                <a:latin typeface="Calibri" panose="020F0502020204030204" pitchFamily="34" charset="0"/>
+                <a:cs typeface="Calibri" panose="020F0502020204030204" pitchFamily="34" charset="0"/>
+              </a:rPr>
+              <a:t>ℝ³</a:t>
+            </a:r>
+            <a:r>
+              <a:rPr lang="es-PY" dirty="0"/>
+              <a:t> </a:t>
+            </a:r>
+            <a:endParaRPr lang="es-ES" dirty="0"/>
+          </a:p>
+        </p:txBody>
+      </p:sp>
+      <p:sp>
+        <p:nvSpPr>
+          <p:cNvPr id="4" name="CuadroTexto 3">
+            <a:extLst>
+              <a:ext uri="{FF2B5EF4-FFF2-40B4-BE49-F238E27FC236}">
+                <a16:creationId xmlns:a16="http://schemas.microsoft.com/office/drawing/2014/main" id="{901A915B-3539-E104-D73A-989EA4CEF4B7}"/>
+              </a:ext>
+            </a:extLst>
+          </p:cNvPr>
+          <p:cNvSpPr txBox="1"/>
+          <p:nvPr/>
+        </p:nvSpPr>
+        <p:spPr>
+          <a:xfrm>
+            <a:off x="8367055" y="1412776"/>
+            <a:ext cx="3561593" cy="3046988"/>
+          </a:xfrm>
+          <a:prstGeom prst="rect">
+            <a:avLst/>
+          </a:prstGeom>
+          <a:noFill/>
+        </p:spPr>
+        <p:txBody>
+          <a:bodyPr wrap="square">
+            <a:spAutoFit/>
+          </a:bodyPr>
+          <a:lstStyle/>
+          <a:p>
+            <a:pPr>
+              <a:buNone/>
+            </a:pPr>
+            <a:r>
+              <a:rPr lang="es-PY" sz="2400" dirty="0">
+                <a:latin typeface="Calibri" panose="020F0502020204030204" pitchFamily="34" charset="0"/>
+                <a:cs typeface="Calibri" panose="020F0502020204030204" pitchFamily="34" charset="0"/>
+              </a:rPr>
+              <a:t>Plane through the origin  </a:t>
+            </a:r>
+          </a:p>
+          <a:p>
+            <a:pPr>
+              <a:buNone/>
+            </a:pPr>
+            <a:r>
+              <a:rPr lang="es-PY" sz="2400" dirty="0">
+                <a:latin typeface="Calibri" panose="020F0502020204030204" pitchFamily="34" charset="0"/>
+                <a:cs typeface="Calibri" panose="020F0502020204030204" pitchFamily="34" charset="0"/>
+              </a:rPr>
+              <a:t>Line through the origin  </a:t>
+            </a:r>
+          </a:p>
+          <a:p>
+            <a:pPr>
+              <a:buNone/>
+            </a:pPr>
+            <a:endParaRPr lang="es-PY" sz="2400" dirty="0">
+              <a:latin typeface="Calibri" panose="020F0502020204030204" pitchFamily="34" charset="0"/>
+              <a:cs typeface="Calibri" panose="020F0502020204030204" pitchFamily="34" charset="0"/>
+            </a:endParaRPr>
+          </a:p>
+          <a:p>
+            <a:pPr>
+              <a:buNone/>
+            </a:pPr>
+            <a:r>
+              <a:rPr lang="es-PY" sz="2400" dirty="0">
+                <a:latin typeface="Calibri" panose="020F0502020204030204" pitchFamily="34" charset="0"/>
+                <a:cs typeface="Calibri" panose="020F0502020204030204" pitchFamily="34" charset="0"/>
+              </a:rPr>
+              <a:t>Closed under:</a:t>
+            </a:r>
+          </a:p>
+          <a:p>
+            <a:pPr>
+              <a:buNone/>
+            </a:pPr>
+            <a:r>
+              <a:rPr lang="es-PY" sz="2400" dirty="0">
+                <a:latin typeface="Calibri" panose="020F0502020204030204" pitchFamily="34" charset="0"/>
+                <a:cs typeface="Calibri" panose="020F0502020204030204" pitchFamily="34" charset="0"/>
+              </a:rPr>
+              <a:t>• addition  </a:t>
+            </a:r>
+          </a:p>
+          <a:p>
+            <a:pPr>
+              <a:buNone/>
+            </a:pPr>
+            <a:r>
+              <a:rPr lang="es-PY" sz="2400" dirty="0">
+                <a:latin typeface="Calibri" panose="020F0502020204030204" pitchFamily="34" charset="0"/>
+                <a:cs typeface="Calibri" panose="020F0502020204030204" pitchFamily="34" charset="0"/>
+              </a:rPr>
+              <a:t>• scalar multiplication  </a:t>
+            </a:r>
+          </a:p>
+          <a:p>
+            <a:pPr>
+              <a:buNone/>
+            </a:pPr>
+            <a:endParaRPr lang="es-PY" sz="2400" dirty="0">
+              <a:latin typeface="Calibri" panose="020F0502020204030204" pitchFamily="34" charset="0"/>
+              <a:cs typeface="Calibri" panose="020F0502020204030204" pitchFamily="34" charset="0"/>
+            </a:endParaRPr>
+          </a:p>
+          <a:p>
+            <a:pPr>
+              <a:buNone/>
+            </a:pPr>
+            <a:r>
+              <a:rPr lang="es-PY" sz="2400" dirty="0">
+                <a:latin typeface="Calibri" panose="020F0502020204030204" pitchFamily="34" charset="0"/>
+                <a:cs typeface="Calibri" panose="020F0502020204030204" pitchFamily="34" charset="0"/>
+              </a:rPr>
+              <a:t>⇒ Subspaces of ℝ³</a:t>
+            </a:r>
+          </a:p>
+        </p:txBody>
+      </p:sp>
+      <p:pic>
+        <p:nvPicPr>
+          <p:cNvPr id="13" name="Imagen 12">
+            <a:extLst>
+              <a:ext uri="{FF2B5EF4-FFF2-40B4-BE49-F238E27FC236}">
+                <a16:creationId xmlns:a16="http://schemas.microsoft.com/office/drawing/2014/main" id="{4B010C97-1624-436B-9E14-C7B2A3BCFD21}"/>
+              </a:ext>
+            </a:extLst>
+          </p:cNvPr>
+          <p:cNvPicPr>
+            <a:picLocks noChangeAspect="1"/>
+          </p:cNvPicPr>
+          <p:nvPr/>
+        </p:nvPicPr>
+        <p:blipFill>
+          <a:blip r:embed="rId2"/>
+          <a:stretch>
+            <a:fillRect/>
+          </a:stretch>
+        </p:blipFill>
+        <p:spPr>
+          <a:xfrm>
+            <a:off x="839433" y="879640"/>
+            <a:ext cx="5971025" cy="5533733"/>
+          </a:xfrm>
+          <a:prstGeom prst="rect">
+            <a:avLst/>
+          </a:prstGeom>
+        </p:spPr>
+      </p:pic>
+      <p:sp>
+        <p:nvSpPr>
+          <p:cNvPr id="10" name="CuadroTexto 9">
+            <a:extLst>
+              <a:ext uri="{FF2B5EF4-FFF2-40B4-BE49-F238E27FC236}">
+                <a16:creationId xmlns:a16="http://schemas.microsoft.com/office/drawing/2014/main" id="{F651BB70-1D22-A1EF-8B0B-B4EE175F0FE8}"/>
+              </a:ext>
+            </a:extLst>
+          </p:cNvPr>
+          <p:cNvSpPr txBox="1"/>
+          <p:nvPr/>
+        </p:nvSpPr>
+        <p:spPr>
+          <a:xfrm>
+            <a:off x="4123332" y="4995284"/>
+            <a:ext cx="7689339" cy="646331"/>
+          </a:xfrm>
+          <a:prstGeom prst="rect">
+            <a:avLst/>
+          </a:prstGeom>
+          <a:noFill/>
+        </p:spPr>
+        <p:txBody>
+          <a:bodyPr wrap="square">
+            <a:spAutoFit/>
+          </a:bodyPr>
+          <a:lstStyle/>
+          <a:p>
+            <a:r>
+              <a:rPr lang="es-PY" sz="3600" b="1" dirty="0"/>
+              <a:t>Closed under linear combinations</a:t>
+            </a:r>
+          </a:p>
+        </p:txBody>
+      </p:sp>
+    </p:spTree>
+    <p:extLst>
+      <p:ext uri="{BB962C8B-B14F-4D97-AF65-F5344CB8AC3E}">
+        <p14:creationId xmlns:p14="http://schemas.microsoft.com/office/powerpoint/2010/main" val="561215893"/>
+      </p:ext>
+    </p:extLst>
+  </p:cSld>
+  <p:clrMapOvr>
+    <a:masterClrMapping/>
+  </p:clrMapOvr>
+</p:sld>
+</file>
+
+<file path=ppt/slides/slide4.xml><?xml version="1.0" encoding="utf-8"?>
+<p:sld xmlns:a="http://schemas.openxmlformats.org/drawingml/2006/main" xmlns:r="http://schemas.openxmlformats.org/officeDocument/2006/relationships" xmlns:p="http://schemas.openxmlformats.org/presentationml/2006/main">
+  <p:cSld>
+    <p:spTree>
+      <p:nvGrpSpPr>
+        <p:cNvPr id="1" name=""/>
+        <p:cNvGrpSpPr/>
+        <p:nvPr/>
+      </p:nvGrpSpPr>
+      <p:grpSpPr>
+        <a:xfrm>
+          <a:off x="0" y="0"/>
+          <a:ext cx="0" cy="0"/>
+          <a:chOff x="0" y="0"/>
+          <a:chExt cx="0" cy="0"/>
+        </a:xfrm>
+      </p:grpSpPr>
+      <p:sp>
+        <p:nvSpPr>
+          <p:cNvPr id="11" name="1 Título">
+            <a:extLst>
+              <a:ext uri="{FF2B5EF4-FFF2-40B4-BE49-F238E27FC236}">
+                <a16:creationId xmlns:a16="http://schemas.microsoft.com/office/drawing/2014/main" id="{78093345-92CF-5F44-AAF2-10D38BEB5F91}"/>
+              </a:ext>
+            </a:extLst>
+          </p:cNvPr>
+          <p:cNvSpPr txBox="1">
+            <a:spLocks/>
+          </p:cNvSpPr>
+          <p:nvPr/>
+        </p:nvSpPr>
+        <p:spPr>
+          <a:xfrm>
+            <a:off x="1666656" y="255786"/>
             <a:ext cx="5365449" cy="618302"/>
           </a:xfrm>
           <a:prstGeom prst="rect">
@@ -5682,7 +5778,7 @@
         </p:blipFill>
         <p:spPr>
           <a:xfrm>
-            <a:off x="5292313" y="224752"/>
+            <a:off x="6816314" y="224752"/>
             <a:ext cx="3524701" cy="1620072"/>
           </a:xfrm>
           <a:prstGeom prst="rect">
@@ -5704,7 +5800,7 @@
         </p:nvSpPr>
         <p:spPr>
           <a:xfrm>
-            <a:off x="2411760" y="255786"/>
+            <a:off x="3935761" y="255787"/>
             <a:ext cx="2742417" cy="646331"/>
           </a:xfrm>
           <a:prstGeom prst="rect">
@@ -5731,8 +5827,8 @@
           </a:p>
         </p:txBody>
       </p:sp>
-      <mc:AlternateContent xmlns:mc="http://schemas.openxmlformats.org/markup-compatibility/2006" xmlns:a14="http://schemas.microsoft.com/office/drawing/2010/main">
-        <mc:Choice Requires="a14">
+      <mc:AlternateContent xmlns:mc="http://schemas.openxmlformats.org/markup-compatibility/2006">
+        <mc:Choice xmlns:a14="http://schemas.microsoft.com/office/drawing/2010/main" Requires="a14">
           <p:sp>
             <p:nvSpPr>
               <p:cNvPr id="4" name="CuadroTexto 3">
@@ -5747,7 +5843,7 @@
             </p:nvSpPr>
             <p:spPr>
               <a:xfrm>
-                <a:off x="260685" y="1988840"/>
+                <a:off x="1784686" y="1988840"/>
                 <a:ext cx="3824893" cy="861774"/>
               </a:xfrm>
               <a:prstGeom prst="rect">
@@ -5769,68 +5865,68 @@
                     </m:oMathParaPr>
                     <m:oMath xmlns:m="http://schemas.openxmlformats.org/officeDocument/2006/math">
                       <m:r>
-                        <a:rPr lang="es-ES" sz="2800" b="0" i="1" smtClean="0">
+                        <a:rPr lang="es-ES" sz="2800" i="1">
                           <a:latin typeface="Cambria Math" panose="02040503050406030204" pitchFamily="18" charset="0"/>
                         </a:rPr>
                         <m:t>𝑃</m:t>
                       </m:r>
                       <m:r>
-                        <a:rPr lang="es-ES" sz="2800" b="0" i="1" smtClean="0">
+                        <a:rPr lang="es-ES" sz="2800" i="1">
                           <a:latin typeface="Cambria Math" panose="02040503050406030204" pitchFamily="18" charset="0"/>
                         </a:rPr>
                         <m:t> ∪</m:t>
                       </m:r>
                       <m:r>
-                        <a:rPr lang="es-ES" sz="2800" b="0" i="1" smtClean="0">
+                        <a:rPr lang="es-ES" sz="2800" i="1">
                           <a:latin typeface="Cambria Math" panose="02040503050406030204" pitchFamily="18" charset="0"/>
                           <a:ea typeface="Cambria Math" panose="02040503050406030204" pitchFamily="18" charset="0"/>
                         </a:rPr>
                         <m:t>𝐿</m:t>
                       </m:r>
                       <m:r>
-                        <a:rPr lang="es-ES" sz="2800" b="0" i="1" smtClean="0">
+                        <a:rPr lang="es-ES" sz="2800" i="1">
                           <a:latin typeface="Cambria Math" panose="02040503050406030204" pitchFamily="18" charset="0"/>
                           <a:ea typeface="Cambria Math" panose="02040503050406030204" pitchFamily="18" charset="0"/>
                         </a:rPr>
                         <m:t>= </m:t>
                       </m:r>
                       <m:r>
-                        <a:rPr lang="es-ES" sz="2800" b="0" i="1" smtClean="0">
+                        <a:rPr lang="es-ES" sz="2800" i="1">
                           <a:latin typeface="Cambria Math" panose="02040503050406030204" pitchFamily="18" charset="0"/>
                           <a:ea typeface="Cambria Math" panose="02040503050406030204" pitchFamily="18" charset="0"/>
                         </a:rPr>
                         <m:t>𝑖𝑠</m:t>
                       </m:r>
                       <m:r>
-                        <a:rPr lang="es-ES" sz="2800" b="0" i="1" smtClean="0">
+                        <a:rPr lang="es-ES" sz="2800" i="1">
                           <a:latin typeface="Cambria Math" panose="02040503050406030204" pitchFamily="18" charset="0"/>
                           <a:ea typeface="Cambria Math" panose="02040503050406030204" pitchFamily="18" charset="0"/>
                         </a:rPr>
                         <m:t> </m:t>
                       </m:r>
                       <m:r>
-                        <a:rPr lang="es-ES" sz="2800" b="0" i="1" smtClean="0">
+                        <a:rPr lang="es-ES" sz="2800" i="1">
                           <a:latin typeface="Cambria Math" panose="02040503050406030204" pitchFamily="18" charset="0"/>
                           <a:ea typeface="Cambria Math" panose="02040503050406030204" pitchFamily="18" charset="0"/>
                         </a:rPr>
                         <m:t>𝑎</m:t>
                       </m:r>
                       <m:r>
-                        <a:rPr lang="es-ES" sz="2800" b="0" i="1" smtClean="0">
+                        <a:rPr lang="es-ES" sz="2800" i="1">
                           <a:latin typeface="Cambria Math" panose="02040503050406030204" pitchFamily="18" charset="0"/>
                           <a:ea typeface="Cambria Math" panose="02040503050406030204" pitchFamily="18" charset="0"/>
                         </a:rPr>
                         <m:t> </m:t>
                       </m:r>
                       <m:r>
-                        <a:rPr lang="es-ES" sz="2800" b="0" i="1" smtClean="0">
+                        <a:rPr lang="es-ES" sz="2800" i="1">
                           <a:latin typeface="Cambria Math" panose="02040503050406030204" pitchFamily="18" charset="0"/>
                           <a:ea typeface="Cambria Math" panose="02040503050406030204" pitchFamily="18" charset="0"/>
                         </a:rPr>
                         <m:t>𝑠𝑢𝑏𝑠𝑝𝑎𝑐𝑒</m:t>
                       </m:r>
                       <m:r>
-                        <a:rPr lang="es-ES" sz="2800" b="0" i="1" smtClean="0">
+                        <a:rPr lang="es-ES" sz="2800" i="1">
                           <a:latin typeface="Cambria Math" panose="02040503050406030204" pitchFamily="18" charset="0"/>
                           <a:ea typeface="Cambria Math" panose="02040503050406030204" pitchFamily="18" charset="0"/>
                         </a:rPr>
@@ -5839,7 +5935,7 @@
                     </m:oMath>
                   </m:oMathPara>
                 </a14:m>
-                <a:endParaRPr lang="es-ES" sz="2800" b="0" dirty="0">
+                <a:endParaRPr lang="es-ES" sz="2800" dirty="0">
                   <a:ea typeface="Cambria Math" panose="02040503050406030204" pitchFamily="18" charset="0"/>
                 </a:endParaRPr>
               </a:p>
@@ -5871,7 +5967,7 @@
                         <m:t>𝐿</m:t>
                       </m:r>
                       <m:r>
-                        <a:rPr lang="es-ES" sz="2800" b="0" i="1" smtClean="0">
+                        <a:rPr lang="es-ES" sz="2800" i="1">
                           <a:latin typeface="Cambria Math" panose="02040503050406030204" pitchFamily="18" charset="0"/>
                           <a:ea typeface="Cambria Math" panose="02040503050406030204" pitchFamily="18" charset="0"/>
                         </a:rPr>
@@ -5927,7 +6023,7 @@
             </p:txBody>
           </p:sp>
         </mc:Choice>
-        <mc:Fallback xmlns="">
+        <mc:Fallback>
           <p:sp>
             <p:nvSpPr>
               <p:cNvPr id="4" name="CuadroTexto 3">
@@ -5944,7 +6040,7 @@
             </p:nvSpPr>
             <p:spPr>
               <a:xfrm>
-                <a:off x="260685" y="1988840"/>
+                <a:off x="1784686" y="1988840"/>
                 <a:ext cx="3824893" cy="861774"/>
               </a:xfrm>
               <a:prstGeom prst="rect">
@@ -5953,7 +6049,7 @@
               <a:blipFill>
                 <a:blip r:embed="rId3"/>
                 <a:stretch>
-                  <a:fillRect l="-1656" t="-5882" r="-1325" b="-16176"/>
+                  <a:fillRect l="-1656" t="-5797" r="-1656" b="-15942"/>
                 </a:stretch>
               </a:blipFill>
             </p:spPr>
@@ -5962,7 +6058,7 @@
               <a:lstStyle/>
               <a:p>
                 <a:r>
-                  <a:rPr lang="es-PY">
+                  <a:rPr lang="es-ES_tradnl">
                     <a:noFill/>
                   </a:rPr>
                   <a:t> </a:t>
@@ -5986,7 +6082,7 @@
         </p:nvSpPr>
         <p:spPr>
           <a:xfrm>
-            <a:off x="269813" y="3159079"/>
+            <a:off x="1793814" y="3159079"/>
             <a:ext cx="4056303" cy="400110"/>
           </a:xfrm>
           <a:prstGeom prst="rect">
@@ -6007,8 +6103,8 @@
           </a:p>
         </p:txBody>
       </p:sp>
-      <mc:AlternateContent xmlns:mc="http://schemas.openxmlformats.org/markup-compatibility/2006" xmlns:a14="http://schemas.microsoft.com/office/drawing/2010/main">
-        <mc:Choice Requires="a14">
+      <mc:AlternateContent xmlns:mc="http://schemas.openxmlformats.org/markup-compatibility/2006">
+        <mc:Choice xmlns:a14="http://schemas.microsoft.com/office/drawing/2010/main" Requires="a14">
           <p:sp>
             <p:nvSpPr>
               <p:cNvPr id="7" name="CuadroTexto 6">
@@ -6023,7 +6119,7 @@
             </p:nvSpPr>
             <p:spPr>
               <a:xfrm>
-                <a:off x="269813" y="1126377"/>
+                <a:off x="1793813" y="1126377"/>
                 <a:ext cx="3401252" cy="369332"/>
               </a:xfrm>
               <a:prstGeom prst="rect">
@@ -6075,7 +6171,7 @@
             </p:txBody>
           </p:sp>
         </mc:Choice>
-        <mc:Fallback xmlns="">
+        <mc:Fallback>
           <p:sp>
             <p:nvSpPr>
               <p:cNvPr id="7" name="CuadroTexto 6">
@@ -6092,7 +6188,7 @@
             </p:nvSpPr>
             <p:spPr>
               <a:xfrm>
-                <a:off x="269813" y="1126377"/>
+                <a:off x="1793813" y="1126377"/>
                 <a:ext cx="3401252" cy="369332"/>
               </a:xfrm>
               <a:prstGeom prst="rect">
@@ -6101,7 +6197,7 @@
               <a:blipFill>
                 <a:blip r:embed="rId4"/>
                 <a:stretch>
-                  <a:fillRect t="-3333" r="-372" b="-23333"/>
+                  <a:fillRect t="-3333" r="-746" b="-26667"/>
                 </a:stretch>
               </a:blipFill>
             </p:spPr>
@@ -6110,7 +6206,7 @@
               <a:lstStyle/>
               <a:p>
                 <a:r>
-                  <a:rPr lang="es-PY">
+                  <a:rPr lang="es-ES_tradnl">
                     <a:noFill/>
                   </a:rPr>
                   <a:t> </a:t>
@@ -6120,8 +6216,8 @@
           </p:sp>
         </mc:Fallback>
       </mc:AlternateContent>
-      <mc:AlternateContent xmlns:mc="http://schemas.openxmlformats.org/markup-compatibility/2006" xmlns:a14="http://schemas.microsoft.com/office/drawing/2010/main">
-        <mc:Choice Requires="a14">
+      <mc:AlternateContent xmlns:mc="http://schemas.openxmlformats.org/markup-compatibility/2006">
+        <mc:Choice xmlns:a14="http://schemas.microsoft.com/office/drawing/2010/main" Requires="a14">
           <p:sp>
             <p:nvSpPr>
               <p:cNvPr id="10" name="CuadroTexto 9">
@@ -6136,7 +6232,7 @@
             </p:nvSpPr>
             <p:spPr>
               <a:xfrm>
-                <a:off x="269813" y="1522160"/>
+                <a:off x="1793813" y="1522160"/>
                 <a:ext cx="2848472" cy="369332"/>
               </a:xfrm>
               <a:prstGeom prst="rect">
@@ -6188,7 +6284,7 @@
             </p:txBody>
           </p:sp>
         </mc:Choice>
-        <mc:Fallback xmlns="">
+        <mc:Fallback>
           <p:sp>
             <p:nvSpPr>
               <p:cNvPr id="10" name="CuadroTexto 9">
@@ -6205,7 +6301,7 @@
             </p:nvSpPr>
             <p:spPr>
               <a:xfrm>
-                <a:off x="269813" y="1522160"/>
+                <a:off x="1793813" y="1522160"/>
                 <a:ext cx="2848472" cy="369332"/>
               </a:xfrm>
               <a:prstGeom prst="rect">
@@ -6214,7 +6310,7 @@
               <a:blipFill>
                 <a:blip r:embed="rId5"/>
                 <a:stretch>
-                  <a:fillRect t="-6897" r="-442" b="-24138"/>
+                  <a:fillRect t="-6897" r="-889" b="-27586"/>
                 </a:stretch>
               </a:blipFill>
             </p:spPr>
@@ -6223,7 +6319,7 @@
               <a:lstStyle/>
               <a:p>
                 <a:r>
-                  <a:rPr lang="es-PY">
+                  <a:rPr lang="es-ES_tradnl">
                     <a:noFill/>
                   </a:rPr>
                   <a:t> </a:t>
@@ -6233,8 +6329,8 @@
           </p:sp>
         </mc:Fallback>
       </mc:AlternateContent>
-      <mc:AlternateContent xmlns:mc="http://schemas.openxmlformats.org/markup-compatibility/2006" xmlns:a14="http://schemas.microsoft.com/office/drawing/2010/main">
-        <mc:Choice Requires="a14">
+      <mc:AlternateContent xmlns:mc="http://schemas.openxmlformats.org/markup-compatibility/2006">
+        <mc:Choice xmlns:a14="http://schemas.microsoft.com/office/drawing/2010/main" Requires="a14">
           <p:sp>
             <p:nvSpPr>
               <p:cNvPr id="14" name="CuadroTexto 13">
@@ -6249,7 +6345,7 @@
             </p:nvSpPr>
             <p:spPr>
               <a:xfrm>
-                <a:off x="4085578" y="2016869"/>
+                <a:off x="5609579" y="2016869"/>
                 <a:ext cx="772519" cy="683200"/>
               </a:xfrm>
               <a:prstGeom prst="rect">
@@ -6275,7 +6371,7 @@
                           <m:begChr m:val=""/>
                           <m:endChr m:val="}"/>
                           <m:ctrlPr>
-                            <a:rPr lang="es-PY" sz="2800" i="1" smtClean="0">
+                            <a:rPr lang="es-PY" sz="2800" i="1">
                               <a:latin typeface="Cambria Math" panose="02040503050406030204" pitchFamily="18" charset="0"/>
                             </a:rPr>
                           </m:ctrlPr>
@@ -6344,7 +6440,7 @@
             </p:txBody>
           </p:sp>
         </mc:Choice>
-        <mc:Fallback xmlns="">
+        <mc:Fallback>
           <p:sp>
             <p:nvSpPr>
               <p:cNvPr id="14" name="CuadroTexto 13">
@@ -6361,7 +6457,7 @@
             </p:nvSpPr>
             <p:spPr>
               <a:xfrm>
-                <a:off x="4085578" y="2016869"/>
+                <a:off x="5609579" y="2016869"/>
                 <a:ext cx="772519" cy="683200"/>
               </a:xfrm>
               <a:prstGeom prst="rect">
@@ -6370,7 +6466,7 @@
               <a:blipFill>
                 <a:blip r:embed="rId6"/>
                 <a:stretch>
-                  <a:fillRect l="-74194" t="-198182" r="-122581" b="-289091"/>
+                  <a:fillRect l="-74194" t="-198182" r="-124194" b="-289091"/>
                 </a:stretch>
               </a:blipFill>
             </p:spPr>
@@ -6379,7 +6475,7 @@
               <a:lstStyle/>
               <a:p>
                 <a:r>
-                  <a:rPr lang="es-PY">
+                  <a:rPr lang="es-ES_tradnl">
                     <a:noFill/>
                   </a:rPr>
                   <a:t> </a:t>
@@ -6403,7 +6499,7 @@
         </p:nvSpPr>
         <p:spPr>
           <a:xfrm>
-            <a:off x="5061411" y="2127636"/>
+            <a:off x="6585411" y="2127637"/>
             <a:ext cx="893386" cy="461665"/>
           </a:xfrm>
           <a:prstGeom prst="rect">
@@ -6428,8 +6524,8 @@
           </a:p>
         </p:txBody>
       </p:sp>
-      <mc:AlternateContent xmlns:mc="http://schemas.openxmlformats.org/markup-compatibility/2006" xmlns:a14="http://schemas.microsoft.com/office/drawing/2010/main">
-        <mc:Choice Requires="a14">
+      <mc:AlternateContent xmlns:mc="http://schemas.openxmlformats.org/markup-compatibility/2006">
+        <mc:Choice xmlns:a14="http://schemas.microsoft.com/office/drawing/2010/main" Requires="a14">
           <p:sp>
             <p:nvSpPr>
               <p:cNvPr id="17" name="CuadroTexto 16">
@@ -6444,7 +6540,7 @@
             </p:nvSpPr>
             <p:spPr>
               <a:xfrm>
-                <a:off x="2411760" y="4005064"/>
+                <a:off x="3935760" y="4005064"/>
                 <a:ext cx="5117940" cy="1077218"/>
               </a:xfrm>
               <a:prstGeom prst="rect">
@@ -6527,7 +6623,7 @@
                       <m:t> </m:t>
                     </m:r>
                     <m:r>
-                      <a:rPr lang="es-ES" sz="3200" b="0" i="1" smtClean="0">
+                      <a:rPr lang="es-ES" sz="3200" i="1">
                         <a:solidFill>
                           <a:srgbClr val="FF0000"/>
                         </a:solidFill>
@@ -6545,7 +6641,7 @@
                       <m:t>∩</m:t>
                     </m:r>
                     <m:r>
-                      <a:rPr lang="es-ES" sz="3200" b="0" i="1" smtClean="0">
+                      <a:rPr lang="es-ES" sz="3200" i="1">
                         <a:solidFill>
                           <a:srgbClr val="FF0000"/>
                         </a:solidFill>
@@ -6567,7 +6663,7 @@
             </p:txBody>
           </p:sp>
         </mc:Choice>
-        <mc:Fallback xmlns="">
+        <mc:Fallback>
           <p:sp>
             <p:nvSpPr>
               <p:cNvPr id="17" name="CuadroTexto 16">
@@ -6584,7 +6680,7 @@
             </p:nvSpPr>
             <p:spPr>
               <a:xfrm>
-                <a:off x="2411760" y="4005064"/>
+                <a:off x="3935760" y="4005064"/>
                 <a:ext cx="5117940" cy="1077218"/>
               </a:xfrm>
               <a:prstGeom prst="rect">
@@ -6593,7 +6689,7 @@
               <a:blipFill>
                 <a:blip r:embed="rId7"/>
                 <a:stretch>
-                  <a:fillRect l="-2723" t="-4651" b="-18605"/>
+                  <a:fillRect l="-2978" t="-5814" b="-18605"/>
                 </a:stretch>
               </a:blipFill>
             </p:spPr>
@@ -6602,7 +6698,7 @@
               <a:lstStyle/>
               <a:p>
                 <a:r>
-                  <a:rPr lang="es-PY">
+                  <a:rPr lang="es-ES_tradnl">
                     <a:noFill/>
                   </a:rPr>
                   <a:t> </a:t>
@@ -6625,7 +6721,7 @@
 </p:sld>
 </file>
 
-<file path=ppt/slides/slide4.xml><?xml version="1.0" encoding="utf-8"?>
+<file path=ppt/slides/slide5.xml><?xml version="1.0" encoding="utf-8"?>
 <p:sld xmlns:a="http://schemas.openxmlformats.org/drawingml/2006/main" xmlns:r="http://schemas.openxmlformats.org/officeDocument/2006/relationships" xmlns:p="http://schemas.openxmlformats.org/presentationml/2006/main">
   <p:cSld>
     <p:spTree>
@@ -6642,8 +6738,8 @@
           <a:chExt cx="0" cy="0"/>
         </a:xfrm>
       </p:grpSpPr>
-      <mc:AlternateContent xmlns:mc="http://schemas.openxmlformats.org/markup-compatibility/2006" xmlns:a14="http://schemas.microsoft.com/office/drawing/2010/main">
-        <mc:Choice Requires="a14">
+      <mc:AlternateContent xmlns:mc="http://schemas.openxmlformats.org/markup-compatibility/2006">
+        <mc:Choice xmlns:a14="http://schemas.microsoft.com/office/drawing/2010/main" Requires="a14">
           <p:sp>
             <p:nvSpPr>
               <p:cNvPr id="11" name="1 Título">
@@ -6660,7 +6756,7 @@
             </p:nvSpPr>
             <p:spPr>
               <a:xfrm>
-                <a:off x="142655" y="255786"/>
+                <a:off x="1666656" y="255786"/>
                 <a:ext cx="5365449" cy="618302"/>
               </a:xfrm>
               <a:prstGeom prst="rect">
@@ -6744,7 +6840,7 @@
             </p:txBody>
           </p:sp>
         </mc:Choice>
-        <mc:Fallback xmlns="">
+        <mc:Fallback>
           <p:sp>
             <p:nvSpPr>
               <p:cNvPr id="11" name="1 Título">
@@ -6761,7 +6857,7 @@
             </p:nvSpPr>
             <p:spPr>
               <a:xfrm>
-                <a:off x="142655" y="255786"/>
+                <a:off x="1666656" y="255786"/>
                 <a:ext cx="5365449" cy="618302"/>
               </a:xfrm>
               <a:prstGeom prst="rect">
@@ -6770,7 +6866,7 @@
               <a:blipFill>
                 <a:blip r:embed="rId2"/>
                 <a:stretch>
-                  <a:fillRect l="-2830" t="-20000" r="-2358" b="-28000"/>
+                  <a:fillRect l="-3310" t="-22449" r="-2600" b="-30612"/>
                 </a:stretch>
               </a:blipFill>
             </p:spPr>
@@ -6779,7 +6875,7 @@
               <a:lstStyle/>
               <a:p>
                 <a:r>
-                  <a:rPr lang="es-PY">
+                  <a:rPr lang="es-ES_tradnl">
                     <a:noFill/>
                   </a:rPr>
                   <a:t> </a:t>
@@ -6789,8 +6885,8 @@
           </p:sp>
         </mc:Fallback>
       </mc:AlternateContent>
-      <mc:AlternateContent xmlns:mc="http://schemas.openxmlformats.org/markup-compatibility/2006" xmlns:a14="http://schemas.microsoft.com/office/drawing/2010/main">
-        <mc:Choice Requires="a14">
+      <mc:AlternateContent xmlns:mc="http://schemas.openxmlformats.org/markup-compatibility/2006">
+        <mc:Choice xmlns:a14="http://schemas.microsoft.com/office/drawing/2010/main" Requires="a14">
           <p:sp>
             <p:nvSpPr>
               <p:cNvPr id="12" name="CuadroTexto 11">
@@ -6805,7 +6901,7 @@
             </p:nvSpPr>
             <p:spPr>
               <a:xfrm>
-                <a:off x="611560" y="874088"/>
+                <a:off x="2135560" y="874088"/>
                 <a:ext cx="6548588" cy="1077218"/>
               </a:xfrm>
               <a:prstGeom prst="rect">
@@ -6912,7 +7008,7 @@
                     <m:sSub>
                       <m:sSubPr>
                         <m:ctrlPr>
-                          <a:rPr lang="es-ES" sz="3200" i="1" smtClean="0">
+                          <a:rPr lang="es-ES" sz="3200" i="1">
                             <a:solidFill>
                               <a:srgbClr val="FF0000"/>
                             </a:solidFill>
@@ -6922,7 +7018,7 @@
                       </m:sSubPr>
                       <m:e>
                         <m:r>
-                          <a:rPr lang="es-ES" sz="3200" b="0" i="1" smtClean="0">
+                          <a:rPr lang="es-ES" sz="3200" i="1">
                             <a:solidFill>
                               <a:srgbClr val="FF0000"/>
                             </a:solidFill>
@@ -6933,7 +7029,7 @@
                       </m:e>
                       <m:sub>
                         <m:r>
-                          <a:rPr lang="es-ES" sz="3200" b="0" i="1" smtClean="0">
+                          <a:rPr lang="es-ES" sz="3200" i="1">
                             <a:solidFill>
                               <a:srgbClr val="FF0000"/>
                             </a:solidFill>
@@ -6970,7 +7066,7 @@
                     <m:d>
                       <m:dPr>
                         <m:ctrlPr>
-                          <a:rPr lang="es-PY" sz="3200" i="1" smtClean="0">
+                          <a:rPr lang="es-PY" sz="3200" i="1">
                             <a:solidFill>
                               <a:srgbClr val="FF0000"/>
                             </a:solidFill>
@@ -6980,7 +7076,7 @@
                       </m:dPr>
                       <m:e>
                         <m:r>
-                          <a:rPr lang="es-ES" sz="3200" b="0" i="1" smtClean="0">
+                          <a:rPr lang="es-ES" sz="3200" i="1">
                             <a:solidFill>
                               <a:srgbClr val="FF0000"/>
                             </a:solidFill>
@@ -7005,7 +7101,7 @@
                     <m:sSup>
                       <m:sSupPr>
                         <m:ctrlPr>
-                          <a:rPr lang="es-PY" sz="3200" i="1" smtClean="0">
+                          <a:rPr lang="es-PY" sz="3200" i="1">
                             <a:solidFill>
                               <a:srgbClr val="FF0000"/>
                             </a:solidFill>
@@ -7015,7 +7111,7 @@
                       </m:sSupPr>
                       <m:e>
                         <m:r>
-                          <a:rPr lang="es-PY" sz="3200" i="1" smtClean="0">
+                          <a:rPr lang="es-PY" sz="3200" i="1">
                             <a:solidFill>
                               <a:srgbClr val="FF0000"/>
                             </a:solidFill>
@@ -7027,7 +7123,7 @@
                       </m:e>
                       <m:sup>
                         <m:r>
-                          <a:rPr lang="es-ES" sz="3200" b="0" i="1" smtClean="0">
+                          <a:rPr lang="es-ES" sz="3200" i="1">
                             <a:solidFill>
                               <a:srgbClr val="FF0000"/>
                             </a:solidFill>
@@ -7051,7 +7147,7 @@
             </p:txBody>
           </p:sp>
         </mc:Choice>
-        <mc:Fallback xmlns="">
+        <mc:Fallback>
           <p:sp>
             <p:nvSpPr>
               <p:cNvPr id="12" name="CuadroTexto 11">
@@ -7068,7 +7164,7 @@
             </p:nvSpPr>
             <p:spPr>
               <a:xfrm>
-                <a:off x="611560" y="874088"/>
+                <a:off x="2135560" y="874088"/>
                 <a:ext cx="6548588" cy="1077218"/>
               </a:xfrm>
               <a:prstGeom prst="rect">
@@ -7077,7 +7173,7 @@
               <a:blipFill>
                 <a:blip r:embed="rId3"/>
                 <a:stretch>
-                  <a:fillRect l="-2326" t="-5814" b="-17442"/>
+                  <a:fillRect l="-2326" t="-5814" b="-18605"/>
                 </a:stretch>
               </a:blipFill>
             </p:spPr>
@@ -7086,7 +7182,7 @@
               <a:lstStyle/>
               <a:p>
                 <a:r>
-                  <a:rPr lang="es-PY">
+                  <a:rPr lang="es-ES_tradnl">
                     <a:noFill/>
                   </a:rPr>
                   <a:t> </a:t>
@@ -7096,8 +7192,8 @@
           </p:sp>
         </mc:Fallback>
       </mc:AlternateContent>
-      <mc:AlternateContent xmlns:mc="http://schemas.openxmlformats.org/markup-compatibility/2006" xmlns:a14="http://schemas.microsoft.com/office/drawing/2010/main">
-        <mc:Choice Requires="a14">
+      <mc:AlternateContent xmlns:mc="http://schemas.openxmlformats.org/markup-compatibility/2006">
+        <mc:Choice xmlns:a14="http://schemas.microsoft.com/office/drawing/2010/main" Requires="a14">
           <p:sp>
             <p:nvSpPr>
               <p:cNvPr id="2" name="CuadroTexto 1">
@@ -7112,7 +7208,7 @@
             </p:nvSpPr>
             <p:spPr>
               <a:xfrm>
-                <a:off x="611560" y="1984341"/>
+                <a:off x="2135560" y="1984341"/>
                 <a:ext cx="2044214" cy="1287212"/>
               </a:xfrm>
               <a:prstGeom prst="rect">
@@ -7134,13 +7230,13 @@
                     </m:oMathParaPr>
                     <m:oMath xmlns:m="http://schemas.openxmlformats.org/officeDocument/2006/math">
                       <m:r>
-                        <a:rPr lang="es-ES" sz="2400" b="0" i="1" smtClean="0">
+                        <a:rPr lang="es-ES" sz="2400" i="1">
                           <a:latin typeface="Cambria Math" panose="02040503050406030204" pitchFamily="18" charset="0"/>
                         </a:rPr>
                         <m:t>𝐴</m:t>
                       </m:r>
                       <m:r>
-                        <a:rPr lang="es-ES" sz="2400" b="0" i="1" smtClean="0">
+                        <a:rPr lang="es-ES" sz="2400" i="1">
                           <a:latin typeface="Cambria Math" panose="02040503050406030204" pitchFamily="18" charset="0"/>
                         </a:rPr>
                         <m:t>=</m:t>
@@ -7150,7 +7246,7 @@
                           <m:begChr m:val="["/>
                           <m:endChr m:val="]"/>
                           <m:ctrlPr>
-                            <a:rPr lang="es-ES" sz="2400" b="0" i="1" smtClean="0">
+                            <a:rPr lang="es-ES" sz="2400" i="1">
                               <a:latin typeface="Cambria Math" panose="02040503050406030204" pitchFamily="18" charset="0"/>
                             </a:rPr>
                           </m:ctrlPr>
@@ -7167,7 +7263,7 @@
                                 </m:mc>
                               </m:mcs>
                               <m:ctrlPr>
-                                <a:rPr lang="es-ES" sz="2400" b="0" i="1" smtClean="0">
+                                <a:rPr lang="es-ES" sz="2400" i="1">
                                   <a:latin typeface="Cambria Math" panose="02040503050406030204" pitchFamily="18" charset="0"/>
                                 </a:rPr>
                               </m:ctrlPr>
@@ -7185,7 +7281,7 @@
                                       </m:mc>
                                     </m:mcs>
                                     <m:ctrlPr>
-                                      <a:rPr lang="es-ES" sz="2400" b="0" i="1" smtClean="0">
+                                      <a:rPr lang="es-ES" sz="2400" i="1">
                                         <a:latin typeface="Cambria Math" panose="02040503050406030204" pitchFamily="18" charset="0"/>
                                       </a:rPr>
                                     </m:ctrlPr>
@@ -7196,7 +7292,7 @@
                                         <m:rPr>
                                           <m:brk m:alnAt="7"/>
                                         </m:rPr>
-                                        <a:rPr lang="es-ES" sz="2400" b="0" i="1" smtClean="0">
+                                        <a:rPr lang="es-ES" sz="2400" i="1">
                                           <a:latin typeface="Cambria Math" panose="02040503050406030204" pitchFamily="18" charset="0"/>
                                         </a:rPr>
                                         <m:t>1</m:t>
@@ -7204,7 +7300,7 @@
                                     </m:e>
                                     <m:e>
                                       <m:r>
-                                        <a:rPr lang="es-ES" sz="2400" b="0" i="1" smtClean="0">
+                                        <a:rPr lang="es-ES" sz="2400" i="1">
                                           <a:latin typeface="Cambria Math" panose="02040503050406030204" pitchFamily="18" charset="0"/>
                                         </a:rPr>
                                         <m:t>1</m:t>
@@ -7212,7 +7308,7 @@
                                     </m:e>
                                     <m:e>
                                       <m:r>
-                                        <a:rPr lang="es-ES" sz="2400" b="0" i="1" smtClean="0">
+                                        <a:rPr lang="es-ES" sz="2400" i="1">
                                           <a:latin typeface="Cambria Math" panose="02040503050406030204" pitchFamily="18" charset="0"/>
                                         </a:rPr>
                                         <m:t>2</m:t>
@@ -7235,7 +7331,7 @@
                                       </m:mc>
                                     </m:mcs>
                                     <m:ctrlPr>
-                                      <a:rPr lang="es-ES" sz="2400" b="0" i="1" smtClean="0">
+                                      <a:rPr lang="es-ES" sz="2400" i="1">
                                         <a:latin typeface="Cambria Math" panose="02040503050406030204" pitchFamily="18" charset="0"/>
                                       </a:rPr>
                                     </m:ctrlPr>
@@ -7246,7 +7342,7 @@
                                         <m:rPr>
                                           <m:brk m:alnAt="7"/>
                                         </m:rPr>
-                                        <a:rPr lang="es-ES" sz="2400" b="0" i="1" smtClean="0">
+                                        <a:rPr lang="es-ES" sz="2400" i="1">
                                           <a:latin typeface="Cambria Math" panose="02040503050406030204" pitchFamily="18" charset="0"/>
                                         </a:rPr>
                                         <m:t>2</m:t>
@@ -7254,7 +7350,7 @@
                                     </m:e>
                                     <m:e>
                                       <m:r>
-                                        <a:rPr lang="es-ES" sz="2400" b="0" i="1" smtClean="0">
+                                        <a:rPr lang="es-ES" sz="2400" i="1">
                                           <a:latin typeface="Cambria Math" panose="02040503050406030204" pitchFamily="18" charset="0"/>
                                         </a:rPr>
                                         <m:t>1</m:t>
@@ -7262,7 +7358,7 @@
                                     </m:e>
                                     <m:e>
                                       <m:r>
-                                        <a:rPr lang="es-ES" sz="2400" b="0" i="1" smtClean="0">
+                                        <a:rPr lang="es-ES" sz="2400" i="1">
                                           <a:latin typeface="Cambria Math" panose="02040503050406030204" pitchFamily="18" charset="0"/>
                                         </a:rPr>
                                         <m:t>3</m:t>
@@ -7285,7 +7381,7 @@
                                       </m:mc>
                                     </m:mcs>
                                     <m:ctrlPr>
-                                      <a:rPr lang="es-ES" sz="2400" b="0" i="1" smtClean="0">
+                                      <a:rPr lang="es-ES" sz="2400" i="1">
                                         <a:latin typeface="Cambria Math" panose="02040503050406030204" pitchFamily="18" charset="0"/>
                                       </a:rPr>
                                     </m:ctrlPr>
@@ -7303,7 +7399,7 @@
                                             </m:mc>
                                           </m:mcs>
                                           <m:ctrlPr>
-                                            <a:rPr lang="es-ES" sz="2400" b="0" i="1" smtClean="0">
+                                            <a:rPr lang="es-ES" sz="2400" i="1">
                                               <a:latin typeface="Cambria Math" panose="02040503050406030204" pitchFamily="18" charset="0"/>
                                             </a:rPr>
                                           </m:ctrlPr>
@@ -7314,7 +7410,7 @@
                                               <m:rPr>
                                                 <m:brk m:alnAt="7"/>
                                               </m:rPr>
-                                              <a:rPr lang="es-ES" sz="2400" b="0" i="1" smtClean="0">
+                                              <a:rPr lang="es-ES" sz="2400" i="1">
                                                 <a:latin typeface="Cambria Math" panose="02040503050406030204" pitchFamily="18" charset="0"/>
                                               </a:rPr>
                                               <m:t>3</m:t>
@@ -7322,7 +7418,7 @@
                                           </m:e>
                                           <m:e>
                                             <m:r>
-                                              <a:rPr lang="es-ES" sz="2400" b="0" i="1" smtClean="0">
+                                              <a:rPr lang="es-ES" sz="2400" i="1">
                                                 <a:latin typeface="Cambria Math" panose="02040503050406030204" pitchFamily="18" charset="0"/>
                                               </a:rPr>
                                               <m:t>1</m:t>
@@ -7330,7 +7426,7 @@
                                           </m:e>
                                           <m:e>
                                             <m:r>
-                                              <a:rPr lang="es-ES" sz="2400" b="0" i="1" smtClean="0">
+                                              <a:rPr lang="es-ES" sz="2400" i="1">
                                                 <a:latin typeface="Cambria Math" panose="02040503050406030204" pitchFamily="18" charset="0"/>
                                               </a:rPr>
                                               <m:t>4</m:t>
@@ -7353,7 +7449,7 @@
                                             </m:mc>
                                           </m:mcs>
                                           <m:ctrlPr>
-                                            <a:rPr lang="es-ES" sz="2400" b="0" i="1" smtClean="0">
+                                            <a:rPr lang="es-ES" sz="2400" i="1">
                                               <a:latin typeface="Cambria Math" panose="02040503050406030204" pitchFamily="18" charset="0"/>
                                             </a:rPr>
                                           </m:ctrlPr>
@@ -7364,7 +7460,7 @@
                                               <m:rPr>
                                                 <m:brk m:alnAt="7"/>
                                               </m:rPr>
-                                              <a:rPr lang="es-ES" sz="2400" b="0" i="1" smtClean="0">
+                                              <a:rPr lang="es-ES" sz="2400" i="1">
                                                 <a:latin typeface="Cambria Math" panose="02040503050406030204" pitchFamily="18" charset="0"/>
                                               </a:rPr>
                                               <m:t>4</m:t>
@@ -7372,7 +7468,7 @@
                                           </m:e>
                                           <m:e>
                                             <m:r>
-                                              <a:rPr lang="es-ES" sz="2400" b="0" i="1" smtClean="0">
+                                              <a:rPr lang="es-ES" sz="2400" i="1">
                                                 <a:latin typeface="Cambria Math" panose="02040503050406030204" pitchFamily="18" charset="0"/>
                                               </a:rPr>
                                               <m:t>1</m:t>
@@ -7380,7 +7476,7 @@
                                           </m:e>
                                           <m:e>
                                             <m:r>
-                                              <a:rPr lang="es-ES" sz="2400" b="0" i="1" smtClean="0">
+                                              <a:rPr lang="es-ES" sz="2400" i="1">
                                                 <a:latin typeface="Cambria Math" panose="02040503050406030204" pitchFamily="18" charset="0"/>
                                               </a:rPr>
                                               <m:t>5</m:t>
@@ -7404,7 +7500,7 @@
             </p:txBody>
           </p:sp>
         </mc:Choice>
-        <mc:Fallback xmlns="">
+        <mc:Fallback>
           <p:sp>
             <p:nvSpPr>
               <p:cNvPr id="2" name="CuadroTexto 1">
@@ -7421,7 +7517,7 @@
             </p:nvSpPr>
             <p:spPr>
               <a:xfrm>
-                <a:off x="611560" y="1984341"/>
+                <a:off x="2135560" y="1984341"/>
                 <a:ext cx="2044214" cy="1287212"/>
               </a:xfrm>
               <a:prstGeom prst="rect">
@@ -7430,7 +7526,7 @@
               <a:blipFill>
                 <a:blip r:embed="rId4"/>
                 <a:stretch>
-                  <a:fillRect l="-3106" b="-6863"/>
+                  <a:fillRect l="-3086" b="-7843"/>
                 </a:stretch>
               </a:blipFill>
             </p:spPr>
@@ -7439,7 +7535,7 @@
               <a:lstStyle/>
               <a:p>
                 <a:r>
-                  <a:rPr lang="es-PY">
+                  <a:rPr lang="es-ES_tradnl">
                     <a:noFill/>
                   </a:rPr>
                   <a:t> </a:t>
@@ -7449,8 +7545,8 @@
           </p:sp>
         </mc:Fallback>
       </mc:AlternateContent>
-      <mc:AlternateContent xmlns:mc="http://schemas.openxmlformats.org/markup-compatibility/2006" xmlns:a14="http://schemas.microsoft.com/office/drawing/2010/main">
-        <mc:Choice Requires="a14">
+      <mc:AlternateContent xmlns:mc="http://schemas.openxmlformats.org/markup-compatibility/2006">
+        <mc:Choice xmlns:a14="http://schemas.microsoft.com/office/drawing/2010/main" Requires="a14">
           <p:sp>
             <p:nvSpPr>
               <p:cNvPr id="3" name="CuadroTexto 2">
@@ -7465,7 +7561,7 @@
             </p:nvSpPr>
             <p:spPr>
               <a:xfrm>
-                <a:off x="189874" y="3387615"/>
+                <a:off x="1713874" y="3387616"/>
                 <a:ext cx="5566204" cy="830997"/>
               </a:xfrm>
               <a:prstGeom prst="rect">
@@ -7486,25 +7582,25 @@
                 <a14:m>
                   <m:oMath xmlns:m="http://schemas.openxmlformats.org/officeDocument/2006/math">
                     <m:r>
-                      <a:rPr lang="es-ES" sz="2400" b="1" i="1" smtClean="0">
+                      <a:rPr lang="es-ES" sz="2400" b="1" i="1">
                         <a:latin typeface="Cambria Math" panose="02040503050406030204" pitchFamily="18" charset="0"/>
                       </a:rPr>
                       <m:t>𝑨𝒙</m:t>
                     </m:r>
                     <m:r>
-                      <a:rPr lang="es-ES" sz="2400" b="1" i="1" smtClean="0">
+                      <a:rPr lang="es-ES" sz="2400" b="1" i="1">
                         <a:latin typeface="Cambria Math" panose="02040503050406030204" pitchFamily="18" charset="0"/>
                       </a:rPr>
                       <m:t>=</m:t>
                     </m:r>
                     <m:r>
-                      <a:rPr lang="es-ES" sz="2400" b="1" i="1" smtClean="0">
+                      <a:rPr lang="es-ES" sz="2400" b="1" i="1">
                         <a:latin typeface="Cambria Math" panose="02040503050406030204" pitchFamily="18" charset="0"/>
                       </a:rPr>
                       <m:t>𝒃</m:t>
                     </m:r>
                     <m:r>
-                      <a:rPr lang="es-ES" sz="2400" b="1" i="1" smtClean="0">
+                      <a:rPr lang="es-ES" sz="2400" b="1" i="1">
                         <a:latin typeface="Cambria Math" panose="02040503050406030204" pitchFamily="18" charset="0"/>
                       </a:rPr>
                       <m:t> </m:t>
@@ -7545,7 +7641,7 @@
             </p:txBody>
           </p:sp>
         </mc:Choice>
-        <mc:Fallback xmlns="">
+        <mc:Fallback>
           <p:sp>
             <p:nvSpPr>
               <p:cNvPr id="3" name="CuadroTexto 2">
@@ -7562,7 +7658,7 @@
             </p:nvSpPr>
             <p:spPr>
               <a:xfrm>
-                <a:off x="189874" y="3387615"/>
+                <a:off x="1713874" y="3387616"/>
                 <a:ext cx="5566204" cy="830997"/>
               </a:xfrm>
               <a:prstGeom prst="rect">
@@ -7571,7 +7667,7 @@
               <a:blipFill>
                 <a:blip r:embed="rId5"/>
                 <a:stretch>
-                  <a:fillRect l="-1595" t="-4545" r="-683" b="-15152"/>
+                  <a:fillRect l="-1591" t="-4478" r="-682" b="-14925"/>
                 </a:stretch>
               </a:blipFill>
             </p:spPr>
@@ -7580,7 +7676,7 @@
               <a:lstStyle/>
               <a:p>
                 <a:r>
-                  <a:rPr lang="es-PY">
+                  <a:rPr lang="es-ES_tradnl">
                     <a:noFill/>
                   </a:rPr>
                   <a:t> </a:t>
@@ -7590,8 +7686,8 @@
           </p:sp>
         </mc:Fallback>
       </mc:AlternateContent>
-      <mc:AlternateContent xmlns:mc="http://schemas.openxmlformats.org/markup-compatibility/2006" xmlns:a14="http://schemas.microsoft.com/office/drawing/2010/main">
-        <mc:Choice Requires="a14">
+      <mc:AlternateContent xmlns:mc="http://schemas.openxmlformats.org/markup-compatibility/2006">
+        <mc:Choice xmlns:a14="http://schemas.microsoft.com/office/drawing/2010/main" Requires="a14">
           <p:sp>
             <p:nvSpPr>
               <p:cNvPr id="5" name="Rectángulo 4">
@@ -7606,7 +7702,7 @@
             </p:nvSpPr>
             <p:spPr>
               <a:xfrm>
-                <a:off x="2864447" y="1855620"/>
+                <a:off x="4388448" y="1855620"/>
                 <a:ext cx="3846181" cy="1544654"/>
               </a:xfrm>
               <a:prstGeom prst="rect">
@@ -7622,16 +7718,10 @@
                 <a14:m>
                   <m:oMath xmlns:m="http://schemas.openxmlformats.org/officeDocument/2006/math">
                     <m:r>
-                      <a:rPr lang="es-ES" sz="2400" i="1" smtClean="0">
+                      <a:rPr lang="es-ES" sz="2400" i="1">
                         <a:latin typeface="Cambria Math" panose="02040503050406030204" pitchFamily="18" charset="0"/>
                       </a:rPr>
-                      <m:t>𝐴</m:t>
-                    </m:r>
-                    <m:r>
-                      <a:rPr lang="es-ES" sz="2400" b="0" i="1" smtClean="0">
-                        <a:latin typeface="Cambria Math" panose="02040503050406030204" pitchFamily="18" charset="0"/>
-                      </a:rPr>
-                      <m:t>𝑥</m:t>
+                      <m:t>𝐴𝑥</m:t>
                     </m:r>
                     <m:r>
                       <a:rPr lang="es-ES" sz="2400" i="1">
@@ -7930,14 +8020,14 @@
                               <m:sSub>
                                 <m:sSubPr>
                                   <m:ctrlPr>
-                                    <a:rPr lang="es-ES" sz="2400" i="1" smtClean="0">
+                                    <a:rPr lang="es-ES" sz="2400" i="1">
                                       <a:latin typeface="Cambria Math" panose="02040503050406030204" pitchFamily="18" charset="0"/>
                                     </a:rPr>
                                   </m:ctrlPr>
                                 </m:sSubPr>
                                 <m:e>
                                   <m:r>
-                                    <a:rPr lang="es-ES" sz="2400" b="0" i="1" smtClean="0">
+                                    <a:rPr lang="es-ES" sz="2400" i="1">
                                       <a:latin typeface="Cambria Math" panose="02040503050406030204" pitchFamily="18" charset="0"/>
                                     </a:rPr>
                                     <m:t>𝑥</m:t>
@@ -7945,7 +8035,7 @@
                                 </m:e>
                                 <m:sub>
                                   <m:r>
-                                    <a:rPr lang="es-ES" sz="2400" b="0" i="1" smtClean="0">
+                                    <a:rPr lang="es-ES" sz="2400" i="1">
                                       <a:latin typeface="Cambria Math" panose="02040503050406030204" pitchFamily="18" charset="0"/>
                                     </a:rPr>
                                     <m:t>1</m:t>
@@ -7974,7 +8064,7 @@
                                 </m:e>
                                 <m:sub>
                                   <m:r>
-                                    <a:rPr lang="es-ES" sz="2400" b="0" i="1" smtClean="0">
+                                    <a:rPr lang="es-ES" sz="2400" i="1">
                                       <a:latin typeface="Cambria Math" panose="02040503050406030204" pitchFamily="18" charset="0"/>
                                     </a:rPr>
                                     <m:t>2</m:t>
@@ -8003,7 +8093,7 @@
                                 </m:e>
                                 <m:sub>
                                   <m:r>
-                                    <a:rPr lang="es-ES" sz="2400" b="0" i="1" smtClean="0">
+                                    <a:rPr lang="es-ES" sz="2400" i="1">
                                       <a:latin typeface="Cambria Math" panose="02040503050406030204" pitchFamily="18" charset="0"/>
                                     </a:rPr>
                                     <m:t>3</m:t>
@@ -8038,7 +8128,7 @@
                         <m:begChr m:val="["/>
                         <m:endChr m:val="]"/>
                         <m:ctrlPr>
-                          <a:rPr lang="es-ES" sz="2400" i="1" smtClean="0">
+                          <a:rPr lang="es-ES" sz="2400" i="1">
                             <a:latin typeface="Cambria Math" panose="02040503050406030204" pitchFamily="18" charset="0"/>
                           </a:rPr>
                         </m:ctrlPr>
@@ -8055,7 +8145,7 @@
                               </m:mc>
                             </m:mcs>
                             <m:ctrlPr>
-                              <a:rPr lang="es-ES" sz="2400" i="1" smtClean="0">
+                              <a:rPr lang="es-ES" sz="2400" i="1">
                                 <a:latin typeface="Cambria Math" panose="02040503050406030204" pitchFamily="18" charset="0"/>
                               </a:rPr>
                             </m:ctrlPr>
@@ -8072,7 +8162,7 @@
                                 </m:sSubPr>
                                 <m:e>
                                   <m:r>
-                                    <a:rPr lang="es-ES" sz="2400" b="0" i="1" smtClean="0">
+                                    <a:rPr lang="es-ES" sz="2400" i="1">
                                       <a:latin typeface="Cambria Math" panose="02040503050406030204" pitchFamily="18" charset="0"/>
                                     </a:rPr>
                                     <m:t>𝑏</m:t>
@@ -8109,7 +8199,7 @@
                                 </m:e>
                                 <m:sub>
                                   <m:r>
-                                    <a:rPr lang="es-ES" sz="2400" b="0" i="1" smtClean="0">
+                                    <a:rPr lang="es-ES" sz="2400" i="1">
                                       <a:latin typeface="Cambria Math" panose="02040503050406030204" pitchFamily="18" charset="0"/>
                                     </a:rPr>
                                     <m:t>2</m:t>
@@ -8131,7 +8221,7 @@
                                     </m:mc>
                                   </m:mcs>
                                   <m:ctrlPr>
-                                    <a:rPr lang="es-ES" sz="2400" i="1" smtClean="0">
+                                    <a:rPr lang="es-ES" sz="2400" i="1">
                                       <a:latin typeface="Cambria Math" panose="02040503050406030204" pitchFamily="18" charset="0"/>
                                     </a:rPr>
                                   </m:ctrlPr>
@@ -8156,7 +8246,7 @@
                                       </m:e>
                                       <m:sub>
                                         <m:r>
-                                          <a:rPr lang="es-ES" sz="2400" b="0" i="1" smtClean="0">
+                                          <a:rPr lang="es-ES" sz="2400" i="1">
                                             <a:latin typeface="Cambria Math" panose="02040503050406030204" pitchFamily="18" charset="0"/>
                                           </a:rPr>
                                           <m:t>3</m:t>
@@ -8185,7 +8275,7 @@
                                       </m:e>
                                       <m:sub>
                                         <m:r>
-                                          <a:rPr lang="es-ES" sz="2400" b="0" i="1" smtClean="0">
+                                          <a:rPr lang="es-ES" sz="2400" i="1">
                                             <a:latin typeface="Cambria Math" panose="02040503050406030204" pitchFamily="18" charset="0"/>
                                           </a:rPr>
                                           <m:t>4</m:t>
@@ -8207,7 +8297,7 @@
             </p:txBody>
           </p:sp>
         </mc:Choice>
-        <mc:Fallback xmlns="">
+        <mc:Fallback>
           <p:sp>
             <p:nvSpPr>
               <p:cNvPr id="5" name="Rectángulo 4">
@@ -8224,7 +8314,7 @@
             </p:nvSpPr>
             <p:spPr>
               <a:xfrm>
-                <a:off x="2864447" y="1855620"/>
+                <a:off x="4388448" y="1855620"/>
                 <a:ext cx="3846181" cy="1544654"/>
               </a:xfrm>
               <a:prstGeom prst="rect">
@@ -8233,7 +8323,7 @@
               <a:blipFill>
                 <a:blip r:embed="rId6"/>
                 <a:stretch>
-                  <a:fillRect l="-330"/>
+                  <a:fillRect l="-329" b="-813"/>
                 </a:stretch>
               </a:blipFill>
             </p:spPr>
@@ -8242,7 +8332,7 @@
               <a:lstStyle/>
               <a:p>
                 <a:r>
-                  <a:rPr lang="es-PY">
+                  <a:rPr lang="es-ES_tradnl">
                     <a:noFill/>
                   </a:rPr>
                   <a:t> </a:t>
@@ -8252,8 +8342,8 @@
           </p:sp>
         </mc:Fallback>
       </mc:AlternateContent>
-      <mc:AlternateContent xmlns:mc="http://schemas.openxmlformats.org/markup-compatibility/2006" xmlns:a14="http://schemas.microsoft.com/office/drawing/2010/main">
-        <mc:Choice Requires="a14">
+      <mc:AlternateContent xmlns:mc="http://schemas.openxmlformats.org/markup-compatibility/2006">
+        <mc:Choice xmlns:a14="http://schemas.microsoft.com/office/drawing/2010/main" Requires="a14">
           <p:sp>
             <p:nvSpPr>
               <p:cNvPr id="16" name="CuadroTexto 15">
@@ -8268,7 +8358,7 @@
             </p:nvSpPr>
             <p:spPr>
               <a:xfrm>
-                <a:off x="208647" y="4474571"/>
+                <a:off x="1732648" y="4474572"/>
                 <a:ext cx="5682005" cy="830997"/>
               </a:xfrm>
               <a:prstGeom prst="rect">
@@ -8291,7 +8381,7 @@
                     <m:sSup>
                       <m:sSupPr>
                         <m:ctrlPr>
-                          <a:rPr lang="es-ES" sz="2400" b="1" i="1" smtClean="0">
+                          <a:rPr lang="es-ES" sz="2400" b="1" i="1">
                             <a:latin typeface="Cambria Math" panose="02040503050406030204" pitchFamily="18" charset="0"/>
                           </a:rPr>
                         </m:ctrlPr>
@@ -8306,7 +8396,7 @@
                       </m:e>
                       <m:sup>
                         <m:r>
-                          <a:rPr lang="es-ES" sz="2400" b="1" i="1" smtClean="0">
+                          <a:rPr lang="es-ES" sz="2400" b="1" i="1">
                             <a:latin typeface="Cambria Math" panose="02040503050406030204" pitchFamily="18" charset="0"/>
                           </a:rPr>
                           <m:t>′</m:t>
@@ -8314,7 +8404,7 @@
                       </m:sup>
                     </m:sSup>
                     <m:r>
-                      <a:rPr lang="es-ES" sz="2400" b="1" i="1" smtClean="0">
+                      <a:rPr lang="es-ES" sz="2400" b="1" i="1">
                         <a:latin typeface="Cambria Math" panose="02040503050406030204" pitchFamily="18" charset="0"/>
                       </a:rPr>
                       <m:t>𝒔</m:t>
@@ -8341,7 +8431,7 @@
             </p:txBody>
           </p:sp>
         </mc:Choice>
-        <mc:Fallback xmlns="">
+        <mc:Fallback>
           <p:sp>
             <p:nvSpPr>
               <p:cNvPr id="16" name="CuadroTexto 15">
@@ -8358,7 +8448,7 @@
             </p:nvSpPr>
             <p:spPr>
               <a:xfrm>
-                <a:off x="208647" y="4474571"/>
+                <a:off x="1732648" y="4474572"/>
                 <a:ext cx="5682005" cy="830997"/>
               </a:xfrm>
               <a:prstGeom prst="rect">
@@ -8367,7 +8457,7 @@
               <a:blipFill>
                 <a:blip r:embed="rId7"/>
                 <a:stretch>
-                  <a:fillRect l="-1336" t="-4478" r="-668" b="-13433"/>
+                  <a:fillRect l="-1563" t="-6061" r="-893" b="-15152"/>
                 </a:stretch>
               </a:blipFill>
             </p:spPr>
@@ -8376,7 +8466,7 @@
               <a:lstStyle/>
               <a:p>
                 <a:r>
-                  <a:rPr lang="es-PY">
+                  <a:rPr lang="es-ES_tradnl">
                     <a:noFill/>
                   </a:rPr>
                   <a:t> </a:t>
@@ -8386,8 +8476,8 @@
           </p:sp>
         </mc:Fallback>
       </mc:AlternateContent>
-      <mc:AlternateContent xmlns:mc="http://schemas.openxmlformats.org/markup-compatibility/2006" xmlns:a14="http://schemas.microsoft.com/office/drawing/2010/main">
-        <mc:Choice Requires="a14">
+      <mc:AlternateContent xmlns:mc="http://schemas.openxmlformats.org/markup-compatibility/2006">
+        <mc:Choice xmlns:a14="http://schemas.microsoft.com/office/drawing/2010/main" Requires="a14">
           <p:sp>
             <p:nvSpPr>
               <p:cNvPr id="13" name="Rectángulo 12">
@@ -8402,7 +8492,7 @@
             </p:nvSpPr>
             <p:spPr>
               <a:xfrm>
-                <a:off x="200870" y="4890069"/>
+                <a:off x="1724870" y="4890069"/>
                 <a:ext cx="4852098" cy="1057918"/>
               </a:xfrm>
               <a:prstGeom prst="rect">
@@ -8422,7 +8512,7 @@
                         <m:begChr m:val="["/>
                         <m:endChr m:val="]"/>
                         <m:ctrlPr>
-                          <a:rPr lang="es-ES" i="1" smtClean="0">
+                          <a:rPr lang="es-ES" i="1">
                             <a:latin typeface="Cambria Math" panose="02040503050406030204" pitchFamily="18" charset="0"/>
                           </a:rPr>
                         </m:ctrlPr>
@@ -8698,7 +8788,7 @@
                               </m:mc>
                             </m:mcs>
                             <m:ctrlPr>
-                              <a:rPr lang="es-ES" i="1" smtClean="0">
+                              <a:rPr lang="es-ES" i="1">
                                 <a:solidFill>
                                   <a:srgbClr val="FF0000"/>
                                 </a:solidFill>
@@ -8871,7 +8961,7 @@
                           <m:mr>
                             <m:e>
                               <m:r>
-                                <a:rPr lang="es-ES" b="0" i="1" smtClean="0">
+                                <a:rPr lang="es-ES" i="1">
                                   <a:latin typeface="Cambria Math" panose="02040503050406030204" pitchFamily="18" charset="0"/>
                                 </a:rPr>
                                 <m:t>1</m:t>
@@ -8881,7 +8971,7 @@
                           <m:mr>
                             <m:e>
                               <m:r>
-                                <a:rPr lang="es-ES" b="0" i="1" smtClean="0">
+                                <a:rPr lang="es-ES" i="1">
                                   <a:latin typeface="Cambria Math" panose="02040503050406030204" pitchFamily="18" charset="0"/>
                                 </a:rPr>
                                 <m:t>2</m:t>
@@ -8909,7 +8999,7 @@
                                 <m:mr>
                                   <m:e>
                                     <m:r>
-                                      <a:rPr lang="es-ES" b="0" i="1" smtClean="0">
+                                      <a:rPr lang="es-ES" i="1">
                                         <a:latin typeface="Cambria Math" panose="02040503050406030204" pitchFamily="18" charset="0"/>
                                       </a:rPr>
                                       <m:t>3</m:t>
@@ -8919,7 +9009,7 @@
                                 <m:mr>
                                   <m:e>
                                     <m:r>
-                                      <a:rPr lang="es-ES" b="0" i="1" smtClean="0">
+                                      <a:rPr lang="es-ES" i="1">
                                         <a:latin typeface="Cambria Math" panose="02040503050406030204" pitchFamily="18" charset="0"/>
                                       </a:rPr>
                                       <m:t>4</m:t>
@@ -9229,7 +9319,7 @@
                               </m:mc>
                             </m:mcs>
                             <m:ctrlPr>
-                              <a:rPr lang="es-ES" i="1" smtClean="0">
+                              <a:rPr lang="es-ES" i="1">
                                 <a:solidFill>
                                   <a:srgbClr val="FF0000"/>
                                 </a:solidFill>
@@ -9243,7 +9333,7 @@
                                 <m:rPr>
                                   <m:brk m:alnAt="7"/>
                                 </m:rPr>
-                                <a:rPr lang="es-ES" b="0" i="1" smtClean="0">
+                                <a:rPr lang="es-ES" i="1">
                                   <a:solidFill>
                                     <a:srgbClr val="FF0000"/>
                                   </a:solidFill>
@@ -9256,7 +9346,7 @@
                           <m:mr>
                             <m:e>
                               <m:r>
-                                <a:rPr lang="es-ES" b="0" i="1" smtClean="0">
+                                <a:rPr lang="es-ES" i="1">
                                   <a:solidFill>
                                     <a:srgbClr val="FF0000"/>
                                   </a:solidFill>
@@ -9269,7 +9359,7 @@
                           <m:mr>
                             <m:e>
                               <m:r>
-                                <a:rPr lang="es-ES" b="0" i="1" smtClean="0">
+                                <a:rPr lang="es-ES" i="1">
                                   <a:solidFill>
                                     <a:srgbClr val="FF0000"/>
                                   </a:solidFill>
@@ -9400,7 +9490,7 @@
             </p:txBody>
           </p:sp>
         </mc:Choice>
-        <mc:Fallback xmlns="">
+        <mc:Fallback>
           <p:sp>
             <p:nvSpPr>
               <p:cNvPr id="13" name="Rectángulo 12">
@@ -9417,7 +9507,7 @@
             </p:nvSpPr>
             <p:spPr>
               <a:xfrm>
-                <a:off x="200870" y="4890069"/>
+                <a:off x="1724870" y="4890069"/>
                 <a:ext cx="4852098" cy="1057918"/>
               </a:xfrm>
               <a:prstGeom prst="rect">
@@ -9426,7 +9516,7 @@
               <a:blipFill>
                 <a:blip r:embed="rId8"/>
                 <a:stretch>
-                  <a:fillRect b="-2381"/>
+                  <a:fillRect b="-2353"/>
                 </a:stretch>
               </a:blipFill>
             </p:spPr>
@@ -9435,7 +9525,7 @@
               <a:lstStyle/>
               <a:p>
                 <a:r>
-                  <a:rPr lang="es-PY">
+                  <a:rPr lang="es-ES_tradnl">
                     <a:noFill/>
                   </a:rPr>
                   <a:t> </a:t>
@@ -9459,7 +9549,7 @@
         </p:nvSpPr>
         <p:spPr>
           <a:xfrm>
-            <a:off x="363799" y="6067197"/>
+            <a:off x="1887800" y="6067197"/>
             <a:ext cx="4583947" cy="369332"/>
           </a:xfrm>
           <a:prstGeom prst="rect">
@@ -9480,8 +9570,8 @@
           </a:p>
         </p:txBody>
       </p:sp>
-      <mc:AlternateContent xmlns:mc="http://schemas.openxmlformats.org/markup-compatibility/2006" xmlns:a14="http://schemas.microsoft.com/office/drawing/2010/main">
-        <mc:Choice Requires="a14">
+      <mc:AlternateContent xmlns:mc="http://schemas.openxmlformats.org/markup-compatibility/2006">
+        <mc:Choice xmlns:a14="http://schemas.microsoft.com/office/drawing/2010/main" Requires="a14">
           <p:sp>
             <p:nvSpPr>
               <p:cNvPr id="20" name="Rectángulo 19">
@@ -9496,7 +9586,7 @@
             </p:nvSpPr>
             <p:spPr>
               <a:xfrm>
-                <a:off x="6156176" y="3518042"/>
+                <a:off x="7680176" y="3518042"/>
                 <a:ext cx="2289216" cy="369332"/>
               </a:xfrm>
               <a:prstGeom prst="rect">
@@ -9515,7 +9605,7 @@
                       <m:rPr>
                         <m:sty m:val="p"/>
                       </m:rPr>
-                      <a:rPr lang="es-ES" smtClean="0">
+                      <a:rPr lang="es-ES">
                         <a:solidFill>
                           <a:srgbClr val="FF0000"/>
                         </a:solidFill>
@@ -9583,7 +9673,7 @@
                       </m:e>
                       <m:sup>
                         <m:r>
-                          <a:rPr lang="es-ES" b="0" i="1" smtClean="0">
+                          <a:rPr lang="es-ES" i="1">
                             <a:solidFill>
                               <a:srgbClr val="FF0000"/>
                             </a:solidFill>
@@ -9601,7 +9691,7 @@
             </p:txBody>
           </p:sp>
         </mc:Choice>
-        <mc:Fallback xmlns="">
+        <mc:Fallback>
           <p:sp>
             <p:nvSpPr>
               <p:cNvPr id="20" name="Rectángulo 19">
@@ -9618,7 +9708,7 @@
             </p:nvSpPr>
             <p:spPr>
               <a:xfrm>
-                <a:off x="6156176" y="3518042"/>
+                <a:off x="7680176" y="3518042"/>
                 <a:ext cx="2289216" cy="369332"/>
               </a:xfrm>
               <a:prstGeom prst="rect">
@@ -9627,7 +9717,7 @@
               <a:blipFill>
                 <a:blip r:embed="rId9"/>
                 <a:stretch>
-                  <a:fillRect b="-23333"/>
+                  <a:fillRect b="-22581"/>
                 </a:stretch>
               </a:blipFill>
             </p:spPr>
@@ -9636,7 +9726,7 @@
               <a:lstStyle/>
               <a:p>
                 <a:r>
-                  <a:rPr lang="es-PY">
+                  <a:rPr lang="es-ES_tradnl">
                     <a:noFill/>
                   </a:rPr>
                   <a:t> </a:t>
@@ -9659,7 +9749,7 @@
 </p:sld>
 </file>
 
-<file path=ppt/slides/slide5.xml><?xml version="1.0" encoding="utf-8"?>
+<file path=ppt/slides/slide6.xml><?xml version="1.0" encoding="utf-8"?>
 <p:sld xmlns:a="http://schemas.openxmlformats.org/drawingml/2006/main" xmlns:r="http://schemas.openxmlformats.org/officeDocument/2006/relationships" xmlns:p="http://schemas.openxmlformats.org/presentationml/2006/main">
   <p:cSld>
     <p:spTree>
@@ -9676,8 +9766,8 @@
           <a:chExt cx="0" cy="0"/>
         </a:xfrm>
       </p:grpSpPr>
-      <mc:AlternateContent xmlns:mc="http://schemas.openxmlformats.org/markup-compatibility/2006" xmlns:a14="http://schemas.microsoft.com/office/drawing/2010/main">
-        <mc:Choice Requires="a14">
+      <mc:AlternateContent xmlns:mc="http://schemas.openxmlformats.org/markup-compatibility/2006">
+        <mc:Choice xmlns:a14="http://schemas.microsoft.com/office/drawing/2010/main" Requires="a14">
           <p:sp>
             <p:nvSpPr>
               <p:cNvPr id="11" name="1 Título">
@@ -9694,7 +9784,7 @@
             </p:nvSpPr>
             <p:spPr>
               <a:xfrm>
-                <a:off x="142655" y="255786"/>
+                <a:off x="1666656" y="255786"/>
                 <a:ext cx="5365449" cy="618302"/>
               </a:xfrm>
               <a:prstGeom prst="rect">
@@ -9742,7 +9832,7 @@
                       <m:t>→</m:t>
                     </m:r>
                     <m:r>
-                      <a:rPr lang="es-ES" sz="3600" b="0" i="1" dirty="0" smtClean="0">
+                      <a:rPr lang="es-ES" sz="3600" i="1" dirty="0">
                         <a:latin typeface="Cambria Math" panose="02040503050406030204" pitchFamily="18" charset="0"/>
                         <a:ea typeface="Cambria Math" panose="02040503050406030204" pitchFamily="18" charset="0"/>
                       </a:rPr>
@@ -9778,7 +9868,7 @@
             </p:txBody>
           </p:sp>
         </mc:Choice>
-        <mc:Fallback xmlns="">
+        <mc:Fallback>
           <p:sp>
             <p:nvSpPr>
               <p:cNvPr id="11" name="1 Título">
@@ -9795,7 +9885,7 @@
             </p:nvSpPr>
             <p:spPr>
               <a:xfrm>
-                <a:off x="142655" y="255786"/>
+                <a:off x="1666656" y="255786"/>
                 <a:ext cx="5365449" cy="618302"/>
               </a:xfrm>
               <a:prstGeom prst="rect">
@@ -9804,7 +9894,7 @@
               <a:blipFill>
                 <a:blip r:embed="rId2"/>
                 <a:stretch>
-                  <a:fillRect l="-2830" t="-20000" b="-28000"/>
+                  <a:fillRect l="-3310" t="-22449" b="-30612"/>
                 </a:stretch>
               </a:blipFill>
             </p:spPr>
@@ -9813,7 +9903,7 @@
               <a:lstStyle/>
               <a:p>
                 <a:r>
-                  <a:rPr lang="es-PY">
+                  <a:rPr lang="es-ES_tradnl">
                     <a:noFill/>
                   </a:rPr>
                   <a:t> </a:t>
@@ -9823,8 +9913,8 @@
           </p:sp>
         </mc:Fallback>
       </mc:AlternateContent>
-      <mc:AlternateContent xmlns:mc="http://schemas.openxmlformats.org/markup-compatibility/2006" xmlns:a14="http://schemas.microsoft.com/office/drawing/2010/main">
-        <mc:Choice Requires="a14">
+      <mc:AlternateContent xmlns:mc="http://schemas.openxmlformats.org/markup-compatibility/2006">
+        <mc:Choice xmlns:a14="http://schemas.microsoft.com/office/drawing/2010/main" Requires="a14">
           <p:sp>
             <p:nvSpPr>
               <p:cNvPr id="12" name="CuadroTexto 11">
@@ -9839,7 +9929,7 @@
             </p:nvSpPr>
             <p:spPr>
               <a:xfrm>
-                <a:off x="611560" y="874088"/>
+                <a:off x="2135561" y="874089"/>
                 <a:ext cx="6304931" cy="1119409"/>
               </a:xfrm>
               <a:prstGeom prst="rect">
@@ -9905,7 +9995,7 @@
                       <m:t>𝐴</m:t>
                     </m:r>
                     <m:r>
-                      <a:rPr lang="es-ES" sz="3200" b="0" i="1" smtClean="0">
+                      <a:rPr lang="es-ES" sz="3200" i="1">
                         <a:solidFill>
                           <a:srgbClr val="FF0000"/>
                         </a:solidFill>
@@ -9914,7 +10004,7 @@
                       <m:t>𝑥</m:t>
                     </m:r>
                     <m:r>
-                      <a:rPr lang="es-ES" sz="3200" b="0" i="1" smtClean="0">
+                      <a:rPr lang="es-ES" sz="3200" i="1">
                         <a:solidFill>
                           <a:srgbClr val="FF0000"/>
                         </a:solidFill>
@@ -9955,7 +10045,7 @@
                     <m:sSub>
                       <m:sSubPr>
                         <m:ctrlPr>
-                          <a:rPr lang="es-ES" sz="3200" i="1" smtClean="0">
+                          <a:rPr lang="es-ES" sz="3200" i="1">
                             <a:solidFill>
                               <a:srgbClr val="FF0000"/>
                             </a:solidFill>
@@ -9965,7 +10055,7 @@
                       </m:sSubPr>
                       <m:e>
                         <m:r>
-                          <a:rPr lang="es-ES" sz="3200" b="0" i="1" smtClean="0">
+                          <a:rPr lang="es-ES" sz="3200" i="1">
                             <a:solidFill>
                               <a:srgbClr val="FF0000"/>
                             </a:solidFill>
@@ -9976,7 +10066,7 @@
                       </m:e>
                       <m:sub>
                         <m:r>
-                          <a:rPr lang="es-ES" sz="3200" b="0" i="1" smtClean="0">
+                          <a:rPr lang="es-ES" sz="3200" i="1">
                             <a:solidFill>
                               <a:srgbClr val="FF0000"/>
                             </a:solidFill>
@@ -10002,7 +10092,7 @@
                       <m:rPr>
                         <m:sty m:val="p"/>
                       </m:rPr>
-                      <a:rPr lang="es-ES" sz="3200" dirty="0" smtClean="0">
+                      <a:rPr lang="es-ES" sz="3200" dirty="0">
                         <a:solidFill>
                           <a:srgbClr val="FF0000"/>
                         </a:solidFill>
@@ -10013,7 +10103,7 @@
                     <m:d>
                       <m:dPr>
                         <m:ctrlPr>
-                          <a:rPr lang="es-PY" sz="3200" i="1" smtClean="0">
+                          <a:rPr lang="es-PY" sz="3200" i="1">
                             <a:solidFill>
                               <a:srgbClr val="FF0000"/>
                             </a:solidFill>
@@ -10023,7 +10113,7 @@
                       </m:dPr>
                       <m:e>
                         <m:r>
-                          <a:rPr lang="es-ES" sz="3200" b="0" i="1" smtClean="0">
+                          <a:rPr lang="es-ES" sz="3200" i="1">
                             <a:solidFill>
                               <a:srgbClr val="FF0000"/>
                             </a:solidFill>
@@ -10048,7 +10138,7 @@
                     <m:sSup>
                       <m:sSupPr>
                         <m:ctrlPr>
-                          <a:rPr lang="es-PY" sz="3200" i="1" smtClean="0">
+                          <a:rPr lang="es-PY" sz="3200" i="1">
                             <a:solidFill>
                               <a:srgbClr val="FF0000"/>
                             </a:solidFill>
@@ -10058,7 +10148,7 @@
                       </m:sSupPr>
                       <m:e>
                         <m:r>
-                          <a:rPr lang="es-PY" sz="3200" i="1" smtClean="0">
+                          <a:rPr lang="es-PY" sz="3200" i="1">
                             <a:solidFill>
                               <a:srgbClr val="FF0000"/>
                             </a:solidFill>
@@ -10070,7 +10160,7 @@
                       </m:e>
                       <m:sup>
                         <m:r>
-                          <a:rPr lang="es-ES" sz="3200" b="0" i="1" smtClean="0">
+                          <a:rPr lang="es-ES" sz="3200" i="1">
                             <a:solidFill>
                               <a:srgbClr val="FF0000"/>
                             </a:solidFill>
@@ -10094,7 +10184,7 @@
             </p:txBody>
           </p:sp>
         </mc:Choice>
-        <mc:Fallback xmlns="">
+        <mc:Fallback>
           <p:sp>
             <p:nvSpPr>
               <p:cNvPr id="12" name="CuadroTexto 11">
@@ -10111,7 +10201,7 @@
             </p:nvSpPr>
             <p:spPr>
               <a:xfrm>
-                <a:off x="611560" y="874088"/>
+                <a:off x="2135561" y="874089"/>
                 <a:ext cx="6304931" cy="1119409"/>
               </a:xfrm>
               <a:prstGeom prst="rect">
@@ -10120,7 +10210,7 @@
               <a:blipFill>
                 <a:blip r:embed="rId3"/>
                 <a:stretch>
-                  <a:fillRect l="-2414" t="-5618" b="-13483"/>
+                  <a:fillRect l="-2414" t="-5618" b="-14607"/>
                 </a:stretch>
               </a:blipFill>
             </p:spPr>
@@ -10129,7 +10219,7 @@
               <a:lstStyle/>
               <a:p>
                 <a:r>
-                  <a:rPr lang="es-PY">
+                  <a:rPr lang="es-ES_tradnl">
                     <a:noFill/>
                   </a:rPr>
                   <a:t> </a:t>
@@ -10139,8 +10229,8 @@
           </p:sp>
         </mc:Fallback>
       </mc:AlternateContent>
-      <mc:AlternateContent xmlns:mc="http://schemas.openxmlformats.org/markup-compatibility/2006" xmlns:a14="http://schemas.microsoft.com/office/drawing/2010/main">
-        <mc:Choice Requires="a14">
+      <mc:AlternateContent xmlns:mc="http://schemas.openxmlformats.org/markup-compatibility/2006">
+        <mc:Choice xmlns:a14="http://schemas.microsoft.com/office/drawing/2010/main" Requires="a14">
           <p:sp>
             <p:nvSpPr>
               <p:cNvPr id="5" name="Rectángulo 4">
@@ -10155,7 +10245,7 @@
             </p:nvSpPr>
             <p:spPr>
               <a:xfrm>
-                <a:off x="208647" y="1892627"/>
+                <a:off x="1732647" y="1892628"/>
                 <a:ext cx="3709926" cy="1379545"/>
               </a:xfrm>
               <a:prstGeom prst="rect">
@@ -10171,16 +10261,10 @@
                 <a14:m>
                   <m:oMath xmlns:m="http://schemas.openxmlformats.org/officeDocument/2006/math">
                     <m:r>
-                      <a:rPr lang="es-ES" sz="2400" i="1" smtClean="0">
+                      <a:rPr lang="es-ES" sz="2400" i="1">
                         <a:latin typeface="Cambria Math" panose="02040503050406030204" pitchFamily="18" charset="0"/>
                       </a:rPr>
-                      <m:t>𝐴</m:t>
-                    </m:r>
-                    <m:r>
-                      <a:rPr lang="es-ES" sz="2400" b="0" i="1" smtClean="0">
-                        <a:latin typeface="Cambria Math" panose="02040503050406030204" pitchFamily="18" charset="0"/>
-                      </a:rPr>
-                      <m:t>𝑥</m:t>
+                      <m:t>𝐴𝑥</m:t>
                     </m:r>
                     <m:r>
                       <a:rPr lang="es-ES" sz="2400" i="1">
@@ -10479,14 +10563,14 @@
                               <m:sSub>
                                 <m:sSubPr>
                                   <m:ctrlPr>
-                                    <a:rPr lang="es-ES" sz="2400" i="1" smtClean="0">
+                                    <a:rPr lang="es-ES" sz="2400" i="1">
                                       <a:latin typeface="Cambria Math" panose="02040503050406030204" pitchFamily="18" charset="0"/>
                                     </a:rPr>
                                   </m:ctrlPr>
                                 </m:sSubPr>
                                 <m:e>
                                   <m:r>
-                                    <a:rPr lang="es-ES" sz="2400" b="0" i="1" smtClean="0">
+                                    <a:rPr lang="es-ES" sz="2400" i="1">
                                       <a:latin typeface="Cambria Math" panose="02040503050406030204" pitchFamily="18" charset="0"/>
                                     </a:rPr>
                                     <m:t>𝑥</m:t>
@@ -10494,7 +10578,7 @@
                                 </m:e>
                                 <m:sub>
                                   <m:r>
-                                    <a:rPr lang="es-ES" sz="2400" b="0" i="1" smtClean="0">
+                                    <a:rPr lang="es-ES" sz="2400" i="1">
                                       <a:latin typeface="Cambria Math" panose="02040503050406030204" pitchFamily="18" charset="0"/>
                                     </a:rPr>
                                     <m:t>1</m:t>
@@ -10523,7 +10607,7 @@
                                 </m:e>
                                 <m:sub>
                                   <m:r>
-                                    <a:rPr lang="es-ES" sz="2400" b="0" i="1" smtClean="0">
+                                    <a:rPr lang="es-ES" sz="2400" i="1">
                                       <a:latin typeface="Cambria Math" panose="02040503050406030204" pitchFamily="18" charset="0"/>
                                     </a:rPr>
                                     <m:t>2</m:t>
@@ -10552,7 +10636,7 @@
                                 </m:e>
                                 <m:sub>
                                   <m:r>
-                                    <a:rPr lang="es-ES" sz="2400" b="0" i="1" smtClean="0">
+                                    <a:rPr lang="es-ES" sz="2400" i="1">
                                       <a:latin typeface="Cambria Math" panose="02040503050406030204" pitchFamily="18" charset="0"/>
                                     </a:rPr>
                                     <m:t>3</m:t>
@@ -10587,7 +10671,7 @@
                         <m:begChr m:val="["/>
                         <m:endChr m:val="]"/>
                         <m:ctrlPr>
-                          <a:rPr lang="es-ES" sz="2400" i="1" smtClean="0">
+                          <a:rPr lang="es-ES" sz="2400" i="1">
                             <a:latin typeface="Cambria Math" panose="02040503050406030204" pitchFamily="18" charset="0"/>
                           </a:rPr>
                         </m:ctrlPr>
@@ -10604,7 +10688,7 @@
                               </m:mc>
                             </m:mcs>
                             <m:ctrlPr>
-                              <a:rPr lang="es-ES" sz="2400" i="1" smtClean="0">
+                              <a:rPr lang="es-ES" sz="2400" i="1">
                                 <a:latin typeface="Cambria Math" panose="02040503050406030204" pitchFamily="18" charset="0"/>
                               </a:rPr>
                             </m:ctrlPr>
@@ -10615,7 +10699,7 @@
                                 <m:rPr>
                                   <m:brk m:alnAt="7"/>
                                 </m:rPr>
-                                <a:rPr lang="es-ES" sz="2400" b="0" i="1" smtClean="0">
+                                <a:rPr lang="es-ES" sz="2400" i="1">
                                   <a:latin typeface="Cambria Math" panose="02040503050406030204" pitchFamily="18" charset="0"/>
                                 </a:rPr>
                                 <m:t>0</m:t>
@@ -10625,7 +10709,7 @@
                           <m:mr>
                             <m:e>
                               <m:r>
-                                <a:rPr lang="es-ES" sz="2400" i="1" smtClean="0">
+                                <a:rPr lang="es-ES" sz="2400" i="1">
                                   <a:latin typeface="Cambria Math" panose="02040503050406030204" pitchFamily="18" charset="0"/>
                                 </a:rPr>
                                 <m:t>0</m:t>
@@ -10645,7 +10729,7 @@
                                     </m:mc>
                                   </m:mcs>
                                   <m:ctrlPr>
-                                    <a:rPr lang="es-ES" sz="2400" i="1" smtClean="0">
+                                    <a:rPr lang="es-ES" sz="2400" i="1">
                                       <a:latin typeface="Cambria Math" panose="02040503050406030204" pitchFamily="18" charset="0"/>
                                     </a:rPr>
                                   </m:ctrlPr>
@@ -10656,7 +10740,7 @@
                                       <m:rPr>
                                         <m:brk m:alnAt="7"/>
                                       </m:rPr>
-                                      <a:rPr lang="es-ES" sz="2400" b="0" i="1" smtClean="0">
+                                      <a:rPr lang="es-ES" sz="2400" i="1">
                                         <a:latin typeface="Cambria Math" panose="02040503050406030204" pitchFamily="18" charset="0"/>
                                       </a:rPr>
                                       <m:t>0</m:t>
@@ -10666,7 +10750,7 @@
                                 <m:mr>
                                   <m:e>
                                     <m:r>
-                                      <a:rPr lang="es-ES" sz="2400" i="1" smtClean="0">
+                                      <a:rPr lang="es-ES" sz="2400" i="1">
                                         <a:latin typeface="Cambria Math" panose="02040503050406030204" pitchFamily="18" charset="0"/>
                                       </a:rPr>
                                       <m:t>0</m:t>
@@ -10686,7 +10770,7 @@
             </p:txBody>
           </p:sp>
         </mc:Choice>
-        <mc:Fallback xmlns="">
+        <mc:Fallback>
           <p:sp>
             <p:nvSpPr>
               <p:cNvPr id="5" name="Rectángulo 4">
@@ -10703,7 +10787,7 @@
             </p:nvSpPr>
             <p:spPr>
               <a:xfrm>
-                <a:off x="208647" y="1892627"/>
+                <a:off x="1732647" y="1892628"/>
                 <a:ext cx="3709926" cy="1379545"/>
               </a:xfrm>
               <a:prstGeom prst="rect">
@@ -10712,7 +10796,7 @@
               <a:blipFill>
                 <a:blip r:embed="rId4"/>
                 <a:stretch>
-                  <a:fillRect b="-2727"/>
+                  <a:fillRect l="-341" b="-3636"/>
                 </a:stretch>
               </a:blipFill>
             </p:spPr>
@@ -10721,7 +10805,7 @@
               <a:lstStyle/>
               <a:p>
                 <a:r>
-                  <a:rPr lang="es-PY">
+                  <a:rPr lang="es-ES_tradnl">
                     <a:noFill/>
                   </a:rPr>
                   <a:t> </a:t>
@@ -10731,8 +10815,8 @@
           </p:sp>
         </mc:Fallback>
       </mc:AlternateContent>
-      <mc:AlternateContent xmlns:mc="http://schemas.openxmlformats.org/markup-compatibility/2006" xmlns:a14="http://schemas.microsoft.com/office/drawing/2010/main">
-        <mc:Choice Requires="a14">
+      <mc:AlternateContent xmlns:mc="http://schemas.openxmlformats.org/markup-compatibility/2006">
+        <mc:Choice xmlns:a14="http://schemas.microsoft.com/office/drawing/2010/main" Requires="a14">
           <p:sp>
             <p:nvSpPr>
               <p:cNvPr id="13" name="Rectángulo 12">
@@ -10747,7 +10831,7 @@
             </p:nvSpPr>
             <p:spPr>
               <a:xfrm>
-                <a:off x="248927" y="3434131"/>
+                <a:off x="1772927" y="3434131"/>
                 <a:ext cx="4813690" cy="1057918"/>
               </a:xfrm>
               <a:prstGeom prst="rect">
@@ -10767,7 +10851,7 @@
                         <m:begChr m:val="["/>
                         <m:endChr m:val="]"/>
                         <m:ctrlPr>
-                          <a:rPr lang="es-ES" i="1" smtClean="0">
+                          <a:rPr lang="es-ES" i="1">
                             <a:latin typeface="Cambria Math" panose="02040503050406030204" pitchFamily="18" charset="0"/>
                           </a:rPr>
                         </m:ctrlPr>
@@ -11043,7 +11127,7 @@
                               </m:mc>
                             </m:mcs>
                             <m:ctrlPr>
-                              <a:rPr lang="es-ES" i="1" smtClean="0">
+                              <a:rPr lang="es-ES" i="1">
                                 <a:solidFill>
                                   <a:srgbClr val="FF0000"/>
                                 </a:solidFill>
@@ -11219,7 +11303,7 @@
                                 <m:rPr>
                                   <m:brk m:alnAt="7"/>
                                 </m:rPr>
-                                <a:rPr lang="es-ES" b="0" i="1" smtClean="0">
+                                <a:rPr lang="es-ES" i="1">
                                   <a:latin typeface="Cambria Math" panose="02040503050406030204" pitchFamily="18" charset="0"/>
                                 </a:rPr>
                                 <m:t>0</m:t>
@@ -11229,7 +11313,7 @@
                           <m:mr>
                             <m:e>
                               <m:r>
-                                <a:rPr lang="es-ES" b="0" i="1" smtClean="0">
+                                <a:rPr lang="es-ES" i="1">
                                   <a:latin typeface="Cambria Math" panose="02040503050406030204" pitchFamily="18" charset="0"/>
                                 </a:rPr>
                                 <m:t>0</m:t>
@@ -11260,7 +11344,7 @@
                                       <m:rPr>
                                         <m:brk m:alnAt="7"/>
                                       </m:rPr>
-                                      <a:rPr lang="es-ES" b="0" i="1" smtClean="0">
+                                      <a:rPr lang="es-ES" i="1">
                                         <a:latin typeface="Cambria Math" panose="02040503050406030204" pitchFamily="18" charset="0"/>
                                       </a:rPr>
                                       <m:t>0</m:t>
@@ -11270,7 +11354,7 @@
                                 <m:mr>
                                   <m:e>
                                     <m:r>
-                                      <a:rPr lang="es-ES" b="0" i="1" smtClean="0">
+                                      <a:rPr lang="es-ES" i="1">
                                         <a:latin typeface="Cambria Math" panose="02040503050406030204" pitchFamily="18" charset="0"/>
                                       </a:rPr>
                                       <m:t>0</m:t>
@@ -11305,7 +11389,7 @@
                         <m:begChr m:val="["/>
                         <m:endChr m:val="]"/>
                         <m:ctrlPr>
-                          <a:rPr lang="es-ES" i="1" smtClean="0">
+                          <a:rPr lang="es-ES" i="1">
                             <a:latin typeface="Cambria Math" panose="02040503050406030204" pitchFamily="18" charset="0"/>
                           </a:rPr>
                         </m:ctrlPr>
@@ -11580,7 +11664,7 @@
                               </m:mc>
                             </m:mcs>
                             <m:ctrlPr>
-                              <a:rPr lang="es-ES" i="1" smtClean="0">
+                              <a:rPr lang="es-ES" i="1">
                                 <a:solidFill>
                                   <a:srgbClr val="FF0000"/>
                                 </a:solidFill>
@@ -11594,7 +11678,7 @@
                                 <m:rPr>
                                   <m:brk m:alnAt="7"/>
                                 </m:rPr>
-                                <a:rPr lang="es-ES" b="0" i="1" smtClean="0">
+                                <a:rPr lang="es-ES" i="1">
                                   <a:solidFill>
                                     <a:srgbClr val="FF0000"/>
                                   </a:solidFill>
@@ -11603,7 +11687,7 @@
                                 <m:t>+</m:t>
                               </m:r>
                               <m:r>
-                                <a:rPr lang="es-ES" b="0" i="1" smtClean="0">
+                                <a:rPr lang="es-ES" i="1">
                                   <a:solidFill>
                                     <a:srgbClr val="FF0000"/>
                                   </a:solidFill>
@@ -11616,7 +11700,7 @@
                           <m:mr>
                             <m:e>
                               <m:r>
-                                <a:rPr lang="es-ES" b="0" i="1" smtClean="0">
+                                <a:rPr lang="es-ES" i="1">
                                   <a:solidFill>
                                     <a:srgbClr val="FF0000"/>
                                   </a:solidFill>
@@ -11629,7 +11713,7 @@
                           <m:mr>
                             <m:e>
                               <m:r>
-                                <a:rPr lang="es-ES" b="0" i="1" smtClean="0">
+                                <a:rPr lang="es-ES" i="1">
                                   <a:solidFill>
                                     <a:srgbClr val="FF0000"/>
                                   </a:solidFill>
@@ -11759,7 +11843,7 @@
             </p:txBody>
           </p:sp>
         </mc:Choice>
-        <mc:Fallback xmlns="">
+        <mc:Fallback>
           <p:sp>
             <p:nvSpPr>
               <p:cNvPr id="13" name="Rectángulo 12">
@@ -11776,7 +11860,7 @@
             </p:nvSpPr>
             <p:spPr>
               <a:xfrm>
-                <a:off x="248927" y="3434131"/>
+                <a:off x="1772927" y="3434131"/>
                 <a:ext cx="4813690" cy="1057918"/>
               </a:xfrm>
               <a:prstGeom prst="rect">
@@ -11785,7 +11869,7 @@
               <a:blipFill>
                 <a:blip r:embed="rId5"/>
                 <a:stretch>
-                  <a:fillRect b="-1176"/>
+                  <a:fillRect b="-2381"/>
                 </a:stretch>
               </a:blipFill>
             </p:spPr>
@@ -11794,7 +11878,7 @@
               <a:lstStyle/>
               <a:p>
                 <a:r>
-                  <a:rPr lang="es-PY">
+                  <a:rPr lang="es-ES_tradnl">
                     <a:noFill/>
                   </a:rPr>
                   <a:t> </a:t>
@@ -11804,8 +11888,8 @@
           </p:sp>
         </mc:Fallback>
       </mc:AlternateContent>
-      <mc:AlternateContent xmlns:mc="http://schemas.openxmlformats.org/markup-compatibility/2006" xmlns:a14="http://schemas.microsoft.com/office/drawing/2010/main">
-        <mc:Choice Requires="a14">
+      <mc:AlternateContent xmlns:mc="http://schemas.openxmlformats.org/markup-compatibility/2006">
+        <mc:Choice xmlns:a14="http://schemas.microsoft.com/office/drawing/2010/main" Requires="a14">
           <p:sp>
             <p:nvSpPr>
               <p:cNvPr id="6" name="Rectángulo 5">
@@ -11820,7 +11904,7 @@
             </p:nvSpPr>
             <p:spPr>
               <a:xfrm>
-                <a:off x="6188887" y="571979"/>
+                <a:off x="7712888" y="571979"/>
                 <a:ext cx="1455207" cy="1069908"/>
               </a:xfrm>
               <a:prstGeom prst="rect">
@@ -11974,7 +12058,7 @@
             </p:txBody>
           </p:sp>
         </mc:Choice>
-        <mc:Fallback xmlns="">
+        <mc:Fallback>
           <p:sp>
             <p:nvSpPr>
               <p:cNvPr id="6" name="Rectángulo 5">
@@ -11991,7 +12075,7 @@
             </p:nvSpPr>
             <p:spPr>
               <a:xfrm>
-                <a:off x="6188887" y="571979"/>
+                <a:off x="7712888" y="571979"/>
                 <a:ext cx="1455207" cy="1069908"/>
               </a:xfrm>
               <a:prstGeom prst="rect">
@@ -12000,7 +12084,7 @@
               <a:blipFill>
                 <a:blip r:embed="rId6"/>
                 <a:stretch>
-                  <a:fillRect l="-5172" b="-1176"/>
+                  <a:fillRect l="-6087" b="-1176"/>
                 </a:stretch>
               </a:blipFill>
             </p:spPr>
@@ -12009,7 +12093,7 @@
               <a:lstStyle/>
               <a:p>
                 <a:r>
-                  <a:rPr lang="es-PY">
+                  <a:rPr lang="es-ES_tradnl">
                     <a:noFill/>
                   </a:rPr>
                   <a:t> </a:t>
@@ -12019,8 +12103,8 @@
           </p:sp>
         </mc:Fallback>
       </mc:AlternateContent>
-      <mc:AlternateContent xmlns:mc="http://schemas.openxmlformats.org/markup-compatibility/2006" xmlns:a14="http://schemas.microsoft.com/office/drawing/2010/main">
-        <mc:Choice Requires="a14">
+      <mc:AlternateContent xmlns:mc="http://schemas.openxmlformats.org/markup-compatibility/2006">
+        <mc:Choice xmlns:a14="http://schemas.microsoft.com/office/drawing/2010/main" Requires="a14">
           <p:sp>
             <p:nvSpPr>
               <p:cNvPr id="7" name="Rectángulo 6">
@@ -12035,7 +12119,7 @@
             </p:nvSpPr>
             <p:spPr>
               <a:xfrm>
-                <a:off x="7561113" y="874088"/>
+                <a:off x="9085114" y="874089"/>
                 <a:ext cx="1527527" cy="646331"/>
               </a:xfrm>
               <a:prstGeom prst="rect">
@@ -12054,7 +12138,7 @@
                       <m:rPr>
                         <m:sty m:val="p"/>
                       </m:rPr>
-                      <a:rPr lang="es-ES" dirty="0" smtClean="0">
+                      <a:rPr lang="es-ES" dirty="0">
                         <a:solidFill>
                           <a:srgbClr val="FF0000"/>
                         </a:solidFill>
@@ -12122,7 +12206,7 @@
                       </m:e>
                       <m:sup>
                         <m:r>
-                          <a:rPr lang="es-ES" b="0" i="1" smtClean="0">
+                          <a:rPr lang="es-ES" i="1">
                             <a:solidFill>
                               <a:srgbClr val="FF0000"/>
                             </a:solidFill>
@@ -12140,7 +12224,7 @@
             </p:txBody>
           </p:sp>
         </mc:Choice>
-        <mc:Fallback xmlns="">
+        <mc:Fallback>
           <p:sp>
             <p:nvSpPr>
               <p:cNvPr id="7" name="Rectángulo 6">
@@ -12157,7 +12241,7 @@
             </p:nvSpPr>
             <p:spPr>
               <a:xfrm>
-                <a:off x="7561113" y="874088"/>
+                <a:off x="9085114" y="874089"/>
                 <a:ext cx="1527527" cy="646331"/>
               </a:xfrm>
               <a:prstGeom prst="rect">
@@ -12166,7 +12250,7 @@
               <a:blipFill>
                 <a:blip r:embed="rId7"/>
                 <a:stretch>
-                  <a:fillRect l="-2459" t="-1923" b="-13462"/>
+                  <a:fillRect l="-3306" t="-1923" b="-15385"/>
                 </a:stretch>
               </a:blipFill>
             </p:spPr>
@@ -12175,7 +12259,7 @@
               <a:lstStyle/>
               <a:p>
                 <a:r>
-                  <a:rPr lang="es-PY">
+                  <a:rPr lang="es-ES_tradnl">
                     <a:noFill/>
                   </a:rPr>
                   <a:t> </a:t>
@@ -12185,8 +12269,8 @@
           </p:sp>
         </mc:Fallback>
       </mc:AlternateContent>
-      <mc:AlternateContent xmlns:mc="http://schemas.openxmlformats.org/markup-compatibility/2006" xmlns:a14="http://schemas.microsoft.com/office/drawing/2010/main">
-        <mc:Choice Requires="a14">
+      <mc:AlternateContent xmlns:mc="http://schemas.openxmlformats.org/markup-compatibility/2006">
+        <mc:Choice xmlns:a14="http://schemas.microsoft.com/office/drawing/2010/main" Requires="a14">
           <p:sp>
             <p:nvSpPr>
               <p:cNvPr id="8" name="Rectángulo 7">
@@ -12201,7 +12285,7 @@
             </p:nvSpPr>
             <p:spPr>
               <a:xfrm>
-                <a:off x="2655772" y="5179393"/>
+                <a:off x="4179772" y="5179393"/>
                 <a:ext cx="2483500" cy="1057918"/>
               </a:xfrm>
               <a:prstGeom prst="rect">
@@ -12226,7 +12310,7 @@
                           <m:begChr m:val="["/>
                           <m:endChr m:val="]"/>
                           <m:ctrlPr>
-                            <a:rPr lang="es-ES" i="1" smtClean="0">
+                            <a:rPr lang="es-ES" i="1">
                               <a:latin typeface="Cambria Math" panose="02040503050406030204" pitchFamily="18" charset="0"/>
                             </a:rPr>
                           </m:ctrlPr>
@@ -12501,7 +12585,7 @@
                                 </m:mc>
                               </m:mcs>
                               <m:ctrlPr>
-                                <a:rPr lang="es-ES" i="1" smtClean="0">
+                                <a:rPr lang="es-ES" i="1">
                                   <a:solidFill>
                                     <a:srgbClr val="FF0000"/>
                                   </a:solidFill>
@@ -12524,7 +12608,7 @@
                                   <m:t>+</m:t>
                                 </m:r>
                                 <m:r>
-                                  <a:rPr lang="es-ES" b="0" i="1" smtClean="0">
+                                  <a:rPr lang="es-ES" i="1">
                                     <a:solidFill>
                                       <a:srgbClr val="FF0000"/>
                                     </a:solidFill>
@@ -12546,7 +12630,7 @@
                                   <m:t>+</m:t>
                                 </m:r>
                                 <m:r>
-                                  <a:rPr lang="es-ES" b="0" i="1" smtClean="0">
+                                  <a:rPr lang="es-ES" i="1">
                                     <a:solidFill>
                                       <a:srgbClr val="FF0000"/>
                                     </a:solidFill>
@@ -12568,7 +12652,7 @@
                                   <m:t>−</m:t>
                                 </m:r>
                                 <m:r>
-                                  <a:rPr lang="es-ES" b="0" i="1" smtClean="0">
+                                  <a:rPr lang="es-ES" i="1">
                                     <a:solidFill>
                                       <a:srgbClr val="FF0000"/>
                                     </a:solidFill>
@@ -12699,7 +12783,7 @@
             </p:txBody>
           </p:sp>
         </mc:Choice>
-        <mc:Fallback xmlns="">
+        <mc:Fallback>
           <p:sp>
             <p:nvSpPr>
               <p:cNvPr id="8" name="Rectángulo 7">
@@ -12716,7 +12800,7 @@
             </p:nvSpPr>
             <p:spPr>
               <a:xfrm>
-                <a:off x="2655772" y="5179393"/>
+                <a:off x="4179772" y="5179393"/>
                 <a:ext cx="2483500" cy="1057918"/>
               </a:xfrm>
               <a:prstGeom prst="rect">
@@ -12725,7 +12809,7 @@
               <a:blipFill>
                 <a:blip r:embed="rId8"/>
                 <a:stretch>
-                  <a:fillRect b="-2410"/>
+                  <a:fillRect b="-2381"/>
                 </a:stretch>
               </a:blipFill>
             </p:spPr>
@@ -12734,7 +12818,7 @@
               <a:lstStyle/>
               <a:p>
                 <a:r>
-                  <a:rPr lang="es-PY">
+                  <a:rPr lang="es-ES_tradnl">
                     <a:noFill/>
                   </a:rPr>
                   <a:t> </a:t>
@@ -12744,8 +12828,8 @@
           </p:sp>
         </mc:Fallback>
       </mc:AlternateContent>
-      <mc:AlternateContent xmlns:mc="http://schemas.openxmlformats.org/markup-compatibility/2006" xmlns:a14="http://schemas.microsoft.com/office/drawing/2010/main">
-        <mc:Choice Requires="a14">
+      <mc:AlternateContent xmlns:mc="http://schemas.openxmlformats.org/markup-compatibility/2006">
+        <mc:Choice xmlns:a14="http://schemas.microsoft.com/office/drawing/2010/main" Requires="a14">
           <p:sp>
             <p:nvSpPr>
               <p:cNvPr id="10" name="Rectángulo 9">
@@ -12760,7 +12844,7 @@
             </p:nvSpPr>
             <p:spPr>
               <a:xfrm>
-                <a:off x="4266674" y="2115793"/>
+                <a:off x="5790675" y="2115793"/>
                 <a:ext cx="2482859" cy="824906"/>
               </a:xfrm>
               <a:prstGeom prst="rect">
@@ -12779,7 +12863,7 @@
                       <m:rPr>
                         <m:sty m:val="p"/>
                       </m:rPr>
-                      <a:rPr lang="es-ES" dirty="0" smtClean="0">
+                      <a:rPr lang="es-ES" dirty="0">
                         <a:solidFill>
                           <a:srgbClr val="FF0000"/>
                         </a:solidFill>
@@ -12858,7 +12942,7 @@
                                 <m:rPr>
                                   <m:brk m:alnAt="7"/>
                                 </m:rPr>
-                                <a:rPr lang="es-ES" b="0" i="1" smtClean="0">
+                                <a:rPr lang="es-ES" i="1">
                                   <a:solidFill>
                                     <a:srgbClr val="FF0000"/>
                                   </a:solidFill>
@@ -12871,7 +12955,7 @@
                           <m:mr>
                             <m:e>
                               <m:r>
-                                <a:rPr lang="es-ES" b="0" i="1" smtClean="0">
+                                <a:rPr lang="es-ES" i="1">
                                   <a:solidFill>
                                     <a:srgbClr val="FF0000"/>
                                   </a:solidFill>
@@ -12884,7 +12968,7 @@
                           <m:mr>
                             <m:e>
                               <m:r>
-                                <a:rPr lang="es-ES" b="0" i="1" smtClean="0">
+                                <a:rPr lang="es-ES" i="1">
                                   <a:solidFill>
                                     <a:srgbClr val="FF0000"/>
                                   </a:solidFill>
@@ -12898,7 +12982,7 @@
                       </m:e>
                     </m:d>
                     <m:r>
-                      <a:rPr lang="es-ES" b="0" i="0" smtClean="0">
+                      <a:rPr lang="es-ES">
                         <a:solidFill>
                           <a:srgbClr val="FF0000"/>
                         </a:solidFill>
@@ -13017,7 +13101,7 @@
             </p:txBody>
           </p:sp>
         </mc:Choice>
-        <mc:Fallback xmlns="">
+        <mc:Fallback>
           <p:sp>
             <p:nvSpPr>
               <p:cNvPr id="10" name="Rectángulo 9">
@@ -13034,7 +13118,7 @@
             </p:nvSpPr>
             <p:spPr>
               <a:xfrm>
-                <a:off x="4266674" y="2115793"/>
+                <a:off x="5790675" y="2115793"/>
                 <a:ext cx="2482859" cy="824906"/>
               </a:xfrm>
               <a:prstGeom prst="rect">
@@ -13043,7 +13127,7 @@
               <a:blipFill>
                 <a:blip r:embed="rId9"/>
                 <a:stretch>
-                  <a:fillRect b="-1515"/>
+                  <a:fillRect b="-3030"/>
                 </a:stretch>
               </a:blipFill>
             </p:spPr>
@@ -13052,7 +13136,7 @@
               <a:lstStyle/>
               <a:p>
                 <a:r>
-                  <a:rPr lang="es-PY">
+                  <a:rPr lang="es-ES_tradnl">
                     <a:noFill/>
                   </a:rPr>
                   <a:t> </a:t>
@@ -13090,7 +13174,7 @@
         </p:blipFill>
         <p:spPr>
           <a:xfrm>
-            <a:off x="5191682" y="3434130"/>
+            <a:off x="6715682" y="3434131"/>
             <a:ext cx="3747308" cy="2803181"/>
           </a:xfrm>
           <a:prstGeom prst="rect">
@@ -13111,7 +13195,7 @@
 </p:sld>
 </file>
 
-<file path=ppt/slides/slide6.xml><?xml version="1.0" encoding="utf-8"?>
+<file path=ppt/slides/slide7.xml><?xml version="1.0" encoding="utf-8"?>
 <p:sld xmlns:a="http://schemas.openxmlformats.org/drawingml/2006/main" xmlns:r="http://schemas.openxmlformats.org/officeDocument/2006/relationships" xmlns:p="http://schemas.openxmlformats.org/presentationml/2006/main">
   <p:cSld>
     <p:spTree>
@@ -13128,8 +13212,8 @@
           <a:chExt cx="0" cy="0"/>
         </a:xfrm>
       </p:grpSpPr>
-      <mc:AlternateContent xmlns:mc="http://schemas.openxmlformats.org/markup-compatibility/2006" xmlns:a14="http://schemas.microsoft.com/office/drawing/2010/main">
-        <mc:Choice Requires="a14">
+      <mc:AlternateContent xmlns:mc="http://schemas.openxmlformats.org/markup-compatibility/2006">
+        <mc:Choice xmlns:a14="http://schemas.microsoft.com/office/drawing/2010/main" Requires="a14">
           <p:sp>
             <p:nvSpPr>
               <p:cNvPr id="11" name="1 Título">
@@ -13146,7 +13230,7 @@
             </p:nvSpPr>
             <p:spPr>
               <a:xfrm>
-                <a:off x="142655" y="255786"/>
+                <a:off x="1666656" y="255786"/>
                 <a:ext cx="5365449" cy="618302"/>
               </a:xfrm>
               <a:prstGeom prst="rect">
@@ -13194,7 +13278,7 @@
                       <m:t>→</m:t>
                     </m:r>
                     <m:r>
-                      <a:rPr lang="es-ES" sz="3600" b="0" i="1" dirty="0" smtClean="0">
+                      <a:rPr lang="es-ES" sz="3600" i="1" dirty="0">
                         <a:latin typeface="Cambria Math" panose="02040503050406030204" pitchFamily="18" charset="0"/>
                         <a:ea typeface="Cambria Math" panose="02040503050406030204" pitchFamily="18" charset="0"/>
                       </a:rPr>
@@ -13230,7 +13314,7 @@
             </p:txBody>
           </p:sp>
         </mc:Choice>
-        <mc:Fallback xmlns="">
+        <mc:Fallback>
           <p:sp>
             <p:nvSpPr>
               <p:cNvPr id="11" name="1 Título">
@@ -13247,7 +13331,7 @@
             </p:nvSpPr>
             <p:spPr>
               <a:xfrm>
-                <a:off x="142655" y="255786"/>
+                <a:off x="1666656" y="255786"/>
                 <a:ext cx="5365449" cy="618302"/>
               </a:xfrm>
               <a:prstGeom prst="rect">
@@ -13256,7 +13340,7 @@
               <a:blipFill>
                 <a:blip r:embed="rId2"/>
                 <a:stretch>
-                  <a:fillRect l="-2830" t="-20000" b="-28000"/>
+                  <a:fillRect l="-3310" t="-22449" b="-30612"/>
                 </a:stretch>
               </a:blipFill>
             </p:spPr>
@@ -13265,7 +13349,7 @@
               <a:lstStyle/>
               <a:p>
                 <a:r>
-                  <a:rPr lang="es-PY">
+                  <a:rPr lang="es-ES_tradnl">
                     <a:noFill/>
                   </a:rPr>
                   <a:t> </a:t>
@@ -13275,8 +13359,8 @@
           </p:sp>
         </mc:Fallback>
       </mc:AlternateContent>
-      <mc:AlternateContent xmlns:mc="http://schemas.openxmlformats.org/markup-compatibility/2006" xmlns:a14="http://schemas.microsoft.com/office/drawing/2010/main">
-        <mc:Choice Requires="a14">
+      <mc:AlternateContent xmlns:mc="http://schemas.openxmlformats.org/markup-compatibility/2006">
+        <mc:Choice xmlns:a14="http://schemas.microsoft.com/office/drawing/2010/main" Requires="a14">
           <p:sp>
             <p:nvSpPr>
               <p:cNvPr id="14" name="CuadroTexto 13">
@@ -13291,7 +13375,7 @@
             </p:nvSpPr>
             <p:spPr>
               <a:xfrm>
-                <a:off x="611560" y="874088"/>
+                <a:off x="2135561" y="874088"/>
                 <a:ext cx="5039521" cy="1077218"/>
               </a:xfrm>
               <a:prstGeom prst="rect">
@@ -13325,7 +13409,7 @@
                       <m:t>𝐴</m:t>
                     </m:r>
                     <m:r>
-                      <a:rPr lang="es-ES" sz="3200" b="0" i="1" smtClean="0">
+                      <a:rPr lang="es-ES" sz="3200" i="1">
                         <a:solidFill>
                           <a:srgbClr val="FF0000"/>
                         </a:solidFill>
@@ -13334,7 +13418,7 @@
                       <m:t>𝑥</m:t>
                     </m:r>
                     <m:r>
-                      <a:rPr lang="es-ES" sz="3200" b="0" i="1" smtClean="0">
+                      <a:rPr lang="es-ES" sz="3200" i="1">
                         <a:solidFill>
                           <a:srgbClr val="FF0000"/>
                         </a:solidFill>
@@ -13395,7 +13479,7 @@
             </p:txBody>
           </p:sp>
         </mc:Choice>
-        <mc:Fallback xmlns="">
+        <mc:Fallback>
           <p:sp>
             <p:nvSpPr>
               <p:cNvPr id="14" name="CuadroTexto 13">
@@ -13412,7 +13496,7 @@
             </p:nvSpPr>
             <p:spPr>
               <a:xfrm>
-                <a:off x="611560" y="874088"/>
+                <a:off x="2135561" y="874088"/>
                 <a:ext cx="5039521" cy="1077218"/>
               </a:xfrm>
               <a:prstGeom prst="rect">
@@ -13421,7 +13505,7 @@
               <a:blipFill>
                 <a:blip r:embed="rId3"/>
                 <a:stretch>
-                  <a:fillRect l="-3023" t="-5814" r="-1259" b="-16279"/>
+                  <a:fillRect l="-3023" t="-5814" r="-1511" b="-17442"/>
                 </a:stretch>
               </a:blipFill>
             </p:spPr>
@@ -13430,7 +13514,7 @@
               <a:lstStyle/>
               <a:p>
                 <a:r>
-                  <a:rPr lang="es-PY">
+                  <a:rPr lang="es-ES_tradnl">
                     <a:noFill/>
                   </a:rPr>
                   <a:t> </a:t>
@@ -13440,8 +13524,8 @@
           </p:sp>
         </mc:Fallback>
       </mc:AlternateContent>
-      <mc:AlternateContent xmlns:mc="http://schemas.openxmlformats.org/markup-compatibility/2006" xmlns:a14="http://schemas.microsoft.com/office/drawing/2010/main">
-        <mc:Choice Requires="a14">
+      <mc:AlternateContent xmlns:mc="http://schemas.openxmlformats.org/markup-compatibility/2006">
+        <mc:Choice xmlns:a14="http://schemas.microsoft.com/office/drawing/2010/main" Requires="a14">
           <p:sp>
             <p:nvSpPr>
               <p:cNvPr id="16" name="Rectángulo 15">
@@ -13456,7 +13540,7 @@
             </p:nvSpPr>
             <p:spPr>
               <a:xfrm>
-                <a:off x="7020272" y="564937"/>
+                <a:off x="8544273" y="564937"/>
                 <a:ext cx="1712135" cy="1569660"/>
               </a:xfrm>
               <a:prstGeom prst="rect">
@@ -13472,7 +13556,7 @@
                 <a14:m>
                   <m:oMath xmlns:m="http://schemas.openxmlformats.org/officeDocument/2006/math">
                     <m:r>
-                      <a:rPr lang="es-ES" sz="3200" b="1" i="1" dirty="0" smtClean="0">
+                      <a:rPr lang="es-ES" sz="3200" b="1" i="1" dirty="0">
                         <a:latin typeface="Cambria Math" panose="02040503050406030204" pitchFamily="18" charset="0"/>
                       </a:rPr>
                       <m:t>𝒗</m:t>
@@ -13486,7 +13570,7 @@
                 <a14:m>
                   <m:oMath xmlns:m="http://schemas.openxmlformats.org/officeDocument/2006/math">
                     <m:r>
-                      <a:rPr lang="es-ES" sz="3200" b="1" i="1" dirty="0" smtClean="0">
+                      <a:rPr lang="es-ES" sz="3200" b="1" i="1" dirty="0">
                         <a:latin typeface="Cambria Math" panose="02040503050406030204" pitchFamily="18" charset="0"/>
                         <a:ea typeface="Cambria Math" panose="02040503050406030204" pitchFamily="18" charset="0"/>
                       </a:rPr>
@@ -13495,7 +13579,7 @@
                     <m:sSup>
                       <m:sSupPr>
                         <m:ctrlPr>
-                          <a:rPr lang="es-ES" sz="3200" b="1" i="1" dirty="0" smtClean="0">
+                          <a:rPr lang="es-ES" sz="3200" b="1" i="1" dirty="0">
                             <a:latin typeface="Cambria Math" panose="02040503050406030204" pitchFamily="18" charset="0"/>
                             <a:ea typeface="Cambria Math" panose="02040503050406030204" pitchFamily="18" charset="0"/>
                           </a:rPr>
@@ -13503,7 +13587,7 @@
                       </m:sSupPr>
                       <m:e>
                         <m:r>
-                          <a:rPr lang="es-ES" sz="3200" b="1" i="1" dirty="0" smtClean="0">
+                          <a:rPr lang="es-ES" sz="3200" b="1" i="1" dirty="0">
                             <a:latin typeface="Cambria Math" panose="02040503050406030204" pitchFamily="18" charset="0"/>
                             <a:ea typeface="Cambria Math" panose="02040503050406030204" pitchFamily="18" charset="0"/>
                           </a:rPr>
@@ -13512,7 +13596,7 @@
                       </m:e>
                       <m:sup>
                         <m:r>
-                          <a:rPr lang="es-ES" sz="3200" b="1" i="1" dirty="0" smtClean="0">
+                          <a:rPr lang="es-ES" sz="3200" b="1" i="1" dirty="0">
                             <a:latin typeface="Cambria Math" panose="02040503050406030204" pitchFamily="18" charset="0"/>
                             <a:ea typeface="Cambria Math" panose="02040503050406030204" pitchFamily="18" charset="0"/>
                           </a:rPr>
@@ -13566,7 +13650,7 @@
                       </m:e>
                       <m:sup>
                         <m:r>
-                          <a:rPr lang="es-ES" sz="3200" b="1" i="1" dirty="0" smtClean="0">
+                          <a:rPr lang="es-ES" sz="3200" b="1" i="1" dirty="0">
                             <a:latin typeface="Cambria Math" panose="02040503050406030204" pitchFamily="18" charset="0"/>
                             <a:ea typeface="Cambria Math" panose="02040503050406030204" pitchFamily="18" charset="0"/>
                           </a:rPr>
@@ -13612,7 +13696,7 @@
             </p:txBody>
           </p:sp>
         </mc:Choice>
-        <mc:Fallback xmlns="">
+        <mc:Fallback>
           <p:sp>
             <p:nvSpPr>
               <p:cNvPr id="16" name="Rectángulo 15">
@@ -13629,7 +13713,7 @@
             </p:nvSpPr>
             <p:spPr>
               <a:xfrm>
-                <a:off x="7020272" y="564937"/>
+                <a:off x="8544273" y="564937"/>
                 <a:ext cx="1712135" cy="1569660"/>
               </a:xfrm>
               <a:prstGeom prst="rect">
@@ -13638,7 +13722,7 @@
               <a:blipFill>
                 <a:blip r:embed="rId4"/>
                 <a:stretch>
-                  <a:fillRect l="-8824" t="-5600" r="-7353" b="-10400"/>
+                  <a:fillRect l="-8824" t="-6452" r="-8088" b="-11290"/>
                 </a:stretch>
               </a:blipFill>
             </p:spPr>
@@ -13647,7 +13731,7 @@
               <a:lstStyle/>
               <a:p>
                 <a:r>
-                  <a:rPr lang="es-PY">
+                  <a:rPr lang="es-ES_tradnl">
                     <a:noFill/>
                   </a:rPr>
                   <a:t> </a:t>
@@ -13657,8 +13741,8 @@
           </p:sp>
         </mc:Fallback>
       </mc:AlternateContent>
-      <mc:AlternateContent xmlns:mc="http://schemas.openxmlformats.org/markup-compatibility/2006" xmlns:a14="http://schemas.microsoft.com/office/drawing/2010/main">
-        <mc:Choice Requires="a14">
+      <mc:AlternateContent xmlns:mc="http://schemas.openxmlformats.org/markup-compatibility/2006">
+        <mc:Choice xmlns:a14="http://schemas.microsoft.com/office/drawing/2010/main" Requires="a14">
           <p:sp>
             <p:nvSpPr>
               <p:cNvPr id="17" name="CuadroTexto 16">
@@ -13673,7 +13757,7 @@
             </p:nvSpPr>
             <p:spPr>
               <a:xfrm>
-                <a:off x="755576" y="2537014"/>
+                <a:off x="2279576" y="2537015"/>
                 <a:ext cx="5593198" cy="1200329"/>
               </a:xfrm>
               <a:prstGeom prst="rect">
@@ -13694,37 +13778,37 @@
                 <a14:m>
                   <m:oMath xmlns:m="http://schemas.openxmlformats.org/officeDocument/2006/math">
                     <m:r>
-                      <a:rPr lang="es-ES" sz="2400" b="1" i="1" smtClean="0">
+                      <a:rPr lang="es-ES" sz="2400" b="1" i="1">
                         <a:latin typeface="Cambria Math" panose="02040503050406030204" pitchFamily="18" charset="0"/>
                       </a:rPr>
                       <m:t>𝑨𝒗</m:t>
                     </m:r>
                     <m:r>
-                      <a:rPr lang="es-ES" sz="2400" b="1" i="1" smtClean="0">
+                      <a:rPr lang="es-ES" sz="2400" b="1" i="1">
                         <a:latin typeface="Cambria Math" panose="02040503050406030204" pitchFamily="18" charset="0"/>
                       </a:rPr>
                       <m:t>=</m:t>
                     </m:r>
                     <m:r>
-                      <a:rPr lang="es-ES" sz="2400" b="1" i="1" smtClean="0">
+                      <a:rPr lang="es-ES" sz="2400" b="1" i="1">
                         <a:latin typeface="Cambria Math" panose="02040503050406030204" pitchFamily="18" charset="0"/>
                       </a:rPr>
                       <m:t>𝟎</m:t>
                     </m:r>
                     <m:r>
-                      <a:rPr lang="es-ES" sz="2400" b="1" i="1" smtClean="0">
+                      <a:rPr lang="es-ES" sz="2400" b="1" i="1">
                         <a:latin typeface="Cambria Math" panose="02040503050406030204" pitchFamily="18" charset="0"/>
                       </a:rPr>
                       <m:t> </m:t>
                     </m:r>
                     <m:r>
-                      <a:rPr lang="es-ES" sz="2400" b="1" i="1" smtClean="0">
+                      <a:rPr lang="es-ES" sz="2400" b="1" i="1">
                         <a:latin typeface="Cambria Math" panose="02040503050406030204" pitchFamily="18" charset="0"/>
                       </a:rPr>
                       <m:t>𝒂𝒏𝒅</m:t>
                     </m:r>
                     <m:r>
-                      <a:rPr lang="es-ES" sz="2400" b="1" i="1" smtClean="0">
+                      <a:rPr lang="es-ES" sz="2400" b="1" i="1">
                         <a:latin typeface="Cambria Math" panose="02040503050406030204" pitchFamily="18" charset="0"/>
                       </a:rPr>
                       <m:t> </m:t>
@@ -13736,7 +13820,7 @@
                       <m:t>𝑨</m:t>
                     </m:r>
                     <m:r>
-                      <a:rPr lang="es-ES" sz="2400" b="1" i="1" smtClean="0">
+                      <a:rPr lang="es-ES" sz="2400" b="1" i="1">
                         <a:latin typeface="Cambria Math" panose="02040503050406030204" pitchFamily="18" charset="0"/>
                       </a:rPr>
                       <m:t>𝒘</m:t>
@@ -13831,7 +13915,7 @@
                           <m:rPr>
                             <m:sty m:val="p"/>
                           </m:rPr>
-                          <a:rPr lang="es-ES" sz="2400" b="0" i="0" dirty="0" smtClean="0">
+                          <a:rPr lang="es-ES" sz="2400" dirty="0">
                             <a:latin typeface="Cambria Math" panose="02040503050406030204" pitchFamily="18" charset="0"/>
                           </a:rPr>
                           <m:t>c</m:t>
@@ -13855,7 +13939,7 @@
             </p:txBody>
           </p:sp>
         </mc:Choice>
-        <mc:Fallback xmlns="">
+        <mc:Fallback>
           <p:sp>
             <p:nvSpPr>
               <p:cNvPr id="17" name="CuadroTexto 16">
@@ -13872,7 +13956,7 @@
             </p:nvSpPr>
             <p:spPr>
               <a:xfrm>
-                <a:off x="755576" y="2537014"/>
+                <a:off x="2279576" y="2537015"/>
                 <a:ext cx="5593198" cy="1200329"/>
               </a:xfrm>
               <a:prstGeom prst="rect">
@@ -13881,7 +13965,7 @@
               <a:blipFill>
                 <a:blip r:embed="rId5"/>
                 <a:stretch>
-                  <a:fillRect l="-1584" t="-4211" r="-679" b="-11579"/>
+                  <a:fillRect l="-1814" t="-4167" r="-907" b="-11458"/>
                 </a:stretch>
               </a:blipFill>
             </p:spPr>
@@ -13890,7 +13974,7 @@
               <a:lstStyle/>
               <a:p>
                 <a:r>
-                  <a:rPr lang="es-PY">
+                  <a:rPr lang="es-ES_tradnl">
                     <a:noFill/>
                   </a:rPr>
                   <a:t> </a:t>
@@ -13922,7 +14006,7 @@
         </p:blipFill>
         <p:spPr>
           <a:xfrm>
-            <a:off x="6261338" y="2362478"/>
+            <a:off x="7785338" y="2362478"/>
             <a:ext cx="774700" cy="774700"/>
           </a:xfrm>
           <a:prstGeom prst="rect">
@@ -13952,7 +14036,7 @@
         </p:blipFill>
         <p:spPr>
           <a:xfrm>
-            <a:off x="6305056" y="3137179"/>
+            <a:off x="7829056" y="3137179"/>
             <a:ext cx="774700" cy="774700"/>
           </a:xfrm>
           <a:prstGeom prst="rect">
@@ -13973,7 +14057,7 @@
 </p:sld>
 </file>
 
-<file path=ppt/slides/slide7.xml><?xml version="1.0" encoding="utf-8"?>
+<file path=ppt/slides/slide8.xml><?xml version="1.0" encoding="utf-8"?>
 <p:sld xmlns:a="http://schemas.openxmlformats.org/drawingml/2006/main" xmlns:r="http://schemas.openxmlformats.org/officeDocument/2006/relationships" xmlns:p="http://schemas.openxmlformats.org/presentationml/2006/main">
   <p:cSld>
     <p:spTree>
@@ -14035,7 +14119,7 @@
         </p:nvSpPr>
         <p:spPr>
           <a:xfrm>
-            <a:off x="2107722" y="2661974"/>
+            <a:off x="3631723" y="2661975"/>
             <a:ext cx="3223167" cy="415963"/>
           </a:xfrm>
           <a:prstGeom prst="rect">
@@ -14266,7 +14350,7 @@
         </p:nvSpPr>
         <p:spPr>
           <a:xfrm>
-            <a:off x="4772018" y="464859"/>
+            <a:off x="6296019" y="464860"/>
             <a:ext cx="3649669" cy="1849715"/>
           </a:xfrm>
           <a:prstGeom prst="rect">
@@ -14538,7 +14622,7 @@
         </p:nvSpPr>
         <p:spPr>
           <a:xfrm>
-            <a:off x="262473" y="2617550"/>
+            <a:off x="1786474" y="2617550"/>
             <a:ext cx="817853" cy="369332"/>
           </a:xfrm>
           <a:prstGeom prst="rect">
@@ -14590,7 +14674,7 @@
         </p:blipFill>
         <p:spPr>
           <a:xfrm>
-            <a:off x="322263" y="404815"/>
+            <a:off x="1846263" y="404815"/>
             <a:ext cx="800100" cy="279400"/>
           </a:xfrm>
           <a:prstGeom prst="rect">
@@ -14612,7 +14696,7 @@
         </p:nvSpPr>
         <p:spPr>
           <a:xfrm>
-            <a:off x="200018" y="734400"/>
+            <a:off x="1724018" y="734401"/>
             <a:ext cx="4572000" cy="646331"/>
           </a:xfrm>
           <a:prstGeom prst="rect">
@@ -14646,7 +14730,7 @@
         </p:nvGrpSpPr>
         <p:grpSpPr>
           <a:xfrm>
-            <a:off x="262473" y="3003076"/>
+            <a:off x="1786474" y="3003077"/>
             <a:ext cx="7405871" cy="1096633"/>
             <a:chOff x="262473" y="2770828"/>
             <a:chExt cx="7405871" cy="1096633"/>

</xml_diff>